<commit_message>
Apply the supplied palette to all 16 figures and website; add verified supplier tickers and BD ownership mapping
</commit_message>
<xml_diff>
--- a/editable/AI_antibody_data_density_editable.pptx
+++ b/editable/AI_antibody_data_density_editable.pptx
@@ -2,14 +2,14 @@
 <file path=ppt/presentation.xml><?xml version="1.0" encoding="utf-8"?>
 <p:presentation xmlns:p="http://schemas.openxmlformats.org/presentationml/2006/main">
   <p:sldMasterIdLst>
-    <p:sldMasterId xmlns:r="http://schemas.openxmlformats.org/officeDocument/2006/relationships" id="2147483648" r:id="Rbbeca56a11cc49a7"/>
+    <p:sldMasterId xmlns:r="http://schemas.openxmlformats.org/officeDocument/2006/relationships" id="2147483648" r:id="Ra4fa471de4bb48ec"/>
   </p:sldMasterIdLst>
   <p:notesMasterIdLst>
-    <p:notesMasterId xmlns:r="http://schemas.openxmlformats.org/officeDocument/2006/relationships" r:id="R04eb2d394428452a"/>
+    <p:notesMasterId xmlns:r="http://schemas.openxmlformats.org/officeDocument/2006/relationships" r:id="R12a7cf4e63d44ffd"/>
   </p:notesMasterIdLst>
   <p:sldIdLst>
-    <p:sldId xmlns:r="http://schemas.openxmlformats.org/officeDocument/2006/relationships" id="256" r:id="R62617eea7c874719"/>
-    <p:sldId xmlns:r="http://schemas.openxmlformats.org/officeDocument/2006/relationships" id="257" r:id="Rb3e89e08127f4940"/>
+    <p:sldId xmlns:r="http://schemas.openxmlformats.org/officeDocument/2006/relationships" id="256" r:id="R6ca7062c13ba44a9"/>
+    <p:sldId xmlns:r="http://schemas.openxmlformats.org/officeDocument/2006/relationships" id="257" r:id="R468fcb8bbe77477f"/>
   </p:sldIdLst>
   <p:sldSz cx="18288000" cy="10287000"/>
   <p:notesSz cx="6858000" cy="9144000"/>
@@ -801,6 +801,21 @@
               <a:t/>
             </a:r>
           </a:p>
+          <a:p xmlns:a="http://schemas.openxmlformats.org/drawingml/2006/main">
+            <a:r>
+              <a:t/>
+            </a:r>
+          </a:p>
+          <a:p xmlns:a="http://schemas.openxmlformats.org/drawingml/2006/main">
+            <a:r>
+              <a:t>Palette updated to the user's eight RGB colors on 13 October 2026. Original company marks retain their brand colors.</a:t>
+            </a:r>
+          </a:p>
+          <a:p xmlns:a="http://schemas.openxmlformats.org/drawingml/2006/main">
+            <a:r>
+              <a:t/>
+            </a:r>
+          </a:p>
         </p:txBody>
       </p:sp>
       <p:sp>
@@ -1226,6 +1241,21 @@
               <a:t/>
             </a:r>
           </a:p>
+          <a:p xmlns:a="http://schemas.openxmlformats.org/drawingml/2006/main">
+            <a:r>
+              <a:t/>
+            </a:r>
+          </a:p>
+          <a:p xmlns:a="http://schemas.openxmlformats.org/drawingml/2006/main">
+            <a:r>
+              <a:t>Palette updated to the user's eight RGB colors on 13 October 2026. Original company marks retain their brand colors.</a:t>
+            </a:r>
+          </a:p>
+          <a:p xmlns:a="http://schemas.openxmlformats.org/drawingml/2006/main">
+            <a:r>
+              <a:t/>
+            </a:r>
+          </a:p>
         </p:txBody>
       </p:sp>
       <p:sp>
@@ -1270,7 +1300,7 @@
           <p:cNvPr id="3" name="Title">
             <a:extLst xmlns:a="http://schemas.openxmlformats.org/drawingml/2006/main">
               <a:ext uri="{FF2B5EF4-FFF2-40B4-BE49-F238E27FC236}">
-                <a16:creationId xmlns:a16="http://schemas.microsoft.com/office/drawing/2014/main" id="{47C51E82-2503-4FC6-B436-3569EB53C5A3}"/>
+                <a16:creationId xmlns:a16="http://schemas.microsoft.com/office/drawing/2014/main" id="{DEBF7B23-15D3-42A3-8188-3C6C6CC2EBC7}"/>
               </a:ext>
             </a:extLst>
           </p:cNvPr>
@@ -1427,7 +1457,7 @@
           <p:cNvPr id="2" name="Subtitle">
             <a:extLst xmlns:a="http://schemas.openxmlformats.org/drawingml/2006/main">
               <a:ext uri="{FF2B5EF4-FFF2-40B4-BE49-F238E27FC236}">
-                <a16:creationId xmlns:a16="http://schemas.microsoft.com/office/drawing/2014/main" id="{F7FD230A-E806-43B4-B8EC-B929668D8353}"/>
+                <a16:creationId xmlns:a16="http://schemas.microsoft.com/office/drawing/2014/main" id="{B7B1B44E-4500-4743-99C0-33B4A5A12FF2}"/>
               </a:ext>
             </a:extLst>
           </p:cNvPr>
@@ -1601,7 +1631,7 @@
           <p:cNvPr id="2" name="Section title">
             <a:extLst xmlns:a="http://schemas.openxmlformats.org/drawingml/2006/main">
               <a:ext uri="{FF2B5EF4-FFF2-40B4-BE49-F238E27FC236}">
-                <a16:creationId xmlns:a16="http://schemas.microsoft.com/office/drawing/2014/main" id="{04595FDC-458C-466D-B1D5-7F0DD5FC8CB6}"/>
+                <a16:creationId xmlns:a16="http://schemas.microsoft.com/office/drawing/2014/main" id="{08620BBE-8FAF-4E71-83EC-3EBCF730A9B1}"/>
               </a:ext>
             </a:extLst>
           </p:cNvPr>
@@ -1775,7 +1805,7 @@
           <p:cNvPr id="3" name="Title">
             <a:extLst xmlns:a="http://schemas.openxmlformats.org/drawingml/2006/main">
               <a:ext uri="{FF2B5EF4-FFF2-40B4-BE49-F238E27FC236}">
-                <a16:creationId xmlns:a16="http://schemas.microsoft.com/office/drawing/2014/main" id="{15CB5136-7098-44AB-B011-9343809BFA97}"/>
+                <a16:creationId xmlns:a16="http://schemas.microsoft.com/office/drawing/2014/main" id="{E6AB2AB0-0361-44B4-B933-B6926B193DD0}"/>
               </a:ext>
             </a:extLst>
           </p:cNvPr>
@@ -1932,7 +1962,7 @@
           <p:cNvPr id="2" name="Body">
             <a:extLst xmlns:a="http://schemas.openxmlformats.org/drawingml/2006/main">
               <a:ext uri="{FF2B5EF4-FFF2-40B4-BE49-F238E27FC236}">
-                <a16:creationId xmlns:a16="http://schemas.microsoft.com/office/drawing/2014/main" id="{5A2C0728-1897-4917-81E2-F2D3E2A36004}"/>
+                <a16:creationId xmlns:a16="http://schemas.microsoft.com/office/drawing/2014/main" id="{1DA8BD50-3A46-41E2-A7EB-F2A7EA2EB3E4}"/>
               </a:ext>
             </a:extLst>
           </p:cNvPr>
@@ -2106,7 +2136,7 @@
           <p:cNvPr id="4" name="Title">
             <a:extLst xmlns:a="http://schemas.openxmlformats.org/drawingml/2006/main">
               <a:ext uri="{FF2B5EF4-FFF2-40B4-BE49-F238E27FC236}">
-                <a16:creationId xmlns:a16="http://schemas.microsoft.com/office/drawing/2014/main" id="{F51D0760-073D-4348-AE4C-72C06E98D618}"/>
+                <a16:creationId xmlns:a16="http://schemas.microsoft.com/office/drawing/2014/main" id="{178E687E-6C22-4A03-B8A1-C353CC6CD7CA}"/>
               </a:ext>
             </a:extLst>
           </p:cNvPr>
@@ -2263,7 +2293,7 @@
           <p:cNvPr id="2" name="Left column">
             <a:extLst xmlns:a="http://schemas.openxmlformats.org/drawingml/2006/main">
               <a:ext uri="{FF2B5EF4-FFF2-40B4-BE49-F238E27FC236}">
-                <a16:creationId xmlns:a16="http://schemas.microsoft.com/office/drawing/2014/main" id="{8617EFC3-A561-4BF8-A168-1777586999B8}"/>
+                <a16:creationId xmlns:a16="http://schemas.microsoft.com/office/drawing/2014/main" id="{F825E284-2A8B-4AE6-8B79-731A7122BB92}"/>
               </a:ext>
             </a:extLst>
           </p:cNvPr>
@@ -2420,7 +2450,7 @@
           <p:cNvPr id="3" name="Right column">
             <a:extLst xmlns:a="http://schemas.openxmlformats.org/drawingml/2006/main">
               <a:ext uri="{FF2B5EF4-FFF2-40B4-BE49-F238E27FC236}">
-                <a16:creationId xmlns:a16="http://schemas.microsoft.com/office/drawing/2014/main" id="{A8C6359C-3ACB-42A8-9BF1-E057E032F566}"/>
+                <a16:creationId xmlns:a16="http://schemas.microsoft.com/office/drawing/2014/main" id="{FA539200-0219-4E05-95FE-93351599A46C}"/>
               </a:ext>
             </a:extLst>
           </p:cNvPr>
@@ -2594,7 +2624,7 @@
           <p:cNvPr id="3" name="Title">
             <a:extLst xmlns:a="http://schemas.openxmlformats.org/drawingml/2006/main">
               <a:ext uri="{FF2B5EF4-FFF2-40B4-BE49-F238E27FC236}">
-                <a16:creationId xmlns:a16="http://schemas.microsoft.com/office/drawing/2014/main" id="{3FC8A26F-B3E3-4159-B8C0-91A3596367C2}"/>
+                <a16:creationId xmlns:a16="http://schemas.microsoft.com/office/drawing/2014/main" id="{5CA690AA-0C4B-4BF0-8ADA-D26A55A52320}"/>
               </a:ext>
             </a:extLst>
           </p:cNvPr>
@@ -2751,7 +2781,7 @@
           <p:cNvPr id="2" name="Left column">
             <a:extLst xmlns:a="http://schemas.openxmlformats.org/drawingml/2006/main">
               <a:ext uri="{FF2B5EF4-FFF2-40B4-BE49-F238E27FC236}">
-                <a16:creationId xmlns:a16="http://schemas.microsoft.com/office/drawing/2014/main" id="{3110184A-9448-4777-A3A3-DD0636100ADE}"/>
+                <a16:creationId xmlns:a16="http://schemas.microsoft.com/office/drawing/2014/main" id="{6010A507-3ECC-4DF4-99EC-CE20EE62AFAD}"/>
               </a:ext>
             </a:extLst>
           </p:cNvPr>
@@ -2946,12 +2976,12 @@
   </p:cSld>
   <p:clrMap bg1="lt1" tx1="dk1" bg2="lt2" tx2="dk2" accent1="accent1" accent2="accent2" accent3="accent3" accent4="accent4" accent5="accent5" accent6="accent6" hlink="hlink" folHlink="folHlink"/>
   <p:sldLayoutIdLst>
-    <p:sldLayoutId xmlns:r="http://schemas.openxmlformats.org/officeDocument/2006/relationships" id="2147483649" r:id="R17d6942ce6684a0c"/>
-    <p:sldLayoutId xmlns:r="http://schemas.openxmlformats.org/officeDocument/2006/relationships" id="2147483650" r:id="R82a693a8a3fe4180"/>
-    <p:sldLayoutId xmlns:r="http://schemas.openxmlformats.org/officeDocument/2006/relationships" id="2147483651" r:id="Ra85f3d46e3e042de"/>
-    <p:sldLayoutId xmlns:r="http://schemas.openxmlformats.org/officeDocument/2006/relationships" id="2147483652" r:id="R6975674547104123"/>
-    <p:sldLayoutId xmlns:r="http://schemas.openxmlformats.org/officeDocument/2006/relationships" id="2147483653" r:id="R8ad6c6afbbd84827"/>
-    <p:sldLayoutId xmlns:r="http://schemas.openxmlformats.org/officeDocument/2006/relationships" id="2147483654" r:id="Rc5ebf7057a21431f"/>
+    <p:sldLayoutId xmlns:r="http://schemas.openxmlformats.org/officeDocument/2006/relationships" id="2147483649" r:id="R584c96e771984e30"/>
+    <p:sldLayoutId xmlns:r="http://schemas.openxmlformats.org/officeDocument/2006/relationships" id="2147483650" r:id="R5b0fc5110643404d"/>
+    <p:sldLayoutId xmlns:r="http://schemas.openxmlformats.org/officeDocument/2006/relationships" id="2147483651" r:id="Rd666a45efe7f4ee5"/>
+    <p:sldLayoutId xmlns:r="http://schemas.openxmlformats.org/officeDocument/2006/relationships" id="2147483652" r:id="Rd2947a9b08dd4706"/>
+    <p:sldLayoutId xmlns:r="http://schemas.openxmlformats.org/officeDocument/2006/relationships" id="2147483653" r:id="R4fdef0390066452f"/>
+    <p:sldLayoutId xmlns:r="http://schemas.openxmlformats.org/officeDocument/2006/relationships" id="2147483654" r:id="Rf402e7200efc404d"/>
   </p:sldLayoutIdLst>
   <p:txStyles>
     <p:titleStyle>
@@ -3502,7 +3532,7 @@
           <p:cNvPr id="36" name="">
             <a:extLst xmlns:a="http://schemas.openxmlformats.org/drawingml/2006/main">
               <a:ext uri="{FF2B5EF4-FFF2-40B4-BE49-F238E27FC236}">
-                <a16:creationId xmlns:a16="http://schemas.microsoft.com/office/drawing/2014/main" id="{818164C1-8A0B-4EF5-AF7A-3ECDE7B79584}"/>
+                <a16:creationId xmlns:a16="http://schemas.microsoft.com/office/drawing/2014/main" id="{311929EF-572B-4BAF-9011-FF361D21BFEB}"/>
               </a:ext>
             </a:extLst>
           </p:cNvPr>
@@ -3520,7 +3550,7 @@
             <a:avLst/>
           </a:prstGeom>
           <a:solidFill xmlns:a="http://schemas.openxmlformats.org/drawingml/2006/main">
-            <a:srgbClr val="007D80"/>
+            <a:srgbClr val="00355F"/>
           </a:solidFill>
           <a:ln xmlns:a="http://schemas.openxmlformats.org/drawingml/2006/main" w="9525">
             <a:noFill/>
@@ -3532,7 +3562,7 @@
           <p:cNvPr id="2" name="Fewer molecules. Deeper experimental data.">
             <a:extLst xmlns:a="http://schemas.openxmlformats.org/drawingml/2006/main">
               <a:ext uri="{FF2B5EF4-FFF2-40B4-BE49-F238E27FC236}">
-                <a16:creationId xmlns:a16="http://schemas.microsoft.com/office/drawing/2014/main" id="{7F459EDF-35D9-4E64-BA87-E49488B7AB55}"/>
+                <a16:creationId xmlns:a16="http://schemas.microsoft.com/office/drawing/2014/main" id="{7B11863C-3997-4DF2-9052-B08A4EB70ED5}"/>
               </a:ext>
             </a:extLst>
           </p:cNvPr>
@@ -3560,7 +3590,7 @@
             <a:defPPr algn="l">
               <a:defRPr sz="3450" b="1">
                 <a:solidFill>
-                  <a:srgbClr val="152C3A"/>
+                  <a:srgbClr val="00355F"/>
                 </a:solidFill>
                 <a:latin typeface="Arial"/>
                 <a:ea typeface="Arial"/>
@@ -3576,7 +3606,7 @@
               <a:buNone/>
               <a:defRPr sz="3450" b="1">
                 <a:solidFill>
-                  <a:srgbClr val="152C3A"/>
+                  <a:srgbClr val="00355F"/>
                 </a:solidFill>
                 <a:latin typeface="Arial"/>
                 <a:ea typeface="Arial"/>
@@ -3586,7 +3616,7 @@
             <a:r>
               <a:rPr sz="3450" b="1">
                 <a:solidFill>
-                  <a:srgbClr val="152C3A"/>
+                  <a:srgbClr val="00355F"/>
                 </a:solidFill>
                 <a:latin typeface="Arial"/>
                 <a:ea typeface="Arial"/>
@@ -3602,7 +3632,7 @@
           <p:cNvPr id="3" name="AI may reduce candidate counts while increasing characterization per molecule">
             <a:extLst xmlns:a="http://schemas.openxmlformats.org/drawingml/2006/main">
               <a:ext uri="{FF2B5EF4-FFF2-40B4-BE49-F238E27FC236}">
-                <a16:creationId xmlns:a16="http://schemas.microsoft.com/office/drawing/2014/main" id="{73542742-CC3F-4800-A63D-FCE4C086EB0E}"/>
+                <a16:creationId xmlns:a16="http://schemas.microsoft.com/office/drawing/2014/main" id="{5B3FD066-E003-4C9A-91A9-600108D38F5D}"/>
               </a:ext>
             </a:extLst>
           </p:cNvPr>
@@ -3630,7 +3660,7 @@
             <a:defPPr algn="l">
               <a:defRPr sz="2025" b="0">
                 <a:solidFill>
-                  <a:srgbClr val="647887"/>
+                  <a:srgbClr val="00355F"/>
                 </a:solidFill>
                 <a:latin typeface="Arial"/>
                 <a:ea typeface="Arial"/>
@@ -3646,7 +3676,7 @@
               <a:buNone/>
               <a:defRPr sz="2025" b="0">
                 <a:solidFill>
-                  <a:srgbClr val="647887"/>
+                  <a:srgbClr val="00355F"/>
                 </a:solidFill>
                 <a:latin typeface="Arial"/>
                 <a:ea typeface="Arial"/>
@@ -3656,7 +3686,7 @@
             <a:r>
               <a:rPr sz="2025" b="0">
                 <a:solidFill>
-                  <a:srgbClr val="647887"/>
+                  <a:srgbClr val="00355F"/>
                 </a:solidFill>
                 <a:latin typeface="Arial"/>
                 <a:ea typeface="Arial"/>
@@ -3672,7 +3702,7 @@
           <p:cNvPr id="4" name="From molecule throughput to data density: a potential driver of life science tools demand">
             <a:extLst xmlns:a="http://schemas.openxmlformats.org/drawingml/2006/main">
               <a:ext uri="{FF2B5EF4-FFF2-40B4-BE49-F238E27FC236}">
-                <a16:creationId xmlns:a16="http://schemas.microsoft.com/office/drawing/2014/main" id="{BF2993B0-02AA-41D7-B0B1-7A954C164AC4}"/>
+                <a16:creationId xmlns:a16="http://schemas.microsoft.com/office/drawing/2014/main" id="{EB8883F6-3027-41CE-B7D5-4FD7A08BDB39}"/>
               </a:ext>
             </a:extLst>
           </p:cNvPr>
@@ -3700,7 +3730,7 @@
             <a:defPPr algn="l">
               <a:defRPr sz="1575" b="0">
                 <a:solidFill>
-                  <a:srgbClr val="647887"/>
+                  <a:srgbClr val="00355F"/>
                 </a:solidFill>
                 <a:latin typeface="Arial"/>
                 <a:ea typeface="Arial"/>
@@ -3716,7 +3746,7 @@
               <a:buNone/>
               <a:defRPr sz="1575" b="0">
                 <a:solidFill>
-                  <a:srgbClr val="647887"/>
+                  <a:srgbClr val="00355F"/>
                 </a:solidFill>
                 <a:latin typeface="Arial"/>
                 <a:ea typeface="Arial"/>
@@ -3726,7 +3756,7 @@
             <a:r>
               <a:rPr sz="1575" b="0">
                 <a:solidFill>
-                  <a:srgbClr val="647887"/>
+                  <a:srgbClr val="00355F"/>
                 </a:solidFill>
                 <a:latin typeface="Arial"/>
                 <a:ea typeface="Arial"/>
@@ -3742,7 +3772,7 @@
           <p:cNvPr id="5" name="">
             <a:extLst xmlns:a="http://schemas.openxmlformats.org/drawingml/2006/main">
               <a:ext uri="{FF2B5EF4-FFF2-40B4-BE49-F238E27FC236}">
-                <a16:creationId xmlns:a16="http://schemas.microsoft.com/office/drawing/2014/main" id="{63EB93CE-F08F-4D57-AC23-A5082F717BB7}"/>
+                <a16:creationId xmlns:a16="http://schemas.microsoft.com/office/drawing/2014/main" id="{65BF9A3D-545F-4AE2-A9A6-995F83FF4CB4}"/>
               </a:ext>
             </a:extLst>
           </p:cNvPr>
@@ -3771,7 +3801,7 @@
           <a:noFill xmlns:a="http://schemas.openxmlformats.org/drawingml/2006/main"/>
           <a:ln xmlns:a="http://schemas.openxmlformats.org/drawingml/2006/main" w="9525">
             <a:solidFill>
-              <a:srgbClr val="D7E3E8"/>
+              <a:srgbClr val="A5A5A5"/>
             </a:solidFill>
           </a:ln>
         </p:spPr>
@@ -3781,7 +3811,7 @@
           <p:cNvPr id="6" name="">
             <a:extLst xmlns:a="http://schemas.openxmlformats.org/drawingml/2006/main">
               <a:ext uri="{FF2B5EF4-FFF2-40B4-BE49-F238E27FC236}">
-                <a16:creationId xmlns:a16="http://schemas.microsoft.com/office/drawing/2014/main" id="{48BC22F6-B9ED-4848-A925-B288F69136F8}"/>
+                <a16:creationId xmlns:a16="http://schemas.microsoft.com/office/drawing/2014/main" id="{30369601-0B37-46A2-B35D-69382B3CC7E1}"/>
               </a:ext>
             </a:extLst>
           </p:cNvPr>
@@ -3801,11 +3831,11 @@
             </a:avLst>
           </a:prstGeom>
           <a:solidFill xmlns:a="http://schemas.openxmlformats.org/drawingml/2006/main">
-            <a:srgbClr val="F5F8F9"/>
+            <a:srgbClr val="F4F9FD"/>
           </a:solidFill>
           <a:ln xmlns:a="http://schemas.openxmlformats.org/drawingml/2006/main" w="9525">
             <a:solidFill>
-              <a:srgbClr val="D7E3E8"/>
+              <a:srgbClr val="A5A5A5"/>
             </a:solidFill>
           </a:ln>
         </p:spPr>
@@ -3815,7 +3845,7 @@
           <p:cNvPr id="7" name="">
             <a:extLst xmlns:a="http://schemas.openxmlformats.org/drawingml/2006/main">
               <a:ext uri="{FF2B5EF4-FFF2-40B4-BE49-F238E27FC236}">
-                <a16:creationId xmlns:a16="http://schemas.microsoft.com/office/drawing/2014/main" id="{1449EE60-A9A2-4DD7-94D9-6AC6543B7631}"/>
+                <a16:creationId xmlns:a16="http://schemas.microsoft.com/office/drawing/2014/main" id="{D78BD2A6-803C-4BEF-A802-F0DCF67B589C}"/>
               </a:ext>
             </a:extLst>
           </p:cNvPr>
@@ -3835,11 +3865,11 @@
             </a:avLst>
           </a:prstGeom>
           <a:solidFill xmlns:a="http://schemas.openxmlformats.org/drawingml/2006/main">
-            <a:srgbClr val="EAF6F4"/>
+            <a:srgbClr val="EEF6FC"/>
           </a:solidFill>
           <a:ln xmlns:a="http://schemas.openxmlformats.org/drawingml/2006/main" w="9525">
             <a:solidFill>
-              <a:srgbClr val="A5CFC7"/>
+              <a:srgbClr val="7399C6"/>
             </a:solidFill>
           </a:ln>
         </p:spPr>
@@ -3849,7 +3879,7 @@
           <p:cNvPr id="8" name="Existing data: staged screening">
             <a:extLst xmlns:a="http://schemas.openxmlformats.org/drawingml/2006/main">
               <a:ext uri="{FF2B5EF4-FFF2-40B4-BE49-F238E27FC236}">
-                <a16:creationId xmlns:a16="http://schemas.microsoft.com/office/drawing/2014/main" id="{DE78D724-4919-4A12-8096-5FC73D8CD36C}"/>
+                <a16:creationId xmlns:a16="http://schemas.microsoft.com/office/drawing/2014/main" id="{8BB8528D-0182-4A62-940B-C0D56FE5EE52}"/>
               </a:ext>
             </a:extLst>
           </p:cNvPr>
@@ -3877,7 +3907,7 @@
             <a:defPPr algn="l">
               <a:defRPr sz="2175" b="1">
                 <a:solidFill>
-                  <a:srgbClr val="152C3A"/>
+                  <a:srgbClr val="00355F"/>
                 </a:solidFill>
                 <a:latin typeface="Arial"/>
                 <a:ea typeface="Arial"/>
@@ -3893,7 +3923,7 @@
               <a:buNone/>
               <a:defRPr sz="2175" b="1">
                 <a:solidFill>
-                  <a:srgbClr val="152C3A"/>
+                  <a:srgbClr val="00355F"/>
                 </a:solidFill>
                 <a:latin typeface="Arial"/>
                 <a:ea typeface="Arial"/>
@@ -3903,7 +3933,7 @@
             <a:r>
               <a:rPr sz="2175" b="1">
                 <a:solidFill>
-                  <a:srgbClr val="152C3A"/>
+                  <a:srgbClr val="00355F"/>
                 </a:solidFill>
                 <a:latin typeface="Arial"/>
                 <a:ea typeface="Arial"/>
@@ -3919,7 +3949,7 @@
           <p:cNvPr id="9" name="1,000 × 1 initial label">
             <a:extLst xmlns:a="http://schemas.openxmlformats.org/drawingml/2006/main">
               <a:ext uri="{FF2B5EF4-FFF2-40B4-BE49-F238E27FC236}">
-                <a16:creationId xmlns:a16="http://schemas.microsoft.com/office/drawing/2014/main" id="{7F2B7DAE-B620-4BC1-AF2D-EEBD89B5C7E7}"/>
+                <a16:creationId xmlns:a16="http://schemas.microsoft.com/office/drawing/2014/main" id="{041A3F3B-42DE-4253-BA3A-2B52E3BC5D1C}"/>
               </a:ext>
             </a:extLst>
           </p:cNvPr>
@@ -3947,7 +3977,7 @@
             <a:defPPr algn="l">
               <a:defRPr sz="2625" b="1">
                 <a:solidFill>
-                  <a:srgbClr val="2B62B1"/>
+                  <a:srgbClr val="00355F"/>
                 </a:solidFill>
                 <a:latin typeface="Arial"/>
                 <a:ea typeface="Arial"/>
@@ -3963,7 +3993,7 @@
               <a:buNone/>
               <a:defRPr sz="2625" b="1">
                 <a:solidFill>
-                  <a:srgbClr val="2B62B1"/>
+                  <a:srgbClr val="00355F"/>
                 </a:solidFill>
                 <a:latin typeface="Arial"/>
                 <a:ea typeface="Arial"/>
@@ -3973,7 +4003,7 @@
             <a:r>
               <a:rPr sz="2625" b="1">
                 <a:solidFill>
-                  <a:srgbClr val="2B62B1"/>
+                  <a:srgbClr val="00355F"/>
                 </a:solidFill>
                 <a:latin typeface="Arial"/>
                 <a:ea typeface="Arial"/>
@@ -3989,7 +4019,7 @@
           <p:cNvPr id="10" name="Illustrative early single-task dataset">
             <a:extLst xmlns:a="http://schemas.openxmlformats.org/drawingml/2006/main">
               <a:ext uri="{FF2B5EF4-FFF2-40B4-BE49-F238E27FC236}">
-                <a16:creationId xmlns:a16="http://schemas.microsoft.com/office/drawing/2014/main" id="{C484F2E6-6B9D-4F88-8EA5-4D61DF35EB9D}"/>
+                <a16:creationId xmlns:a16="http://schemas.microsoft.com/office/drawing/2014/main" id="{1C156178-1F5C-4406-A88B-62C4F06A2325}"/>
               </a:ext>
             </a:extLst>
           </p:cNvPr>
@@ -4017,7 +4047,7 @@
             <a:defPPr algn="l">
               <a:defRPr sz="1425" b="0">
                 <a:solidFill>
-                  <a:srgbClr val="647887"/>
+                  <a:srgbClr val="00355F"/>
                 </a:solidFill>
                 <a:latin typeface="Arial"/>
                 <a:ea typeface="Arial"/>
@@ -4033,7 +4063,7 @@
               <a:buNone/>
               <a:defRPr sz="1425" b="0">
                 <a:solidFill>
-                  <a:srgbClr val="647887"/>
+                  <a:srgbClr val="00355F"/>
                 </a:solidFill>
                 <a:latin typeface="Arial"/>
                 <a:ea typeface="Arial"/>
@@ -4043,7 +4073,7 @@
             <a:r>
               <a:rPr sz="1425" b="0">
                 <a:solidFill>
-                  <a:srgbClr val="647887"/>
+                  <a:srgbClr val="00355F"/>
                 </a:solidFill>
                 <a:latin typeface="Arial"/>
                 <a:ea typeface="Arial"/>
@@ -4059,7 +4089,7 @@
           <p:cNvPr id="11" name="">
             <a:extLst xmlns:a="http://schemas.openxmlformats.org/drawingml/2006/main">
               <a:ext uri="{FF2B5EF4-FFF2-40B4-BE49-F238E27FC236}">
-                <a16:creationId xmlns:a16="http://schemas.microsoft.com/office/drawing/2014/main" id="{8247930A-FFC5-44E0-8CB6-E972F5EE5061}"/>
+                <a16:creationId xmlns:a16="http://schemas.microsoft.com/office/drawing/2014/main" id="{1812BC12-7AA0-4356-8A6E-E5DD6C545930}"/>
               </a:ext>
             </a:extLst>
           </p:cNvPr>
@@ -4120,7 +4150,7 @@
                       </a:solidFill>
                     </a:lnB>
                     <a:solidFill>
-                      <a:srgbClr val="152C3A"/>
+                      <a:srgbClr val="00355F"/>
                     </a:solidFill>
                   </a:tcPr>
                 </a:tc>
@@ -4160,7 +4190,7 @@
                       </a:solidFill>
                     </a:lnB>
                     <a:solidFill>
-                      <a:srgbClr val="152C3A"/>
+                      <a:srgbClr val="00355F"/>
                     </a:solidFill>
                   </a:tcPr>
                 </a:tc>
@@ -4175,7 +4205,7 @@
                       <a:r>
                         <a:rPr sz="1350" b="0">
                           <a:solidFill>
-                            <a:srgbClr val="647887"/>
+                            <a:srgbClr val="00355F"/>
                           </a:solidFill>
                           <a:latin typeface="Arial"/>
                           <a:ea typeface="Arial"/>
@@ -4215,7 +4245,7 @@
                       <a:r>
                         <a:rPr sz="1425" b="0">
                           <a:solidFill>
-                            <a:srgbClr val="007D80"/>
+                            <a:srgbClr val="00355F"/>
                           </a:solidFill>
                           <a:latin typeface="Arial"/>
                           <a:ea typeface="Arial"/>
@@ -4252,7 +4282,7 @@
                       <a:r>
                         <a:rPr sz="1350" b="0">
                           <a:solidFill>
-                            <a:srgbClr val="647887"/>
+                            <a:srgbClr val="00355F"/>
                           </a:solidFill>
                           <a:latin typeface="Arial"/>
                           <a:ea typeface="Arial"/>
@@ -4292,7 +4322,7 @@
                       <a:r>
                         <a:rPr sz="1425" b="0">
                           <a:solidFill>
-                            <a:srgbClr val="007D80"/>
+                            <a:srgbClr val="00355F"/>
                           </a:solidFill>
                           <a:latin typeface="Arial"/>
                           <a:ea typeface="Arial"/>
@@ -4329,7 +4359,7 @@
                       <a:r>
                         <a:rPr sz="1350" b="0">
                           <a:solidFill>
-                            <a:srgbClr val="647887"/>
+                            <a:srgbClr val="00355F"/>
                           </a:solidFill>
                           <a:latin typeface="Arial"/>
                           <a:ea typeface="Arial"/>
@@ -4369,7 +4399,7 @@
                       <a:r>
                         <a:rPr sz="1425" b="0">
                           <a:solidFill>
-                            <a:srgbClr val="007D80"/>
+                            <a:srgbClr val="00355F"/>
                           </a:solidFill>
                           <a:latin typeface="Arial"/>
                           <a:ea typeface="Arial"/>
@@ -4406,7 +4436,7 @@
                       <a:r>
                         <a:rPr sz="1350" b="0">
                           <a:solidFill>
-                            <a:srgbClr val="647887"/>
+                            <a:srgbClr val="00355F"/>
                           </a:solidFill>
                           <a:latin typeface="Arial"/>
                           <a:ea typeface="Arial"/>
@@ -4446,7 +4476,7 @@
                       <a:r>
                         <a:rPr sz="1425" b="0">
                           <a:solidFill>
-                            <a:srgbClr val="007D80"/>
+                            <a:srgbClr val="00355F"/>
                           </a:solidFill>
                           <a:latin typeface="Arial"/>
                           <a:ea typeface="Arial"/>
@@ -4483,7 +4513,7 @@
                       <a:r>
                         <a:rPr sz="1350" b="0">
                           <a:solidFill>
-                            <a:srgbClr val="647887"/>
+                            <a:srgbClr val="00355F"/>
                           </a:solidFill>
                           <a:latin typeface="Arial"/>
                           <a:ea typeface="Arial"/>
@@ -4523,7 +4553,7 @@
                       <a:r>
                         <a:rPr sz="1425" b="0">
                           <a:solidFill>
-                            <a:srgbClr val="007D80"/>
+                            <a:srgbClr val="00355F"/>
                           </a:solidFill>
                           <a:latin typeface="Arial"/>
                           <a:ea typeface="Arial"/>
@@ -4560,7 +4590,7 @@
                       <a:r>
                         <a:rPr sz="1350" b="0">
                           <a:solidFill>
-                            <a:srgbClr val="647887"/>
+                            <a:srgbClr val="00355F"/>
                           </a:solidFill>
                           <a:latin typeface="Arial"/>
                           <a:ea typeface="Arial"/>
@@ -4600,7 +4630,7 @@
                       <a:r>
                         <a:rPr sz="1425" b="0">
                           <a:solidFill>
-                            <a:srgbClr val="007D80"/>
+                            <a:srgbClr val="00355F"/>
                           </a:solidFill>
                           <a:latin typeface="Arial"/>
                           <a:ea typeface="Arial"/>
@@ -4636,7 +4666,7 @@
           <p:cNvPr id="12" name="Binding first; deeper tests for selected hits">
             <a:extLst xmlns:a="http://schemas.openxmlformats.org/drawingml/2006/main">
               <a:ext uri="{FF2B5EF4-FFF2-40B4-BE49-F238E27FC236}">
-                <a16:creationId xmlns:a16="http://schemas.microsoft.com/office/drawing/2014/main" id="{FE11BABF-7740-4F49-8245-F2B13E27724A}"/>
+                <a16:creationId xmlns:a16="http://schemas.microsoft.com/office/drawing/2014/main" id="{3A3CF096-F483-45C6-9B98-1B5D51AA0B69}"/>
               </a:ext>
             </a:extLst>
           </p:cNvPr>
@@ -4664,7 +4694,7 @@
             <a:defPPr algn="l">
               <a:defRPr sz="1650" b="1">
                 <a:solidFill>
-                  <a:srgbClr val="152C3A"/>
+                  <a:srgbClr val="00355F"/>
                 </a:solidFill>
                 <a:latin typeface="Arial"/>
                 <a:ea typeface="Arial"/>
@@ -4680,7 +4710,7 @@
               <a:buNone/>
               <a:defRPr sz="1650" b="1">
                 <a:solidFill>
-                  <a:srgbClr val="152C3A"/>
+                  <a:srgbClr val="00355F"/>
                 </a:solidFill>
                 <a:latin typeface="Arial"/>
                 <a:ea typeface="Arial"/>
@@ -4690,7 +4720,7 @@
             <a:r>
               <a:rPr sz="1650" b="1">
                 <a:solidFill>
-                  <a:srgbClr val="152C3A"/>
+                  <a:srgbClr val="00355F"/>
                 </a:solidFill>
                 <a:latin typeface="Arial"/>
                 <a:ea typeface="Arial"/>
@@ -4706,7 +4736,7 @@
           <p:cNvPr id="13" name="Multi-assay characterization already exists">
             <a:extLst xmlns:a="http://schemas.openxmlformats.org/drawingml/2006/main">
               <a:ext uri="{FF2B5EF4-FFF2-40B4-BE49-F238E27FC236}">
-                <a16:creationId xmlns:a16="http://schemas.microsoft.com/office/drawing/2014/main" id="{DE0F66E2-BCD2-4E32-85A1-E31CE7B62AA9}"/>
+                <a16:creationId xmlns:a16="http://schemas.microsoft.com/office/drawing/2014/main" id="{F665F633-939D-4BC2-93C1-619E56143A04}"/>
               </a:ext>
             </a:extLst>
           </p:cNvPr>
@@ -4734,7 +4764,7 @@
             <a:defPPr algn="l">
               <a:defRPr sz="1350" b="0">
                 <a:solidFill>
-                  <a:srgbClr val="647887"/>
+                  <a:srgbClr val="00355F"/>
                 </a:solidFill>
                 <a:latin typeface="Arial"/>
                 <a:ea typeface="Arial"/>
@@ -4750,7 +4780,7 @@
               <a:buNone/>
               <a:defRPr sz="1350" b="0">
                 <a:solidFill>
-                  <a:srgbClr val="647887"/>
+                  <a:srgbClr val="00355F"/>
                 </a:solidFill>
                 <a:latin typeface="Arial"/>
                 <a:ea typeface="Arial"/>
@@ -4760,7 +4790,7 @@
             <a:r>
               <a:rPr sz="1350" b="0">
                 <a:solidFill>
-                  <a:srgbClr val="647887"/>
+                  <a:srgbClr val="00355F"/>
                 </a:solidFill>
                 <a:latin typeface="Arial"/>
                 <a:ea typeface="Arial"/>
@@ -4776,7 +4806,7 @@
           <p:cNvPr id="14" name="">
             <a:extLst xmlns:a="http://schemas.openxmlformats.org/drawingml/2006/main">
               <a:ext uri="{FF2B5EF4-FFF2-40B4-BE49-F238E27FC236}">
-                <a16:creationId xmlns:a16="http://schemas.microsoft.com/office/drawing/2014/main" id="{453AE913-9E28-4ED7-BFEC-BFDED55B275D}"/>
+                <a16:creationId xmlns:a16="http://schemas.microsoft.com/office/drawing/2014/main" id="{26BC593D-5177-4BB7-B007-ABC1D3B26D46}"/>
               </a:ext>
             </a:extLst>
           </p:cNvPr>
@@ -4805,7 +4835,7 @@
           <a:noFill xmlns:a="http://schemas.openxmlformats.org/drawingml/2006/main"/>
           <a:ln xmlns:a="http://schemas.openxmlformats.org/drawingml/2006/main" w="28575">
             <a:solidFill>
-              <a:srgbClr val="007D80"/>
+              <a:srgbClr val="00355F"/>
             </a:solidFill>
           </a:ln>
         </p:spPr>
@@ -4815,7 +4845,7 @@
           <p:cNvPr id="15" name="">
             <a:extLst xmlns:a="http://schemas.openxmlformats.org/drawingml/2006/main">
               <a:ext uri="{FF2B5EF4-FFF2-40B4-BE49-F238E27FC236}">
-                <a16:creationId xmlns:a16="http://schemas.microsoft.com/office/drawing/2014/main" id="{B835C5DA-B38B-449B-AC0C-4851049B248C}"/>
+                <a16:creationId xmlns:a16="http://schemas.microsoft.com/office/drawing/2014/main" id="{377B4997-43FF-4B3B-A130-675C46C230F5}"/>
               </a:ext>
             </a:extLst>
           </p:cNvPr>
@@ -4846,7 +4876,7 @@
             </a:pathLst>
           </a:custGeom>
           <a:solidFill xmlns:a="http://schemas.openxmlformats.org/drawingml/2006/main">
-            <a:srgbClr val="007D80"/>
+            <a:srgbClr val="00355F"/>
           </a:solidFill>
           <a:ln xmlns:a="http://schemas.openxmlformats.org/drawingml/2006/main" w="9525">
             <a:noFill/>
@@ -4858,7 +4888,7 @@
           <p:cNvPr id="16" name="AI: richer, linked training data">
             <a:extLst xmlns:a="http://schemas.openxmlformats.org/drawingml/2006/main">
               <a:ext uri="{FF2B5EF4-FFF2-40B4-BE49-F238E27FC236}">
-                <a16:creationId xmlns:a16="http://schemas.microsoft.com/office/drawing/2014/main" id="{B9F50C86-7141-4187-B5EA-A8A82986AF11}"/>
+                <a16:creationId xmlns:a16="http://schemas.microsoft.com/office/drawing/2014/main" id="{CA67AB51-50B7-4622-A7C9-495FECDDC30A}"/>
               </a:ext>
             </a:extLst>
           </p:cNvPr>
@@ -4886,7 +4916,7 @@
             <a:defPPr algn="l">
               <a:defRPr sz="2175" b="1">
                 <a:solidFill>
-                  <a:srgbClr val="152C3A"/>
+                  <a:srgbClr val="00355F"/>
                 </a:solidFill>
                 <a:latin typeface="Arial"/>
                 <a:ea typeface="Arial"/>
@@ -4902,7 +4932,7 @@
               <a:buNone/>
               <a:defRPr sz="2175" b="1">
                 <a:solidFill>
-                  <a:srgbClr val="152C3A"/>
+                  <a:srgbClr val="00355F"/>
                 </a:solidFill>
                 <a:latin typeface="Arial"/>
                 <a:ea typeface="Arial"/>
@@ -4912,7 +4942,7 @@
             <a:r>
               <a:rPr sz="2175" b="1">
                 <a:solidFill>
-                  <a:srgbClr val="152C3A"/>
+                  <a:srgbClr val="00355F"/>
                 </a:solidFill>
                 <a:latin typeface="Arial"/>
                 <a:ea typeface="Arial"/>
@@ -4928,7 +4958,7 @@
           <p:cNvPr id="17" name="300–1,000 antibodies · Up to 9 label types">
             <a:extLst xmlns:a="http://schemas.openxmlformats.org/drawingml/2006/main">
               <a:ext uri="{FF2B5EF4-FFF2-40B4-BE49-F238E27FC236}">
-                <a16:creationId xmlns:a16="http://schemas.microsoft.com/office/drawing/2014/main" id="{6ED02B38-8559-491E-9770-4AF2FD5AF7E6}"/>
+                <a16:creationId xmlns:a16="http://schemas.microsoft.com/office/drawing/2014/main" id="{4F1B6DA0-D6B4-41E5-BA7D-01368C5897DB}"/>
               </a:ext>
             </a:extLst>
           </p:cNvPr>
@@ -4956,7 +4986,7 @@
             <a:defPPr algn="l">
               <a:defRPr sz="2625" b="1">
                 <a:solidFill>
-                  <a:srgbClr val="007D80"/>
+                  <a:srgbClr val="00355F"/>
                 </a:solidFill>
                 <a:latin typeface="Arial"/>
                 <a:ea typeface="Arial"/>
@@ -4972,7 +5002,7 @@
               <a:buNone/>
               <a:defRPr sz="2625" b="1">
                 <a:solidFill>
-                  <a:srgbClr val="007D80"/>
+                  <a:srgbClr val="00355F"/>
                 </a:solidFill>
                 <a:latin typeface="Arial"/>
                 <a:ea typeface="Arial"/>
@@ -4982,7 +5012,7 @@
             <a:r>
               <a:rPr sz="2625" b="1">
                 <a:solidFill>
-                  <a:srgbClr val="007D80"/>
+                  <a:srgbClr val="00355F"/>
                 </a:solidFill>
                 <a:latin typeface="Arial"/>
                 <a:ea typeface="Arial"/>
@@ -4998,7 +5028,7 @@
           <p:cNvPr id="18" name="Measure selected properties on shared molecules; fill the information gaps">
             <a:extLst xmlns:a="http://schemas.openxmlformats.org/drawingml/2006/main">
               <a:ext uri="{FF2B5EF4-FFF2-40B4-BE49-F238E27FC236}">
-                <a16:creationId xmlns:a16="http://schemas.microsoft.com/office/drawing/2014/main" id="{159D0FB3-B70D-4CE8-9037-CD76D6F32FF1}"/>
+                <a16:creationId xmlns:a16="http://schemas.microsoft.com/office/drawing/2014/main" id="{BB22B1F7-D055-4C2D-9CC6-6E81A1E14D81}"/>
               </a:ext>
             </a:extLst>
           </p:cNvPr>
@@ -5026,7 +5056,7 @@
             <a:defPPr algn="l">
               <a:defRPr sz="1425" b="0">
                 <a:solidFill>
-                  <a:srgbClr val="647887"/>
+                  <a:srgbClr val="00355F"/>
                 </a:solidFill>
                 <a:latin typeface="Arial"/>
                 <a:ea typeface="Arial"/>
@@ -5042,7 +5072,7 @@
               <a:buNone/>
               <a:defRPr sz="1425" b="0">
                 <a:solidFill>
-                  <a:srgbClr val="647887"/>
+                  <a:srgbClr val="00355F"/>
                 </a:solidFill>
                 <a:latin typeface="Arial"/>
                 <a:ea typeface="Arial"/>
@@ -5052,7 +5082,7 @@
             <a:r>
               <a:rPr sz="1425" b="0">
                 <a:solidFill>
-                  <a:srgbClr val="647887"/>
+                  <a:srgbClr val="00355F"/>
                 </a:solidFill>
                 <a:latin typeface="Arial"/>
                 <a:ea typeface="Arial"/>
@@ -5068,7 +5098,7 @@
           <p:cNvPr id="19" name="">
             <a:extLst xmlns:a="http://schemas.openxmlformats.org/drawingml/2006/main">
               <a:ext uri="{FF2B5EF4-FFF2-40B4-BE49-F238E27FC236}">
-                <a16:creationId xmlns:a16="http://schemas.microsoft.com/office/drawing/2014/main" id="{8CEF866D-8E5A-40FD-A78B-A839761B6D8D}"/>
+                <a16:creationId xmlns:a16="http://schemas.microsoft.com/office/drawing/2014/main" id="{25EDDA6E-EF97-40ED-B56C-1667B8BDA1CC}"/>
               </a:ext>
             </a:extLst>
           </p:cNvPr>
@@ -5137,7 +5167,7 @@
                       </a:solidFill>
                     </a:lnB>
                     <a:solidFill>
-                      <a:srgbClr val="007D80"/>
+                      <a:srgbClr val="00355F"/>
                     </a:solidFill>
                   </a:tcPr>
                 </a:tc>
@@ -5177,7 +5207,7 @@
                       </a:solidFill>
                     </a:lnB>
                     <a:solidFill>
-                      <a:srgbClr val="007D80"/>
+                      <a:srgbClr val="00355F"/>
                     </a:solidFill>
                   </a:tcPr>
                 </a:tc>
@@ -5217,7 +5247,7 @@
                       </a:solidFill>
                     </a:lnB>
                     <a:solidFill>
-                      <a:srgbClr val="007D80"/>
+                      <a:srgbClr val="00355F"/>
                     </a:solidFill>
                   </a:tcPr>
                 </a:tc>
@@ -5257,7 +5287,7 @@
                       </a:solidFill>
                     </a:lnB>
                     <a:solidFill>
-                      <a:srgbClr val="007D80"/>
+                      <a:srgbClr val="00355F"/>
                     </a:solidFill>
                   </a:tcPr>
                 </a:tc>
@@ -5297,7 +5327,7 @@
                       </a:solidFill>
                     </a:lnB>
                     <a:solidFill>
-                      <a:srgbClr val="007D80"/>
+                      <a:srgbClr val="00355F"/>
                     </a:solidFill>
                   </a:tcPr>
                 </a:tc>
@@ -5337,7 +5367,7 @@
                       </a:solidFill>
                     </a:lnB>
                     <a:solidFill>
-                      <a:srgbClr val="007D80"/>
+                      <a:srgbClr val="00355F"/>
                     </a:solidFill>
                   </a:tcPr>
                 </a:tc>
@@ -5377,7 +5407,7 @@
                       </a:solidFill>
                     </a:lnB>
                     <a:solidFill>
-                      <a:srgbClr val="007D80"/>
+                      <a:srgbClr val="00355F"/>
                     </a:solidFill>
                   </a:tcPr>
                 </a:tc>
@@ -5417,7 +5447,7 @@
                       </a:solidFill>
                     </a:lnB>
                     <a:solidFill>
-                      <a:srgbClr val="007D80"/>
+                      <a:srgbClr val="00355F"/>
                     </a:solidFill>
                   </a:tcPr>
                 </a:tc>
@@ -5457,7 +5487,7 @@
                       </a:solidFill>
                     </a:lnB>
                     <a:solidFill>
-                      <a:srgbClr val="007D80"/>
+                      <a:srgbClr val="00355F"/>
                     </a:solidFill>
                   </a:tcPr>
                 </a:tc>
@@ -5497,7 +5527,7 @@
                       </a:solidFill>
                     </a:lnB>
                     <a:solidFill>
-                      <a:srgbClr val="007D80"/>
+                      <a:srgbClr val="00355F"/>
                     </a:solidFill>
                   </a:tcPr>
                 </a:tc>
@@ -5512,7 +5542,7 @@
                       <a:r>
                         <a:rPr sz="1350" b="0">
                           <a:solidFill>
-                            <a:srgbClr val="647887"/>
+                            <a:srgbClr val="00355F"/>
                           </a:solidFill>
                           <a:latin typeface="Arial"/>
                           <a:ea typeface="Arial"/>
@@ -5552,7 +5582,7 @@
                       <a:r>
                         <a:rPr sz="1425" b="0">
                           <a:solidFill>
-                            <a:srgbClr val="BB8D37"/>
+                            <a:srgbClr val="00355F"/>
                           </a:solidFill>
                           <a:latin typeface="Arial"/>
                           <a:ea typeface="Arial"/>
@@ -5574,7 +5604,7 @@
                       </a:solidFill>
                     </a:lnB>
                     <a:solidFill>
-                      <a:srgbClr val="EAF0FA"/>
+                      <a:srgbClr val="EEF6FC"/>
                     </a:solidFill>
                   </a:tcPr>
                 </a:tc>
@@ -5587,7 +5617,7 @@
                       <a:r>
                         <a:rPr sz="1425" b="0">
                           <a:solidFill>
-                            <a:srgbClr val="007D80"/>
+                            <a:srgbClr val="00355F"/>
                           </a:solidFill>
                           <a:latin typeface="Arial"/>
                           <a:ea typeface="Arial"/>
@@ -5609,7 +5639,7 @@
                       </a:solidFill>
                     </a:lnB>
                     <a:solidFill>
-                      <a:srgbClr val="EAF0FA"/>
+                      <a:srgbClr val="EEF6FC"/>
                     </a:solidFill>
                   </a:tcPr>
                 </a:tc>
@@ -5622,7 +5652,7 @@
                       <a:r>
                         <a:rPr sz="1425" b="0">
                           <a:solidFill>
-                            <a:srgbClr val="007D80"/>
+                            <a:srgbClr val="00355F"/>
                           </a:solidFill>
                           <a:latin typeface="Arial"/>
                           <a:ea typeface="Arial"/>
@@ -5644,7 +5674,7 @@
                       </a:solidFill>
                     </a:lnB>
                     <a:solidFill>
-                      <a:srgbClr val="EAF0FA"/>
+                      <a:srgbClr val="EEF6FC"/>
                     </a:solidFill>
                   </a:tcPr>
                 </a:tc>
@@ -5657,7 +5687,7 @@
                       <a:r>
                         <a:rPr sz="1425" b="0">
                           <a:solidFill>
-                            <a:srgbClr val="007D80"/>
+                            <a:srgbClr val="00355F"/>
                           </a:solidFill>
                           <a:latin typeface="Arial"/>
                           <a:ea typeface="Arial"/>
@@ -5679,7 +5709,7 @@
                       </a:solidFill>
                     </a:lnB>
                     <a:solidFill>
-                      <a:srgbClr val="C7E7E0"/>
+                      <a:srgbClr val="ACD4F1"/>
                     </a:solidFill>
                   </a:tcPr>
                 </a:tc>
@@ -5692,7 +5722,7 @@
                       <a:r>
                         <a:rPr sz="1425" b="0">
                           <a:solidFill>
-                            <a:srgbClr val="007D80"/>
+                            <a:srgbClr val="00355F"/>
                           </a:solidFill>
                           <a:latin typeface="Arial"/>
                           <a:ea typeface="Arial"/>
@@ -5714,7 +5744,7 @@
                       </a:solidFill>
                     </a:lnB>
                     <a:solidFill>
-                      <a:srgbClr val="C7E7E0"/>
+                      <a:srgbClr val="ACD4F1"/>
                     </a:solidFill>
                   </a:tcPr>
                 </a:tc>
@@ -5727,7 +5757,7 @@
                       <a:r>
                         <a:rPr sz="1425" b="0">
                           <a:solidFill>
-                            <a:srgbClr val="007D80"/>
+                            <a:srgbClr val="00355F"/>
                           </a:solidFill>
                           <a:latin typeface="Arial"/>
                           <a:ea typeface="Arial"/>
@@ -5749,7 +5779,7 @@
                       </a:solidFill>
                     </a:lnB>
                     <a:solidFill>
-                      <a:srgbClr val="C7E7E0"/>
+                      <a:srgbClr val="ACD4F1"/>
                     </a:solidFill>
                   </a:tcPr>
                 </a:tc>
@@ -5762,7 +5792,7 @@
                       <a:r>
                         <a:rPr sz="1425" b="0">
                           <a:solidFill>
-                            <a:srgbClr val="007D80"/>
+                            <a:srgbClr val="00355F"/>
                           </a:solidFill>
                           <a:latin typeface="Arial"/>
                           <a:ea typeface="Arial"/>
@@ -5784,7 +5814,7 @@
                       </a:solidFill>
                     </a:lnB>
                     <a:solidFill>
-                      <a:srgbClr val="C7E7E0"/>
+                      <a:srgbClr val="ACD4F1"/>
                     </a:solidFill>
                   </a:tcPr>
                 </a:tc>
@@ -5797,7 +5827,7 @@
                       <a:r>
                         <a:rPr sz="1425" b="0">
                           <a:solidFill>
-                            <a:srgbClr val="007D80"/>
+                            <a:srgbClr val="00355F"/>
                           </a:solidFill>
                           <a:latin typeface="Arial"/>
                           <a:ea typeface="Arial"/>
@@ -5819,7 +5849,7 @@
                       </a:solidFill>
                     </a:lnB>
                     <a:solidFill>
-                      <a:srgbClr val="C7E7E0"/>
+                      <a:srgbClr val="ACD4F1"/>
                     </a:solidFill>
                   </a:tcPr>
                 </a:tc>
@@ -5832,7 +5862,7 @@
                       <a:r>
                         <a:rPr sz="1425" b="0">
                           <a:solidFill>
-                            <a:srgbClr val="007D80"/>
+                            <a:srgbClr val="00355F"/>
                           </a:solidFill>
                           <a:latin typeface="Arial"/>
                           <a:ea typeface="Arial"/>
@@ -5854,7 +5884,7 @@
                       </a:solidFill>
                     </a:lnB>
                     <a:solidFill>
-                      <a:srgbClr val="C7E7E0"/>
+                      <a:srgbClr val="ACD4F1"/>
                     </a:solidFill>
                   </a:tcPr>
                 </a:tc>
@@ -5869,7 +5899,7 @@
                       <a:r>
                         <a:rPr sz="1350" b="0">
                           <a:solidFill>
-                            <a:srgbClr val="647887"/>
+                            <a:srgbClr val="00355F"/>
                           </a:solidFill>
                           <a:latin typeface="Arial"/>
                           <a:ea typeface="Arial"/>
@@ -5909,7 +5939,7 @@
                       <a:r>
                         <a:rPr sz="1425" b="0">
                           <a:solidFill>
-                            <a:srgbClr val="BB8D37"/>
+                            <a:srgbClr val="00355F"/>
                           </a:solidFill>
                           <a:latin typeface="Arial"/>
                           <a:ea typeface="Arial"/>
@@ -5931,7 +5961,7 @@
                       </a:solidFill>
                     </a:lnB>
                     <a:solidFill>
-                      <a:srgbClr val="EAF0FA"/>
+                      <a:srgbClr val="EEF6FC"/>
                     </a:solidFill>
                   </a:tcPr>
                 </a:tc>
@@ -5944,7 +5974,7 @@
                       <a:r>
                         <a:rPr sz="1425" b="0">
                           <a:solidFill>
-                            <a:srgbClr val="007D80"/>
+                            <a:srgbClr val="00355F"/>
                           </a:solidFill>
                           <a:latin typeface="Arial"/>
                           <a:ea typeface="Arial"/>
@@ -5966,7 +5996,7 @@
                       </a:solidFill>
                     </a:lnB>
                     <a:solidFill>
-                      <a:srgbClr val="EAF0FA"/>
+                      <a:srgbClr val="EEF6FC"/>
                     </a:solidFill>
                   </a:tcPr>
                 </a:tc>
@@ -5979,7 +6009,7 @@
                       <a:r>
                         <a:rPr sz="1425" b="0">
                           <a:solidFill>
-                            <a:srgbClr val="007D80"/>
+                            <a:srgbClr val="00355F"/>
                           </a:solidFill>
                           <a:latin typeface="Arial"/>
                           <a:ea typeface="Arial"/>
@@ -6001,7 +6031,7 @@
                       </a:solidFill>
                     </a:lnB>
                     <a:solidFill>
-                      <a:srgbClr val="EAF0FA"/>
+                      <a:srgbClr val="EEF6FC"/>
                     </a:solidFill>
                   </a:tcPr>
                 </a:tc>
@@ -6014,7 +6044,7 @@
                       <a:r>
                         <a:rPr sz="1425" b="0">
                           <a:solidFill>
-                            <a:srgbClr val="007D80"/>
+                            <a:srgbClr val="00355F"/>
                           </a:solidFill>
                           <a:latin typeface="Arial"/>
                           <a:ea typeface="Arial"/>
@@ -6036,7 +6066,7 @@
                       </a:solidFill>
                     </a:lnB>
                     <a:solidFill>
-                      <a:srgbClr val="C7E7E0"/>
+                      <a:srgbClr val="ACD4F1"/>
                     </a:solidFill>
                   </a:tcPr>
                 </a:tc>
@@ -6049,7 +6079,7 @@
                       <a:r>
                         <a:rPr sz="1425" b="0">
                           <a:solidFill>
-                            <a:srgbClr val="007D80"/>
+                            <a:srgbClr val="00355F"/>
                           </a:solidFill>
                           <a:latin typeface="Arial"/>
                           <a:ea typeface="Arial"/>
@@ -6071,7 +6101,7 @@
                       </a:solidFill>
                     </a:lnB>
                     <a:solidFill>
-                      <a:srgbClr val="C7E7E0"/>
+                      <a:srgbClr val="ACD4F1"/>
                     </a:solidFill>
                   </a:tcPr>
                 </a:tc>
@@ -6084,7 +6114,7 @@
                       <a:r>
                         <a:rPr sz="1425" b="0">
                           <a:solidFill>
-                            <a:srgbClr val="007D80"/>
+                            <a:srgbClr val="00355F"/>
                           </a:solidFill>
                           <a:latin typeface="Arial"/>
                           <a:ea typeface="Arial"/>
@@ -6106,7 +6136,7 @@
                       </a:solidFill>
                     </a:lnB>
                     <a:solidFill>
-                      <a:srgbClr val="C7E7E0"/>
+                      <a:srgbClr val="ACD4F1"/>
                     </a:solidFill>
                   </a:tcPr>
                 </a:tc>
@@ -6119,7 +6149,7 @@
                       <a:r>
                         <a:rPr sz="1425" b="0">
                           <a:solidFill>
-                            <a:srgbClr val="007D80"/>
+                            <a:srgbClr val="00355F"/>
                           </a:solidFill>
                           <a:latin typeface="Arial"/>
                           <a:ea typeface="Arial"/>
@@ -6141,7 +6171,7 @@
                       </a:solidFill>
                     </a:lnB>
                     <a:solidFill>
-                      <a:srgbClr val="C7E7E0"/>
+                      <a:srgbClr val="ACD4F1"/>
                     </a:solidFill>
                   </a:tcPr>
                 </a:tc>
@@ -6154,7 +6184,7 @@
                       <a:r>
                         <a:rPr sz="1425" b="0">
                           <a:solidFill>
-                            <a:srgbClr val="007D80"/>
+                            <a:srgbClr val="00355F"/>
                           </a:solidFill>
                           <a:latin typeface="Arial"/>
                           <a:ea typeface="Arial"/>
@@ -6176,7 +6206,7 @@
                       </a:solidFill>
                     </a:lnB>
                     <a:solidFill>
-                      <a:srgbClr val="C7E7E0"/>
+                      <a:srgbClr val="ACD4F1"/>
                     </a:solidFill>
                   </a:tcPr>
                 </a:tc>
@@ -6189,7 +6219,7 @@
                       <a:r>
                         <a:rPr sz="1425" b="0">
                           <a:solidFill>
-                            <a:srgbClr val="007D80"/>
+                            <a:srgbClr val="00355F"/>
                           </a:solidFill>
                           <a:latin typeface="Arial"/>
                           <a:ea typeface="Arial"/>
@@ -6211,7 +6241,7 @@
                       </a:solidFill>
                     </a:lnB>
                     <a:solidFill>
-                      <a:srgbClr val="C7E7E0"/>
+                      <a:srgbClr val="ACD4F1"/>
                     </a:solidFill>
                   </a:tcPr>
                 </a:tc>
@@ -6226,7 +6256,7 @@
                       <a:r>
                         <a:rPr sz="1350" b="0">
                           <a:solidFill>
-                            <a:srgbClr val="647887"/>
+                            <a:srgbClr val="00355F"/>
                           </a:solidFill>
                           <a:latin typeface="Arial"/>
                           <a:ea typeface="Arial"/>
@@ -6266,7 +6296,7 @@
                       <a:r>
                         <a:rPr sz="1425" b="0">
                           <a:solidFill>
-                            <a:srgbClr val="BB8D37"/>
+                            <a:srgbClr val="00355F"/>
                           </a:solidFill>
                           <a:latin typeface="Arial"/>
                           <a:ea typeface="Arial"/>
@@ -6288,7 +6318,7 @@
                       </a:solidFill>
                     </a:lnB>
                     <a:solidFill>
-                      <a:srgbClr val="EAF0FA"/>
+                      <a:srgbClr val="EEF6FC"/>
                     </a:solidFill>
                   </a:tcPr>
                 </a:tc>
@@ -6301,7 +6331,7 @@
                       <a:r>
                         <a:rPr sz="1425" b="0">
                           <a:solidFill>
-                            <a:srgbClr val="007D80"/>
+                            <a:srgbClr val="00355F"/>
                           </a:solidFill>
                           <a:latin typeface="Arial"/>
                           <a:ea typeface="Arial"/>
@@ -6323,7 +6353,7 @@
                       </a:solidFill>
                     </a:lnB>
                     <a:solidFill>
-                      <a:srgbClr val="EAF0FA"/>
+                      <a:srgbClr val="EEF6FC"/>
                     </a:solidFill>
                   </a:tcPr>
                 </a:tc>
@@ -6336,7 +6366,7 @@
                       <a:r>
                         <a:rPr sz="1425" b="0">
                           <a:solidFill>
-                            <a:srgbClr val="007D80"/>
+                            <a:srgbClr val="00355F"/>
                           </a:solidFill>
                           <a:latin typeface="Arial"/>
                           <a:ea typeface="Arial"/>
@@ -6358,7 +6388,7 @@
                       </a:solidFill>
                     </a:lnB>
                     <a:solidFill>
-                      <a:srgbClr val="EAF0FA"/>
+                      <a:srgbClr val="EEF6FC"/>
                     </a:solidFill>
                   </a:tcPr>
                 </a:tc>
@@ -6371,7 +6401,7 @@
                       <a:r>
                         <a:rPr sz="1425" b="0">
                           <a:solidFill>
-                            <a:srgbClr val="007D80"/>
+                            <a:srgbClr val="00355F"/>
                           </a:solidFill>
                           <a:latin typeface="Arial"/>
                           <a:ea typeface="Arial"/>
@@ -6393,7 +6423,7 @@
                       </a:solidFill>
                     </a:lnB>
                     <a:solidFill>
-                      <a:srgbClr val="C7E7E0"/>
+                      <a:srgbClr val="ACD4F1"/>
                     </a:solidFill>
                   </a:tcPr>
                 </a:tc>
@@ -6406,7 +6436,7 @@
                       <a:r>
                         <a:rPr sz="1425" b="0">
                           <a:solidFill>
-                            <a:srgbClr val="007D80"/>
+                            <a:srgbClr val="00355F"/>
                           </a:solidFill>
                           <a:latin typeface="Arial"/>
                           <a:ea typeface="Arial"/>
@@ -6428,7 +6458,7 @@
                       </a:solidFill>
                     </a:lnB>
                     <a:solidFill>
-                      <a:srgbClr val="C7E7E0"/>
+                      <a:srgbClr val="ACD4F1"/>
                     </a:solidFill>
                   </a:tcPr>
                 </a:tc>
@@ -6441,7 +6471,7 @@
                       <a:r>
                         <a:rPr sz="1425" b="0">
                           <a:solidFill>
-                            <a:srgbClr val="007D80"/>
+                            <a:srgbClr val="00355F"/>
                           </a:solidFill>
                           <a:latin typeface="Arial"/>
                           <a:ea typeface="Arial"/>
@@ -6463,7 +6493,7 @@
                       </a:solidFill>
                     </a:lnB>
                     <a:solidFill>
-                      <a:srgbClr val="C7E7E0"/>
+                      <a:srgbClr val="ACD4F1"/>
                     </a:solidFill>
                   </a:tcPr>
                 </a:tc>
@@ -6476,7 +6506,7 @@
                       <a:r>
                         <a:rPr sz="1425" b="0">
                           <a:solidFill>
-                            <a:srgbClr val="007D80"/>
+                            <a:srgbClr val="00355F"/>
                           </a:solidFill>
                           <a:latin typeface="Arial"/>
                           <a:ea typeface="Arial"/>
@@ -6498,7 +6528,7 @@
                       </a:solidFill>
                     </a:lnB>
                     <a:solidFill>
-                      <a:srgbClr val="C7E7E0"/>
+                      <a:srgbClr val="ACD4F1"/>
                     </a:solidFill>
                   </a:tcPr>
                 </a:tc>
@@ -6511,7 +6541,7 @@
                       <a:r>
                         <a:rPr sz="1425" b="0">
                           <a:solidFill>
-                            <a:srgbClr val="007D80"/>
+                            <a:srgbClr val="00355F"/>
                           </a:solidFill>
                           <a:latin typeface="Arial"/>
                           <a:ea typeface="Arial"/>
@@ -6533,7 +6563,7 @@
                       </a:solidFill>
                     </a:lnB>
                     <a:solidFill>
-                      <a:srgbClr val="C7E7E0"/>
+                      <a:srgbClr val="ACD4F1"/>
                     </a:solidFill>
                   </a:tcPr>
                 </a:tc>
@@ -6546,7 +6576,7 @@
                       <a:r>
                         <a:rPr sz="1425" b="0">
                           <a:solidFill>
-                            <a:srgbClr val="007D80"/>
+                            <a:srgbClr val="00355F"/>
                           </a:solidFill>
                           <a:latin typeface="Arial"/>
                           <a:ea typeface="Arial"/>
@@ -6568,7 +6598,7 @@
                       </a:solidFill>
                     </a:lnB>
                     <a:solidFill>
-                      <a:srgbClr val="C7E7E0"/>
+                      <a:srgbClr val="ACD4F1"/>
                     </a:solidFill>
                   </a:tcPr>
                 </a:tc>
@@ -6583,7 +6613,7 @@
                       <a:r>
                         <a:rPr sz="1350" b="0">
                           <a:solidFill>
-                            <a:srgbClr val="647887"/>
+                            <a:srgbClr val="00355F"/>
                           </a:solidFill>
                           <a:latin typeface="Arial"/>
                           <a:ea typeface="Arial"/>
@@ -6623,7 +6653,7 @@
                       <a:r>
                         <a:rPr sz="1425" b="0">
                           <a:solidFill>
-                            <a:srgbClr val="BB8D37"/>
+                            <a:srgbClr val="00355F"/>
                           </a:solidFill>
                           <a:latin typeface="Arial"/>
                           <a:ea typeface="Arial"/>
@@ -6645,7 +6675,7 @@
                       </a:solidFill>
                     </a:lnB>
                     <a:solidFill>
-                      <a:srgbClr val="EAF0FA"/>
+                      <a:srgbClr val="EEF6FC"/>
                     </a:solidFill>
                   </a:tcPr>
                 </a:tc>
@@ -6658,7 +6688,7 @@
                       <a:r>
                         <a:rPr sz="1425" b="0">
                           <a:solidFill>
-                            <a:srgbClr val="007D80"/>
+                            <a:srgbClr val="00355F"/>
                           </a:solidFill>
                           <a:latin typeface="Arial"/>
                           <a:ea typeface="Arial"/>
@@ -6680,7 +6710,7 @@
                       </a:solidFill>
                     </a:lnB>
                     <a:solidFill>
-                      <a:srgbClr val="EAF0FA"/>
+                      <a:srgbClr val="EEF6FC"/>
                     </a:solidFill>
                   </a:tcPr>
                 </a:tc>
@@ -6693,7 +6723,7 @@
                       <a:r>
                         <a:rPr sz="1425" b="0">
                           <a:solidFill>
-                            <a:srgbClr val="007D80"/>
+                            <a:srgbClr val="00355F"/>
                           </a:solidFill>
                           <a:latin typeface="Arial"/>
                           <a:ea typeface="Arial"/>
@@ -6715,7 +6745,7 @@
                       </a:solidFill>
                     </a:lnB>
                     <a:solidFill>
-                      <a:srgbClr val="EAF0FA"/>
+                      <a:srgbClr val="EEF6FC"/>
                     </a:solidFill>
                   </a:tcPr>
                 </a:tc>
@@ -6728,7 +6758,7 @@
                       <a:r>
                         <a:rPr sz="1425" b="0">
                           <a:solidFill>
-                            <a:srgbClr val="007D80"/>
+                            <a:srgbClr val="00355F"/>
                           </a:solidFill>
                           <a:latin typeface="Arial"/>
                           <a:ea typeface="Arial"/>
@@ -6750,7 +6780,7 @@
                       </a:solidFill>
                     </a:lnB>
                     <a:solidFill>
-                      <a:srgbClr val="C7E7E0"/>
+                      <a:srgbClr val="ACD4F1"/>
                     </a:solidFill>
                   </a:tcPr>
                 </a:tc>
@@ -6763,7 +6793,7 @@
                       <a:r>
                         <a:rPr sz="1425" b="0">
                           <a:solidFill>
-                            <a:srgbClr val="007D80"/>
+                            <a:srgbClr val="00355F"/>
                           </a:solidFill>
                           <a:latin typeface="Arial"/>
                           <a:ea typeface="Arial"/>
@@ -6785,7 +6815,7 @@
                       </a:solidFill>
                     </a:lnB>
                     <a:solidFill>
-                      <a:srgbClr val="C7E7E0"/>
+                      <a:srgbClr val="ACD4F1"/>
                     </a:solidFill>
                   </a:tcPr>
                 </a:tc>
@@ -6798,7 +6828,7 @@
                       <a:r>
                         <a:rPr sz="1425" b="0">
                           <a:solidFill>
-                            <a:srgbClr val="007D80"/>
+                            <a:srgbClr val="00355F"/>
                           </a:solidFill>
                           <a:latin typeface="Arial"/>
                           <a:ea typeface="Arial"/>
@@ -6820,7 +6850,7 @@
                       </a:solidFill>
                     </a:lnB>
                     <a:solidFill>
-                      <a:srgbClr val="C7E7E0"/>
+                      <a:srgbClr val="ACD4F1"/>
                     </a:solidFill>
                   </a:tcPr>
                 </a:tc>
@@ -6833,7 +6863,7 @@
                       <a:r>
                         <a:rPr sz="1425" b="0">
                           <a:solidFill>
-                            <a:srgbClr val="007D80"/>
+                            <a:srgbClr val="00355F"/>
                           </a:solidFill>
                           <a:latin typeface="Arial"/>
                           <a:ea typeface="Arial"/>
@@ -6855,7 +6885,7 @@
                       </a:solidFill>
                     </a:lnB>
                     <a:solidFill>
-                      <a:srgbClr val="C7E7E0"/>
+                      <a:srgbClr val="ACD4F1"/>
                     </a:solidFill>
                   </a:tcPr>
                 </a:tc>
@@ -6868,7 +6898,7 @@
                       <a:r>
                         <a:rPr sz="1425" b="0">
                           <a:solidFill>
-                            <a:srgbClr val="007D80"/>
+                            <a:srgbClr val="00355F"/>
                           </a:solidFill>
                           <a:latin typeface="Arial"/>
                           <a:ea typeface="Arial"/>
@@ -6890,7 +6920,7 @@
                       </a:solidFill>
                     </a:lnB>
                     <a:solidFill>
-                      <a:srgbClr val="C7E7E0"/>
+                      <a:srgbClr val="ACD4F1"/>
                     </a:solidFill>
                   </a:tcPr>
                 </a:tc>
@@ -6903,7 +6933,7 @@
                       <a:r>
                         <a:rPr sz="1425" b="0">
                           <a:solidFill>
-                            <a:srgbClr val="007D80"/>
+                            <a:srgbClr val="00355F"/>
                           </a:solidFill>
                           <a:latin typeface="Arial"/>
                           <a:ea typeface="Arial"/>
@@ -6925,7 +6955,7 @@
                       </a:solidFill>
                     </a:lnB>
                     <a:solidFill>
-                      <a:srgbClr val="C7E7E0"/>
+                      <a:srgbClr val="ACD4F1"/>
                     </a:solidFill>
                   </a:tcPr>
                 </a:tc>
@@ -6940,7 +6970,7 @@
                       <a:r>
                         <a:rPr sz="1350" b="0">
                           <a:solidFill>
-                            <a:srgbClr val="647887"/>
+                            <a:srgbClr val="00355F"/>
                           </a:solidFill>
                           <a:latin typeface="Arial"/>
                           <a:ea typeface="Arial"/>
@@ -6980,7 +7010,7 @@
                       <a:r>
                         <a:rPr sz="1425" b="0">
                           <a:solidFill>
-                            <a:srgbClr val="BB8D37"/>
+                            <a:srgbClr val="00355F"/>
                           </a:solidFill>
                           <a:latin typeface="Arial"/>
                           <a:ea typeface="Arial"/>
@@ -7002,7 +7032,7 @@
                       </a:solidFill>
                     </a:lnB>
                     <a:solidFill>
-                      <a:srgbClr val="EAF0FA"/>
+                      <a:srgbClr val="EEF6FC"/>
                     </a:solidFill>
                   </a:tcPr>
                 </a:tc>
@@ -7015,7 +7045,7 @@
                       <a:r>
                         <a:rPr sz="1425" b="0">
                           <a:solidFill>
-                            <a:srgbClr val="007D80"/>
+                            <a:srgbClr val="00355F"/>
                           </a:solidFill>
                           <a:latin typeface="Arial"/>
                           <a:ea typeface="Arial"/>
@@ -7037,7 +7067,7 @@
                       </a:solidFill>
                     </a:lnB>
                     <a:solidFill>
-                      <a:srgbClr val="EAF0FA"/>
+                      <a:srgbClr val="EEF6FC"/>
                     </a:solidFill>
                   </a:tcPr>
                 </a:tc>
@@ -7050,7 +7080,7 @@
                       <a:r>
                         <a:rPr sz="1425" b="0">
                           <a:solidFill>
-                            <a:srgbClr val="007D80"/>
+                            <a:srgbClr val="00355F"/>
                           </a:solidFill>
                           <a:latin typeface="Arial"/>
                           <a:ea typeface="Arial"/>
@@ -7072,7 +7102,7 @@
                       </a:solidFill>
                     </a:lnB>
                     <a:solidFill>
-                      <a:srgbClr val="EAF0FA"/>
+                      <a:srgbClr val="EEF6FC"/>
                     </a:solidFill>
                   </a:tcPr>
                 </a:tc>
@@ -7085,7 +7115,7 @@
                       <a:r>
                         <a:rPr sz="1425" b="0">
                           <a:solidFill>
-                            <a:srgbClr val="007D80"/>
+                            <a:srgbClr val="00355F"/>
                           </a:solidFill>
                           <a:latin typeface="Arial"/>
                           <a:ea typeface="Arial"/>
@@ -7107,7 +7137,7 @@
                       </a:solidFill>
                     </a:lnB>
                     <a:solidFill>
-                      <a:srgbClr val="C7E7E0"/>
+                      <a:srgbClr val="ACD4F1"/>
                     </a:solidFill>
                   </a:tcPr>
                 </a:tc>
@@ -7120,7 +7150,7 @@
                       <a:r>
                         <a:rPr sz="1425" b="0">
                           <a:solidFill>
-                            <a:srgbClr val="007D80"/>
+                            <a:srgbClr val="00355F"/>
                           </a:solidFill>
                           <a:latin typeface="Arial"/>
                           <a:ea typeface="Arial"/>
@@ -7142,7 +7172,7 @@
                       </a:solidFill>
                     </a:lnB>
                     <a:solidFill>
-                      <a:srgbClr val="C7E7E0"/>
+                      <a:srgbClr val="ACD4F1"/>
                     </a:solidFill>
                   </a:tcPr>
                 </a:tc>
@@ -7155,7 +7185,7 @@
                       <a:r>
                         <a:rPr sz="1425" b="0">
                           <a:solidFill>
-                            <a:srgbClr val="007D80"/>
+                            <a:srgbClr val="00355F"/>
                           </a:solidFill>
                           <a:latin typeface="Arial"/>
                           <a:ea typeface="Arial"/>
@@ -7177,7 +7207,7 @@
                       </a:solidFill>
                     </a:lnB>
                     <a:solidFill>
-                      <a:srgbClr val="C7E7E0"/>
+                      <a:srgbClr val="ACD4F1"/>
                     </a:solidFill>
                   </a:tcPr>
                 </a:tc>
@@ -7190,7 +7220,7 @@
                       <a:r>
                         <a:rPr sz="1425" b="0">
                           <a:solidFill>
-                            <a:srgbClr val="647887"/>
+                            <a:srgbClr val="00355F"/>
                           </a:solidFill>
                           <a:latin typeface="Arial"/>
                           <a:ea typeface="Arial"/>
@@ -7212,7 +7242,7 @@
                       </a:solidFill>
                     </a:lnB>
                     <a:solidFill>
-                      <a:srgbClr val="F5F8F9"/>
+                      <a:srgbClr val="F4F9FD"/>
                     </a:solidFill>
                   </a:tcPr>
                 </a:tc>
@@ -7225,7 +7255,7 @@
                       <a:r>
                         <a:rPr sz="1425" b="0">
                           <a:solidFill>
-                            <a:srgbClr val="007D80"/>
+                            <a:srgbClr val="00355F"/>
                           </a:solidFill>
                           <a:latin typeface="Arial"/>
                           <a:ea typeface="Arial"/>
@@ -7247,7 +7277,7 @@
                       </a:solidFill>
                     </a:lnB>
                     <a:solidFill>
-                      <a:srgbClr val="C7E7E0"/>
+                      <a:srgbClr val="ACD4F1"/>
                     </a:solidFill>
                   </a:tcPr>
                 </a:tc>
@@ -7260,7 +7290,7 @@
                       <a:r>
                         <a:rPr sz="1425" b="0">
                           <a:solidFill>
-                            <a:srgbClr val="647887"/>
+                            <a:srgbClr val="00355F"/>
                           </a:solidFill>
                           <a:latin typeface="Arial"/>
                           <a:ea typeface="Arial"/>
@@ -7282,7 +7312,7 @@
                       </a:solidFill>
                     </a:lnB>
                     <a:solidFill>
-                      <a:srgbClr val="F5F8F9"/>
+                      <a:srgbClr val="F4F9FD"/>
                     </a:solidFill>
                   </a:tcPr>
                 </a:tc>
@@ -7297,7 +7327,7 @@
                       <a:r>
                         <a:rPr sz="1350" b="0">
                           <a:solidFill>
-                            <a:srgbClr val="647887"/>
+                            <a:srgbClr val="00355F"/>
                           </a:solidFill>
                           <a:latin typeface="Arial"/>
                           <a:ea typeface="Arial"/>
@@ -7337,7 +7367,7 @@
                       <a:r>
                         <a:rPr sz="1425" b="0">
                           <a:solidFill>
-                            <a:srgbClr val="BB8D37"/>
+                            <a:srgbClr val="00355F"/>
                           </a:solidFill>
                           <a:latin typeface="Arial"/>
                           <a:ea typeface="Arial"/>
@@ -7359,7 +7389,7 @@
                       </a:solidFill>
                     </a:lnB>
                     <a:solidFill>
-                      <a:srgbClr val="EAF0FA"/>
+                      <a:srgbClr val="EEF6FC"/>
                     </a:solidFill>
                   </a:tcPr>
                 </a:tc>
@@ -7372,7 +7402,7 @@
                       <a:r>
                         <a:rPr sz="1425" b="0">
                           <a:solidFill>
-                            <a:srgbClr val="007D80"/>
+                            <a:srgbClr val="00355F"/>
                           </a:solidFill>
                           <a:latin typeface="Arial"/>
                           <a:ea typeface="Arial"/>
@@ -7394,7 +7424,7 @@
                       </a:solidFill>
                     </a:lnB>
                     <a:solidFill>
-                      <a:srgbClr val="EAF0FA"/>
+                      <a:srgbClr val="EEF6FC"/>
                     </a:solidFill>
                   </a:tcPr>
                 </a:tc>
@@ -7407,7 +7437,7 @@
                       <a:r>
                         <a:rPr sz="1425" b="0">
                           <a:solidFill>
-                            <a:srgbClr val="007D80"/>
+                            <a:srgbClr val="00355F"/>
                           </a:solidFill>
                           <a:latin typeface="Arial"/>
                           <a:ea typeface="Arial"/>
@@ -7429,7 +7459,7 @@
                       </a:solidFill>
                     </a:lnB>
                     <a:solidFill>
-                      <a:srgbClr val="EAF0FA"/>
+                      <a:srgbClr val="EEF6FC"/>
                     </a:solidFill>
                   </a:tcPr>
                 </a:tc>
@@ -7442,7 +7472,7 @@
                       <a:r>
                         <a:rPr sz="1425" b="0">
                           <a:solidFill>
-                            <a:srgbClr val="007D80"/>
+                            <a:srgbClr val="00355F"/>
                           </a:solidFill>
                           <a:latin typeface="Arial"/>
                           <a:ea typeface="Arial"/>
@@ -7464,7 +7494,7 @@
                       </a:solidFill>
                     </a:lnB>
                     <a:solidFill>
-                      <a:srgbClr val="C7E7E0"/>
+                      <a:srgbClr val="ACD4F1"/>
                     </a:solidFill>
                   </a:tcPr>
                 </a:tc>
@@ -7477,7 +7507,7 @@
                       <a:r>
                         <a:rPr sz="1425" b="0">
                           <a:solidFill>
-                            <a:srgbClr val="007D80"/>
+                            <a:srgbClr val="00355F"/>
                           </a:solidFill>
                           <a:latin typeface="Arial"/>
                           <a:ea typeface="Arial"/>
@@ -7499,7 +7529,7 @@
                       </a:solidFill>
                     </a:lnB>
                     <a:solidFill>
-                      <a:srgbClr val="C7E7E0"/>
+                      <a:srgbClr val="ACD4F1"/>
                     </a:solidFill>
                   </a:tcPr>
                 </a:tc>
@@ -7512,7 +7542,7 @@
                       <a:r>
                         <a:rPr sz="1425" b="0">
                           <a:solidFill>
-                            <a:srgbClr val="007D80"/>
+                            <a:srgbClr val="00355F"/>
                           </a:solidFill>
                           <a:latin typeface="Arial"/>
                           <a:ea typeface="Arial"/>
@@ -7534,7 +7564,7 @@
                       </a:solidFill>
                     </a:lnB>
                     <a:solidFill>
-                      <a:srgbClr val="C7E7E0"/>
+                      <a:srgbClr val="ACD4F1"/>
                     </a:solidFill>
                   </a:tcPr>
                 </a:tc>
@@ -7547,7 +7577,7 @@
                       <a:r>
                         <a:rPr sz="1425" b="0">
                           <a:solidFill>
-                            <a:srgbClr val="007D80"/>
+                            <a:srgbClr val="00355F"/>
                           </a:solidFill>
                           <a:latin typeface="Arial"/>
                           <a:ea typeface="Arial"/>
@@ -7569,7 +7599,7 @@
                       </a:solidFill>
                     </a:lnB>
                     <a:solidFill>
-                      <a:srgbClr val="C7E7E0"/>
+                      <a:srgbClr val="ACD4F1"/>
                     </a:solidFill>
                   </a:tcPr>
                 </a:tc>
@@ -7582,7 +7612,7 @@
                       <a:r>
                         <a:rPr sz="1425" b="0">
                           <a:solidFill>
-                            <a:srgbClr val="647887"/>
+                            <a:srgbClr val="00355F"/>
                           </a:solidFill>
                           <a:latin typeface="Arial"/>
                           <a:ea typeface="Arial"/>
@@ -7604,7 +7634,7 @@
                       </a:solidFill>
                     </a:lnB>
                     <a:solidFill>
-                      <a:srgbClr val="F5F8F9"/>
+                      <a:srgbClr val="F4F9FD"/>
                     </a:solidFill>
                   </a:tcPr>
                 </a:tc>
@@ -7617,7 +7647,7 @@
                       <a:r>
                         <a:rPr sz="1425" b="0">
                           <a:solidFill>
-                            <a:srgbClr val="007D80"/>
+                            <a:srgbClr val="00355F"/>
                           </a:solidFill>
                           <a:latin typeface="Arial"/>
                           <a:ea typeface="Arial"/>
@@ -7639,7 +7669,7 @@
                       </a:solidFill>
                     </a:lnB>
                     <a:solidFill>
-                      <a:srgbClr val="C7E7E0"/>
+                      <a:srgbClr val="ACD4F1"/>
                     </a:solidFill>
                   </a:tcPr>
                 </a:tc>
@@ -7653,7 +7683,7 @@
           <p:cNvPr id="20" name="Learn binding, expression, stability and functional relationships">
             <a:extLst xmlns:a="http://schemas.openxmlformats.org/drawingml/2006/main">
               <a:ext uri="{FF2B5EF4-FFF2-40B4-BE49-F238E27FC236}">
-                <a16:creationId xmlns:a16="http://schemas.microsoft.com/office/drawing/2014/main" id="{97C031F8-DD18-4E5B-B2A4-00D894F096A8}"/>
+                <a16:creationId xmlns:a16="http://schemas.microsoft.com/office/drawing/2014/main" id="{7B77D2A1-F185-4EDE-840C-08419E56576C}"/>
               </a:ext>
             </a:extLst>
           </p:cNvPr>
@@ -7681,7 +7711,7 @@
             <a:defPPr algn="l">
               <a:defRPr sz="1650" b="1">
                 <a:solidFill>
-                  <a:srgbClr val="152C3A"/>
+                  <a:srgbClr val="00355F"/>
                 </a:solidFill>
                 <a:latin typeface="Arial"/>
                 <a:ea typeface="Arial"/>
@@ -7697,7 +7727,7 @@
               <a:buNone/>
               <a:defRPr sz="1650" b="1">
                 <a:solidFill>
-                  <a:srgbClr val="152C3A"/>
+                  <a:srgbClr val="00355F"/>
                 </a:solidFill>
                 <a:latin typeface="Arial"/>
                 <a:ea typeface="Arial"/>
@@ -7707,7 +7737,7 @@
             <a:r>
               <a:rPr sz="1650" b="1">
                 <a:solidFill>
-                  <a:srgbClr val="152C3A"/>
+                  <a:srgbClr val="00355F"/>
                 </a:solidFill>
                 <a:latin typeface="Arial"/>
                 <a:ea typeface="Arial"/>
@@ -7723,7 +7753,7 @@
           <p:cNvPr id="21" name="● Measured label   ○ KD derived from shared kinetics   — Unmeasured; colors show coverage">
             <a:extLst xmlns:a="http://schemas.openxmlformats.org/drawingml/2006/main">
               <a:ext uri="{FF2B5EF4-FFF2-40B4-BE49-F238E27FC236}">
-                <a16:creationId xmlns:a16="http://schemas.microsoft.com/office/drawing/2014/main" id="{FF134704-33F6-40CB-9ACA-176BB40BB5A3}"/>
+                <a16:creationId xmlns:a16="http://schemas.microsoft.com/office/drawing/2014/main" id="{A409B588-95BD-4A8F-BAB8-32C710A946E1}"/>
               </a:ext>
             </a:extLst>
           </p:cNvPr>
@@ -7751,7 +7781,7 @@
             <a:defPPr algn="l">
               <a:defRPr sz="1275" b="0">
                 <a:solidFill>
-                  <a:srgbClr val="647887"/>
+                  <a:srgbClr val="00355F"/>
                 </a:solidFill>
                 <a:latin typeface="Arial"/>
                 <a:ea typeface="Arial"/>
@@ -7767,7 +7797,7 @@
               <a:buNone/>
               <a:defRPr sz="1275" b="0">
                 <a:solidFill>
-                  <a:srgbClr val="647887"/>
+                  <a:srgbClr val="00355F"/>
                 </a:solidFill>
                 <a:latin typeface="Arial"/>
                 <a:ea typeface="Arial"/>
@@ -7777,7 +7807,7 @@
             <a:r>
               <a:rPr sz="1275" b="0">
                 <a:solidFill>
-                  <a:srgbClr val="647887"/>
+                  <a:srgbClr val="00355F"/>
                 </a:solidFill>
                 <a:latin typeface="Arial"/>
                 <a:ea typeface="Arial"/>
@@ -7793,7 +7823,7 @@
           <p:cNvPr id="22" name="">
             <a:extLst xmlns:a="http://schemas.openxmlformats.org/drawingml/2006/main">
               <a:ext uri="{FF2B5EF4-FFF2-40B4-BE49-F238E27FC236}">
-                <a16:creationId xmlns:a16="http://schemas.microsoft.com/office/drawing/2014/main" id="{04EBBF18-B153-4080-9ED0-8E5942323102}"/>
+                <a16:creationId xmlns:a16="http://schemas.microsoft.com/office/drawing/2014/main" id="{D4CB9D4C-FE23-474D-9145-D8ABDF4B766E}"/>
               </a:ext>
             </a:extLst>
           </p:cNvPr>
@@ -7817,7 +7847,7 @@
           </a:solidFill>
           <a:ln xmlns:a="http://schemas.openxmlformats.org/drawingml/2006/main" w="9525">
             <a:solidFill>
-              <a:srgbClr val="D7E3E8"/>
+              <a:srgbClr val="A5A5A5"/>
             </a:solidFill>
           </a:ln>
         </p:spPr>
@@ -7827,7 +7857,7 @@
           <p:cNvPr id="23" name="Reuse existing data">
             <a:extLst xmlns:a="http://schemas.openxmlformats.org/drawingml/2006/main">
               <a:ext uri="{FF2B5EF4-FFF2-40B4-BE49-F238E27FC236}">
-                <a16:creationId xmlns:a16="http://schemas.microsoft.com/office/drawing/2014/main" id="{C54D5403-B569-470A-8A4B-A233A9154CF5}"/>
+                <a16:creationId xmlns:a16="http://schemas.microsoft.com/office/drawing/2014/main" id="{DB532DB5-43A3-428C-BB89-CD6AFA166EB6}"/>
               </a:ext>
             </a:extLst>
           </p:cNvPr>
@@ -7855,7 +7885,7 @@
             <a:defPPr algn="l">
               <a:defRPr sz="1875" b="1">
                 <a:solidFill>
-                  <a:srgbClr val="152C3A"/>
+                  <a:srgbClr val="00355F"/>
                 </a:solidFill>
                 <a:latin typeface="Arial"/>
                 <a:ea typeface="Arial"/>
@@ -7871,7 +7901,7 @@
               <a:buNone/>
               <a:defRPr sz="1875" b="1">
                 <a:solidFill>
-                  <a:srgbClr val="152C3A"/>
+                  <a:srgbClr val="00355F"/>
                 </a:solidFill>
                 <a:latin typeface="Arial"/>
                 <a:ea typeface="Arial"/>
@@ -7881,7 +7911,7 @@
             <a:r>
               <a:rPr sz="1875" b="1">
                 <a:solidFill>
-                  <a:srgbClr val="152C3A"/>
+                  <a:srgbClr val="00355F"/>
                 </a:solidFill>
                 <a:latin typeface="Arial"/>
                 <a:ea typeface="Arial"/>
@@ -7897,7 +7927,7 @@
           <p:cNvPr id="24" name="Normalize formats, conditions and access">
             <a:extLst xmlns:a="http://schemas.openxmlformats.org/drawingml/2006/main">
               <a:ext uri="{FF2B5EF4-FFF2-40B4-BE49-F238E27FC236}">
-                <a16:creationId xmlns:a16="http://schemas.microsoft.com/office/drawing/2014/main" id="{AE965EE2-1E52-489F-B59A-ED936F6AF404}"/>
+                <a16:creationId xmlns:a16="http://schemas.microsoft.com/office/drawing/2014/main" id="{02682A18-5627-4C9C-9EBB-E678118EEF3D}"/>
               </a:ext>
             </a:extLst>
           </p:cNvPr>
@@ -7925,7 +7955,7 @@
             <a:defPPr algn="l">
               <a:defRPr sz="1500" b="0">
                 <a:solidFill>
-                  <a:srgbClr val="647887"/>
+                  <a:srgbClr val="00355F"/>
                 </a:solidFill>
                 <a:latin typeface="Arial"/>
                 <a:ea typeface="Arial"/>
@@ -7941,7 +7971,7 @@
               <a:buNone/>
               <a:defRPr sz="1500" b="0">
                 <a:solidFill>
-                  <a:srgbClr val="647887"/>
+                  <a:srgbClr val="00355F"/>
                 </a:solidFill>
                 <a:latin typeface="Arial"/>
                 <a:ea typeface="Arial"/>
@@ -7951,7 +7981,7 @@
             <a:r>
               <a:rPr sz="1500" b="0">
                 <a:solidFill>
-                  <a:srgbClr val="647887"/>
+                  <a:srgbClr val="00355F"/>
                 </a:solidFill>
                 <a:latin typeface="Arial"/>
                 <a:ea typeface="Arial"/>
@@ -7968,7 +7998,7 @@
               <a:buNone/>
               <a:defRPr sz="1500" b="0">
                 <a:solidFill>
-                  <a:srgbClr val="647887"/>
+                  <a:srgbClr val="00355F"/>
                 </a:solidFill>
                 <a:latin typeface="Arial"/>
                 <a:ea typeface="Arial"/>
@@ -7978,7 +8008,7 @@
             <a:r>
               <a:rPr sz="1500" b="0">
                 <a:solidFill>
-                  <a:srgbClr val="647887"/>
+                  <a:srgbClr val="00355F"/>
                 </a:solidFill>
                 <a:latin typeface="Arial"/>
                 <a:ea typeface="Arial"/>
@@ -7994,7 +8024,7 @@
           <p:cNvPr id="25" name="">
             <a:extLst xmlns:a="http://schemas.openxmlformats.org/drawingml/2006/main">
               <a:ext uri="{FF2B5EF4-FFF2-40B4-BE49-F238E27FC236}">
-                <a16:creationId xmlns:a16="http://schemas.microsoft.com/office/drawing/2014/main" id="{1A120617-0EF4-481E-BA70-DCE83B5DDFFE}"/>
+                <a16:creationId xmlns:a16="http://schemas.microsoft.com/office/drawing/2014/main" id="{AAC50B55-A49D-426A-9800-CA1136044D96}"/>
               </a:ext>
             </a:extLst>
           </p:cNvPr>
@@ -8014,11 +8044,11 @@
             </a:avLst>
           </a:prstGeom>
           <a:solidFill xmlns:a="http://schemas.openxmlformats.org/drawingml/2006/main">
-            <a:srgbClr val="EAF6F4"/>
+            <a:srgbClr val="EEF6FC"/>
           </a:solidFill>
           <a:ln xmlns:a="http://schemas.openxmlformats.org/drawingml/2006/main" w="9525">
             <a:solidFill>
-              <a:srgbClr val="D7E3E8"/>
+              <a:srgbClr val="A5A5A5"/>
             </a:solidFill>
           </a:ln>
         </p:spPr>
@@ -8028,7 +8058,7 @@
           <p:cNvPr id="26" name="Stage 0: fill data gaps">
             <a:extLst xmlns:a="http://schemas.openxmlformats.org/drawingml/2006/main">
               <a:ext uri="{FF2B5EF4-FFF2-40B4-BE49-F238E27FC236}">
-                <a16:creationId xmlns:a16="http://schemas.microsoft.com/office/drawing/2014/main" id="{26A770B3-E133-4837-BA2A-8627B81EBEAB}"/>
+                <a16:creationId xmlns:a16="http://schemas.microsoft.com/office/drawing/2014/main" id="{F37CECE0-1E71-480C-ADE8-AC76824A2111}"/>
               </a:ext>
             </a:extLst>
           </p:cNvPr>
@@ -8056,7 +8086,7 @@
             <a:defPPr algn="l">
               <a:defRPr sz="1875" b="1">
                 <a:solidFill>
-                  <a:srgbClr val="152C3A"/>
+                  <a:srgbClr val="00355F"/>
                 </a:solidFill>
                 <a:latin typeface="Arial"/>
                 <a:ea typeface="Arial"/>
@@ -8072,7 +8102,7 @@
               <a:buNone/>
               <a:defRPr sz="1875" b="1">
                 <a:solidFill>
-                  <a:srgbClr val="152C3A"/>
+                  <a:srgbClr val="00355F"/>
                 </a:solidFill>
                 <a:latin typeface="Arial"/>
                 <a:ea typeface="Arial"/>
@@ -8082,7 +8112,7 @@
             <a:r>
               <a:rPr sz="1875" b="1">
                 <a:solidFill>
-                  <a:srgbClr val="152C3A"/>
+                  <a:srgbClr val="00355F"/>
                 </a:solidFill>
                 <a:latin typeface="Arial"/>
                 <a:ea typeface="Arial"/>
@@ -8098,7 +8128,7 @@
           <p:cNvPr id="27" name="Add missing assays and biological diversity">
             <a:extLst xmlns:a="http://schemas.openxmlformats.org/drawingml/2006/main">
               <a:ext uri="{FF2B5EF4-FFF2-40B4-BE49-F238E27FC236}">
-                <a16:creationId xmlns:a16="http://schemas.microsoft.com/office/drawing/2014/main" id="{38DAB2C7-D6C5-4848-80A0-EE12930A60FE}"/>
+                <a16:creationId xmlns:a16="http://schemas.microsoft.com/office/drawing/2014/main" id="{00DF510D-932F-4F03-B940-44D52D590902}"/>
               </a:ext>
             </a:extLst>
           </p:cNvPr>
@@ -8126,7 +8156,7 @@
             <a:defPPr algn="l">
               <a:defRPr sz="1500" b="0">
                 <a:solidFill>
-                  <a:srgbClr val="647887"/>
+                  <a:srgbClr val="00355F"/>
                 </a:solidFill>
                 <a:latin typeface="Arial"/>
                 <a:ea typeface="Arial"/>
@@ -8142,7 +8172,7 @@
               <a:buNone/>
               <a:defRPr sz="1500" b="0">
                 <a:solidFill>
-                  <a:srgbClr val="647887"/>
+                  <a:srgbClr val="00355F"/>
                 </a:solidFill>
                 <a:latin typeface="Arial"/>
                 <a:ea typeface="Arial"/>
@@ -8152,7 +8182,7 @@
             <a:r>
               <a:rPr sz="1500" b="0">
                 <a:solidFill>
-                  <a:srgbClr val="647887"/>
+                  <a:srgbClr val="00355F"/>
                 </a:solidFill>
                 <a:latin typeface="Arial"/>
                 <a:ea typeface="Arial"/>
@@ -8169,7 +8199,7 @@
               <a:buNone/>
               <a:defRPr sz="1500" b="0">
                 <a:solidFill>
-                  <a:srgbClr val="647887"/>
+                  <a:srgbClr val="00355F"/>
                 </a:solidFill>
                 <a:latin typeface="Arial"/>
                 <a:ea typeface="Arial"/>
@@ -8179,7 +8209,7 @@
             <a:r>
               <a:rPr sz="1500" b="0">
                 <a:solidFill>
-                  <a:srgbClr val="647887"/>
+                  <a:srgbClr val="00355F"/>
                 </a:solidFill>
                 <a:latin typeface="Arial"/>
                 <a:ea typeface="Arial"/>
@@ -8195,7 +8225,7 @@
           <p:cNvPr id="28" name="">
             <a:extLst xmlns:a="http://schemas.openxmlformats.org/drawingml/2006/main">
               <a:ext uri="{FF2B5EF4-FFF2-40B4-BE49-F238E27FC236}">
-                <a16:creationId xmlns:a16="http://schemas.microsoft.com/office/drawing/2014/main" id="{C236C2E2-EDDE-4C0E-AF4E-F302DEE62ADA}"/>
+                <a16:creationId xmlns:a16="http://schemas.microsoft.com/office/drawing/2014/main" id="{1D2EBAA9-18B6-4C50-8006-C7DA3DEC4468}"/>
               </a:ext>
             </a:extLst>
           </p:cNvPr>
@@ -8219,7 +8249,7 @@
           </a:solidFill>
           <a:ln xmlns:a="http://schemas.openxmlformats.org/drawingml/2006/main" w="9525">
             <a:solidFill>
-              <a:srgbClr val="D7E3E8"/>
+              <a:srgbClr val="A5A5A5"/>
             </a:solidFill>
           </a:ln>
         </p:spPr>
@@ -8229,7 +8259,7 @@
           <p:cNvPr id="29" name="Active learning: measure selectively">
             <a:extLst xmlns:a="http://schemas.openxmlformats.org/drawingml/2006/main">
               <a:ext uri="{FF2B5EF4-FFF2-40B4-BE49-F238E27FC236}">
-                <a16:creationId xmlns:a16="http://schemas.microsoft.com/office/drawing/2014/main" id="{29D212E9-88B7-4E2D-A407-71AC94F7722E}"/>
+                <a16:creationId xmlns:a16="http://schemas.microsoft.com/office/drawing/2014/main" id="{2169A3E4-F9D2-4BAA-95FC-3AD31E154C09}"/>
               </a:ext>
             </a:extLst>
           </p:cNvPr>
@@ -8257,7 +8287,7 @@
             <a:defPPr algn="l">
               <a:defRPr sz="1875" b="1">
                 <a:solidFill>
-                  <a:srgbClr val="152C3A"/>
+                  <a:srgbClr val="00355F"/>
                 </a:solidFill>
                 <a:latin typeface="Arial"/>
                 <a:ea typeface="Arial"/>
@@ -8273,7 +8303,7 @@
               <a:buNone/>
               <a:defRPr sz="1875" b="1">
                 <a:solidFill>
-                  <a:srgbClr val="152C3A"/>
+                  <a:srgbClr val="00355F"/>
                 </a:solidFill>
                 <a:latin typeface="Arial"/>
                 <a:ea typeface="Arial"/>
@@ -8283,7 +8313,7 @@
             <a:r>
               <a:rPr sz="1875" b="1">
                 <a:solidFill>
-                  <a:srgbClr val="152C3A"/>
+                  <a:srgbClr val="00355F"/>
                 </a:solidFill>
                 <a:latin typeface="Arial"/>
                 <a:ea typeface="Arial"/>
@@ -8299,7 +8329,7 @@
           <p:cNvPr id="30" name="Prioritize informative molecules and tests">
             <a:extLst xmlns:a="http://schemas.openxmlformats.org/drawingml/2006/main">
               <a:ext uri="{FF2B5EF4-FFF2-40B4-BE49-F238E27FC236}">
-                <a16:creationId xmlns:a16="http://schemas.microsoft.com/office/drawing/2014/main" id="{24F42A9C-0410-4006-B196-796C6E610AB0}"/>
+                <a16:creationId xmlns:a16="http://schemas.microsoft.com/office/drawing/2014/main" id="{342DC841-F379-4B26-BF11-97B025B3AE52}"/>
               </a:ext>
             </a:extLst>
           </p:cNvPr>
@@ -8327,7 +8357,7 @@
             <a:defPPr algn="l">
               <a:defRPr sz="1500" b="0">
                 <a:solidFill>
-                  <a:srgbClr val="647887"/>
+                  <a:srgbClr val="00355F"/>
                 </a:solidFill>
                 <a:latin typeface="Arial"/>
                 <a:ea typeface="Arial"/>
@@ -8343,7 +8373,7 @@
               <a:buNone/>
               <a:defRPr sz="1500" b="0">
                 <a:solidFill>
-                  <a:srgbClr val="647887"/>
+                  <a:srgbClr val="00355F"/>
                 </a:solidFill>
                 <a:latin typeface="Arial"/>
                 <a:ea typeface="Arial"/>
@@ -8353,7 +8383,7 @@
             <a:r>
               <a:rPr sz="1500" b="0">
                 <a:solidFill>
-                  <a:srgbClr val="647887"/>
+                  <a:srgbClr val="00355F"/>
                 </a:solidFill>
                 <a:latin typeface="Arial"/>
                 <a:ea typeface="Arial"/>
@@ -8370,7 +8400,7 @@
               <a:buNone/>
               <a:defRPr sz="1500" b="0">
                 <a:solidFill>
-                  <a:srgbClr val="647887"/>
+                  <a:srgbClr val="00355F"/>
                 </a:solidFill>
                 <a:latin typeface="Arial"/>
                 <a:ea typeface="Arial"/>
@@ -8380,7 +8410,7 @@
             <a:r>
               <a:rPr sz="1500" b="0">
                 <a:solidFill>
-                  <a:srgbClr val="647887"/>
+                  <a:srgbClr val="00355F"/>
                 </a:solidFill>
                 <a:latin typeface="Arial"/>
                 <a:ea typeface="Arial"/>
@@ -8396,7 +8426,7 @@
           <p:cNvPr id="31" name="">
             <a:extLst xmlns:a="http://schemas.openxmlformats.org/drawingml/2006/main">
               <a:ext uri="{FF2B5EF4-FFF2-40B4-BE49-F238E27FC236}">
-                <a16:creationId xmlns:a16="http://schemas.microsoft.com/office/drawing/2014/main" id="{1A6F14EE-EA3B-426B-8918-D1BC035343E8}"/>
+                <a16:creationId xmlns:a16="http://schemas.microsoft.com/office/drawing/2014/main" id="{D63015C4-A3EF-47D2-9F4B-A97659E14D5A}"/>
               </a:ext>
             </a:extLst>
           </p:cNvPr>
@@ -8416,7 +8446,7 @@
             </a:avLst>
           </a:prstGeom>
           <a:solidFill xmlns:a="http://schemas.openxmlformats.org/drawingml/2006/main">
-            <a:srgbClr val="152C3A"/>
+            <a:srgbClr val="00355F"/>
           </a:solidFill>
           <a:ln xmlns:a="http://schemas.openxmlformats.org/drawingml/2006/main" w="9525">
             <a:noFill/>
@@ -8428,7 +8458,7 @@
           <p:cNvPr id="32" name="">
             <a:extLst xmlns:a="http://schemas.openxmlformats.org/drawingml/2006/main">
               <a:ext uri="{FF2B5EF4-FFF2-40B4-BE49-F238E27FC236}">
-                <a16:creationId xmlns:a16="http://schemas.microsoft.com/office/drawing/2014/main" id="{40D723B3-0283-44C1-A108-588B2A5A8952}"/>
+                <a16:creationId xmlns:a16="http://schemas.microsoft.com/office/drawing/2014/main" id="{4B4FEBA1-CE67-4695-9A2A-2B768F90BC79}"/>
               </a:ext>
             </a:extLst>
           </p:cNvPr>
@@ -8438,10 +8468,10 @@
           <p:nvPr/>
         </p:nvPicPr>
         <p:blipFill>
-          <a:blip xmlns:r="http://schemas.openxmlformats.org/officeDocument/2006/relationships" xmlns:a="http://schemas.openxmlformats.org/drawingml/2006/main" r:embed="R6b477822dc3f431e">
+          <a:blip xmlns:r="http://schemas.openxmlformats.org/officeDocument/2006/relationships" xmlns:a="http://schemas.openxmlformats.org/drawingml/2006/main" r:embed="Ra4428f96641840bb">
             <a:extLst>
               <a:ext uri="{96DAC541-7B7A-43D3-8B79-37D633B846F1}">
-                <asvg:svgBlip xmlns:asvg="http://schemas.microsoft.com/office/drawing/2016/SVG/main" r:embed="R61600107299847b2"/>
+                <asvg:svgBlip xmlns:asvg="http://schemas.microsoft.com/office/drawing/2016/SVG/main" r:embed="R21c6395882364128"/>
               </a:ext>
             </a:extLst>
           </a:blip>
@@ -8462,7 +8492,7 @@
           <p:cNvPr id="33" name="Wet-lab demand depends on funded experiments, assay depth and net tool consumption">
             <a:extLst xmlns:a="http://schemas.openxmlformats.org/drawingml/2006/main">
               <a:ext uri="{FF2B5EF4-FFF2-40B4-BE49-F238E27FC236}">
-                <a16:creationId xmlns:a16="http://schemas.microsoft.com/office/drawing/2014/main" id="{55306093-F141-4133-A995-9C8C399BD38E}"/>
+                <a16:creationId xmlns:a16="http://schemas.microsoft.com/office/drawing/2014/main" id="{5898B350-CCD1-40D1-A8CD-EF9234B954B0}"/>
               </a:ext>
             </a:extLst>
           </p:cNvPr>
@@ -8532,7 +8562,7 @@
           <p:cNvPr id="34" name="Illustrative counts. Nine label types are not nine independent assays; richer data need not come at unchanged cost.">
             <a:extLst xmlns:a="http://schemas.openxmlformats.org/drawingml/2006/main">
               <a:ext uri="{FF2B5EF4-FFF2-40B4-BE49-F238E27FC236}">
-                <a16:creationId xmlns:a16="http://schemas.microsoft.com/office/drawing/2014/main" id="{A3274CA2-6452-4787-80D0-7FC0FA50AADC}"/>
+                <a16:creationId xmlns:a16="http://schemas.microsoft.com/office/drawing/2014/main" id="{6E4A860D-C795-4150-8408-C3D761712053}"/>
               </a:ext>
             </a:extLst>
           </p:cNvPr>
@@ -8560,7 +8590,7 @@
             <a:defPPr algn="l">
               <a:defRPr sz="1275" b="0">
                 <a:solidFill>
-                  <a:srgbClr val="647887"/>
+                  <a:srgbClr val="00355F"/>
                 </a:solidFill>
                 <a:latin typeface="Arial"/>
                 <a:ea typeface="Arial"/>
@@ -8576,7 +8606,7 @@
               <a:buNone/>
               <a:defRPr sz="1275" b="0">
                 <a:solidFill>
-                  <a:srgbClr val="647887"/>
+                  <a:srgbClr val="00355F"/>
                 </a:solidFill>
                 <a:latin typeface="Arial"/>
                 <a:ea typeface="Arial"/>
@@ -8586,7 +8616,7 @@
             <a:r>
               <a:rPr sz="1275" b="0">
                 <a:solidFill>
-                  <a:srgbClr val="647887"/>
+                  <a:srgbClr val="00355F"/>
                 </a:solidFill>
                 <a:latin typeface="Arial"/>
                 <a:ea typeface="Arial"/>
@@ -8602,7 +8632,7 @@
           <p:cNvPr id="35" name="Sources: Jain et al., 2017; Arsiwala et al., 2025; van Niekerk et al., 2026. Mechanism illustration; definitions and links in SOURCES.md.">
             <a:extLst xmlns:a="http://schemas.openxmlformats.org/drawingml/2006/main">
               <a:ext uri="{FF2B5EF4-FFF2-40B4-BE49-F238E27FC236}">
-                <a16:creationId xmlns:a16="http://schemas.microsoft.com/office/drawing/2014/main" id="{BE177730-0D8A-4981-9191-7BEE785F24D7}"/>
+                <a16:creationId xmlns:a16="http://schemas.microsoft.com/office/drawing/2014/main" id="{742913B5-AA67-430A-90AE-CACA78A2D9D8}"/>
               </a:ext>
             </a:extLst>
           </p:cNvPr>
@@ -8630,7 +8660,7 @@
             <a:defPPr algn="l">
               <a:defRPr sz="1163" b="0">
                 <a:solidFill>
-                  <a:srgbClr val="647887"/>
+                  <a:srgbClr val="00355F"/>
                 </a:solidFill>
                 <a:latin typeface="Arial"/>
                 <a:ea typeface="Arial"/>
@@ -8646,7 +8676,7 @@
               <a:buNone/>
               <a:defRPr sz="1163" b="0">
                 <a:solidFill>
-                  <a:srgbClr val="647887"/>
+                  <a:srgbClr val="00355F"/>
                 </a:solidFill>
                 <a:latin typeface="Arial"/>
                 <a:ea typeface="Arial"/>
@@ -8656,7 +8686,7 @@
             <a:r>
               <a:rPr sz="1163" b="0">
                 <a:solidFill>
-                  <a:srgbClr val="647887"/>
+                  <a:srgbClr val="00355F"/>
                 </a:solidFill>
                 <a:latin typeface="Arial"/>
                 <a:ea typeface="Arial"/>
@@ -8670,7 +8700,7 @@
     </p:spTree>
     <p:extLst>
       <p:ext uri="{BB962C8B-B14F-4D97-AF65-F5344CB8AC3E}">
-        <p14:creationId xmlns:p14="http://schemas.microsoft.com/office/powerpoint/2010/main" val="836928103"/>
+        <p14:creationId xmlns:p14="http://schemas.microsoft.com/office/powerpoint/2010/main" val="2138536907"/>
       </p:ext>
     </p:extLst>
   </p:cSld>
@@ -8701,7 +8731,7 @@
           <p:cNvPr id="78" name="">
             <a:extLst xmlns:a="http://schemas.openxmlformats.org/drawingml/2006/main">
               <a:ext uri="{FF2B5EF4-FFF2-40B4-BE49-F238E27FC236}">
-                <a16:creationId xmlns:a16="http://schemas.microsoft.com/office/drawing/2014/main" id="{DB3A2134-841A-45BD-9ED3-EE43EF5FA39D}"/>
+                <a16:creationId xmlns:a16="http://schemas.microsoft.com/office/drawing/2014/main" id="{8A146AF6-5BC4-47D6-8446-2D333B0AF25C}"/>
               </a:ext>
             </a:extLst>
           </p:cNvPr>
@@ -8719,7 +8749,7 @@
             <a:avLst/>
           </a:prstGeom>
           <a:solidFill xmlns:a="http://schemas.openxmlformats.org/drawingml/2006/main">
-            <a:srgbClr val="007D80"/>
+            <a:srgbClr val="00355F"/>
           </a:solidFill>
           <a:ln xmlns:a="http://schemas.openxmlformats.org/drawingml/2006/main" w="9525">
             <a:noFill/>
@@ -8731,7 +8761,7 @@
           <p:cNvPr id="2" name="Experimental data density and the LST ecosystem">
             <a:extLst xmlns:a="http://schemas.openxmlformats.org/drawingml/2006/main">
               <a:ext uri="{FF2B5EF4-FFF2-40B4-BE49-F238E27FC236}">
-                <a16:creationId xmlns:a16="http://schemas.microsoft.com/office/drawing/2014/main" id="{8FB04695-A5C4-4A80-9B1B-E947F92B8097}"/>
+                <a16:creationId xmlns:a16="http://schemas.microsoft.com/office/drawing/2014/main" id="{7A3AE92C-ED72-456C-B04A-121FFF431267}"/>
               </a:ext>
             </a:extLst>
           </p:cNvPr>
@@ -8759,7 +8789,7 @@
             <a:defPPr algn="l">
               <a:defRPr sz="3450" b="1">
                 <a:solidFill>
-                  <a:srgbClr val="152C3A"/>
+                  <a:srgbClr val="00355F"/>
                 </a:solidFill>
                 <a:latin typeface="Arial"/>
                 <a:ea typeface="Arial"/>
@@ -8775,7 +8805,7 @@
               <a:buNone/>
               <a:defRPr sz="3450" b="1">
                 <a:solidFill>
-                  <a:srgbClr val="152C3A"/>
+                  <a:srgbClr val="00355F"/>
                 </a:solidFill>
                 <a:latin typeface="Arial"/>
                 <a:ea typeface="Arial"/>
@@ -8785,7 +8815,7 @@
             <a:r>
               <a:rPr sz="3450" b="1">
                 <a:solidFill>
-                  <a:srgbClr val="152C3A"/>
+                  <a:srgbClr val="00355F"/>
                 </a:solidFill>
                 <a:latin typeface="Arial"/>
                 <a:ea typeface="Arial"/>
@@ -8801,7 +8831,7 @@
           <p:cNvPr id="3" name="Stage 0: biological data production creates a wet-lab use case">
             <a:extLst xmlns:a="http://schemas.openxmlformats.org/drawingml/2006/main">
               <a:ext uri="{FF2B5EF4-FFF2-40B4-BE49-F238E27FC236}">
-                <a16:creationId xmlns:a16="http://schemas.microsoft.com/office/drawing/2014/main" id="{BF206F45-4FE0-4552-AC80-6BF4663CEF9D}"/>
+                <a16:creationId xmlns:a16="http://schemas.microsoft.com/office/drawing/2014/main" id="{AF57FB39-5F66-4F27-9AAF-7AFE3DF06164}"/>
               </a:ext>
             </a:extLst>
           </p:cNvPr>
@@ -8829,7 +8859,7 @@
             <a:defPPr algn="l">
               <a:defRPr sz="2025" b="0">
                 <a:solidFill>
-                  <a:srgbClr val="647887"/>
+                  <a:srgbClr val="00355F"/>
                 </a:solidFill>
                 <a:latin typeface="Arial"/>
                 <a:ea typeface="Arial"/>
@@ -8845,7 +8875,7 @@
               <a:buNone/>
               <a:defRPr sz="2025" b="0">
                 <a:solidFill>
-                  <a:srgbClr val="647887"/>
+                  <a:srgbClr val="00355F"/>
                 </a:solidFill>
                 <a:latin typeface="Arial"/>
                 <a:ea typeface="Arial"/>
@@ -8855,7 +8885,7 @@
             <a:r>
               <a:rPr sz="2025" b="0">
                 <a:solidFill>
-                  <a:srgbClr val="647887"/>
+                  <a:srgbClr val="00355F"/>
                 </a:solidFill>
                 <a:latin typeface="Arial"/>
                 <a:ea typeface="Arial"/>
@@ -8871,7 +8901,7 @@
           <p:cNvPr id="4" name="Learning developability requires comparable assay data and an integrated tool workflow">
             <a:extLst xmlns:a="http://schemas.openxmlformats.org/drawingml/2006/main">
               <a:ext uri="{FF2B5EF4-FFF2-40B4-BE49-F238E27FC236}">
-                <a16:creationId xmlns:a16="http://schemas.microsoft.com/office/drawing/2014/main" id="{B2974318-0FD5-405C-A701-74B774F2AD7F}"/>
+                <a16:creationId xmlns:a16="http://schemas.microsoft.com/office/drawing/2014/main" id="{6AD4DDED-3F33-4C78-B41B-F327D0E16F2E}"/>
               </a:ext>
             </a:extLst>
           </p:cNvPr>
@@ -8899,7 +8929,7 @@
             <a:defPPr algn="l">
               <a:defRPr sz="1575" b="0">
                 <a:solidFill>
-                  <a:srgbClr val="647887"/>
+                  <a:srgbClr val="00355F"/>
                 </a:solidFill>
                 <a:latin typeface="Arial"/>
                 <a:ea typeface="Arial"/>
@@ -8915,7 +8945,7 @@
               <a:buNone/>
               <a:defRPr sz="1575" b="0">
                 <a:solidFill>
-                  <a:srgbClr val="647887"/>
+                  <a:srgbClr val="00355F"/>
                 </a:solidFill>
                 <a:latin typeface="Arial"/>
                 <a:ea typeface="Arial"/>
@@ -8925,7 +8955,7 @@
             <a:r>
               <a:rPr sz="1575" b="0">
                 <a:solidFill>
-                  <a:srgbClr val="647887"/>
+                  <a:srgbClr val="00355F"/>
                 </a:solidFill>
                 <a:latin typeface="Arial"/>
                 <a:ea typeface="Arial"/>
@@ -8941,7 +8971,7 @@
           <p:cNvPr id="5" name="">
             <a:extLst xmlns:a="http://schemas.openxmlformats.org/drawingml/2006/main">
               <a:ext uri="{FF2B5EF4-FFF2-40B4-BE49-F238E27FC236}">
-                <a16:creationId xmlns:a16="http://schemas.microsoft.com/office/drawing/2014/main" id="{D70C267E-925A-4F83-B9C8-138D4CB9CF26}"/>
+                <a16:creationId xmlns:a16="http://schemas.microsoft.com/office/drawing/2014/main" id="{3178CD12-9D11-4861-86F1-7E0EE4AC1180}"/>
               </a:ext>
             </a:extLst>
           </p:cNvPr>
@@ -8970,7 +9000,7 @@
           <a:noFill xmlns:a="http://schemas.openxmlformats.org/drawingml/2006/main"/>
           <a:ln xmlns:a="http://schemas.openxmlformats.org/drawingml/2006/main" w="9525">
             <a:solidFill>
-              <a:srgbClr val="D7E3E8"/>
+              <a:srgbClr val="A5A5A5"/>
             </a:solidFill>
           </a:ln>
         </p:spPr>
@@ -8980,7 +9010,7 @@
           <p:cNvPr id="6" name="">
             <a:extLst xmlns:a="http://schemas.openxmlformats.org/drawingml/2006/main">
               <a:ext uri="{FF2B5EF4-FFF2-40B4-BE49-F238E27FC236}">
-                <a16:creationId xmlns:a16="http://schemas.microsoft.com/office/drawing/2014/main" id="{4C2B3EA7-77C3-4D1C-BC5B-7DACFA0730EC}"/>
+                <a16:creationId xmlns:a16="http://schemas.microsoft.com/office/drawing/2014/main" id="{1B0CDDBC-CF82-434C-BDC9-4DC0FBE3875C}"/>
               </a:ext>
             </a:extLst>
           </p:cNvPr>
@@ -9000,11 +9030,11 @@
             </a:avLst>
           </a:prstGeom>
           <a:solidFill xmlns:a="http://schemas.openxmlformats.org/drawingml/2006/main">
-            <a:srgbClr val="F5F8F9"/>
+            <a:srgbClr val="F4F9FD"/>
           </a:solidFill>
           <a:ln xmlns:a="http://schemas.openxmlformats.org/drawingml/2006/main" w="9525">
             <a:solidFill>
-              <a:srgbClr val="D7E3E8"/>
+              <a:srgbClr val="A5A5A5"/>
             </a:solidFill>
           </a:ln>
         </p:spPr>
@@ -9014,7 +9044,7 @@
           <p:cNvPr id="7" name="Stage 0: biological data production">
             <a:extLst xmlns:a="http://schemas.openxmlformats.org/drawingml/2006/main">
               <a:ext uri="{FF2B5EF4-FFF2-40B4-BE49-F238E27FC236}">
-                <a16:creationId xmlns:a16="http://schemas.microsoft.com/office/drawing/2014/main" id="{A9988D25-A023-461B-A85A-0491E7D10A49}"/>
+                <a16:creationId xmlns:a16="http://schemas.microsoft.com/office/drawing/2014/main" id="{F88A7251-AF0E-4952-AAD0-B45A84BDAC3A}"/>
               </a:ext>
             </a:extLst>
           </p:cNvPr>
@@ -9042,7 +9072,7 @@
             <a:defPPr algn="l">
               <a:defRPr sz="2100" b="1">
                 <a:solidFill>
-                  <a:srgbClr val="152C3A"/>
+                  <a:srgbClr val="00355F"/>
                 </a:solidFill>
                 <a:latin typeface="Arial"/>
                 <a:ea typeface="Arial"/>
@@ -9058,7 +9088,7 @@
               <a:buNone/>
               <a:defRPr sz="2100" b="1">
                 <a:solidFill>
-                  <a:srgbClr val="152C3A"/>
+                  <a:srgbClr val="00355F"/>
                 </a:solidFill>
                 <a:latin typeface="Arial"/>
                 <a:ea typeface="Arial"/>
@@ -9068,7 +9098,7 @@
             <a:r>
               <a:rPr sz="2100" b="1">
                 <a:solidFill>
-                  <a:srgbClr val="152C3A"/>
+                  <a:srgbClr val="00355F"/>
                 </a:solidFill>
                 <a:latin typeface="Arial"/>
                 <a:ea typeface="Arial"/>
@@ -9084,7 +9114,7 @@
           <p:cNvPr id="8" name="Continuous input to training and iteration">
             <a:extLst xmlns:a="http://schemas.openxmlformats.org/drawingml/2006/main">
               <a:ext uri="{FF2B5EF4-FFF2-40B4-BE49-F238E27FC236}">
-                <a16:creationId xmlns:a16="http://schemas.microsoft.com/office/drawing/2014/main" id="{C03CD82C-6B33-46A1-AC4C-E03B8F95D9FF}"/>
+                <a16:creationId xmlns:a16="http://schemas.microsoft.com/office/drawing/2014/main" id="{0CB81708-21DE-41AA-A7CF-D0891E660A84}"/>
               </a:ext>
             </a:extLst>
           </p:cNvPr>
@@ -9112,7 +9142,7 @@
             <a:defPPr algn="l">
               <a:defRPr sz="1500" b="0">
                 <a:solidFill>
-                  <a:srgbClr val="647887"/>
+                  <a:srgbClr val="00355F"/>
                 </a:solidFill>
                 <a:latin typeface="Arial"/>
                 <a:ea typeface="Arial"/>
@@ -9128,7 +9158,7 @@
               <a:buNone/>
               <a:defRPr sz="1500" b="0">
                 <a:solidFill>
-                  <a:srgbClr val="647887"/>
+                  <a:srgbClr val="00355F"/>
                 </a:solidFill>
                 <a:latin typeface="Arial"/>
                 <a:ea typeface="Arial"/>
@@ -9138,7 +9168,7 @@
             <a:r>
               <a:rPr sz="1500" b="0">
                 <a:solidFill>
-                  <a:srgbClr val="647887"/>
+                  <a:srgbClr val="00355F"/>
                 </a:solidFill>
                 <a:latin typeface="Arial"/>
                 <a:ea typeface="Arial"/>
@@ -9154,7 +9184,7 @@
           <p:cNvPr id="9" name="">
             <a:extLst xmlns:a="http://schemas.openxmlformats.org/drawingml/2006/main">
               <a:ext uri="{FF2B5EF4-FFF2-40B4-BE49-F238E27FC236}">
-                <a16:creationId xmlns:a16="http://schemas.microsoft.com/office/drawing/2014/main" id="{BEC32C67-8519-445C-A441-69C63F6C4C0A}"/>
+                <a16:creationId xmlns:a16="http://schemas.microsoft.com/office/drawing/2014/main" id="{54F9313D-829C-45AD-976D-57715DA64423}"/>
               </a:ext>
             </a:extLst>
           </p:cNvPr>
@@ -9174,7 +9204,7 @@
             </a:avLst>
           </a:prstGeom>
           <a:solidFill xmlns:a="http://schemas.openxmlformats.org/drawingml/2006/main">
-            <a:srgbClr val="EAF0FA"/>
+            <a:srgbClr val="EEF6FC"/>
           </a:solidFill>
           <a:ln xmlns:a="http://schemas.openxmlformats.org/drawingml/2006/main" w="9525">
             <a:noFill/>
@@ -9186,7 +9216,7 @@
           <p:cNvPr id="10" name="Binding kinetics">
             <a:extLst xmlns:a="http://schemas.openxmlformats.org/drawingml/2006/main">
               <a:ext uri="{FF2B5EF4-FFF2-40B4-BE49-F238E27FC236}">
-                <a16:creationId xmlns:a16="http://schemas.microsoft.com/office/drawing/2014/main" id="{33911D79-AD08-4A72-B234-BE29C09C1CA7}"/>
+                <a16:creationId xmlns:a16="http://schemas.microsoft.com/office/drawing/2014/main" id="{519F21E6-2178-48AC-A602-8D233D018066}"/>
               </a:ext>
             </a:extLst>
           </p:cNvPr>
@@ -9214,7 +9244,7 @@
             <a:defPPr algn="l">
               <a:defRPr sz="1425" b="0">
                 <a:solidFill>
-                  <a:srgbClr val="647887"/>
+                  <a:srgbClr val="00355F"/>
                 </a:solidFill>
                 <a:latin typeface="Arial"/>
                 <a:ea typeface="Arial"/>
@@ -9230,7 +9260,7 @@
               <a:buNone/>
               <a:defRPr sz="1425" b="0">
                 <a:solidFill>
-                  <a:srgbClr val="647887"/>
+                  <a:srgbClr val="00355F"/>
                 </a:solidFill>
                 <a:latin typeface="Arial"/>
                 <a:ea typeface="Arial"/>
@@ -9240,7 +9270,7 @@
             <a:r>
               <a:rPr sz="1425" b="0">
                 <a:solidFill>
-                  <a:srgbClr val="647887"/>
+                  <a:srgbClr val="00355F"/>
                 </a:solidFill>
                 <a:latin typeface="Arial"/>
                 <a:ea typeface="Arial"/>
@@ -9256,7 +9286,7 @@
           <p:cNvPr id="11" name="KD / kon / koff">
             <a:extLst xmlns:a="http://schemas.openxmlformats.org/drawingml/2006/main">
               <a:ext uri="{FF2B5EF4-FFF2-40B4-BE49-F238E27FC236}">
-                <a16:creationId xmlns:a16="http://schemas.microsoft.com/office/drawing/2014/main" id="{32E8FFE8-87EE-47C4-8927-8B7DDAE332FC}"/>
+                <a16:creationId xmlns:a16="http://schemas.microsoft.com/office/drawing/2014/main" id="{0C56D2DC-969C-4713-865E-861716FE7FCB}"/>
               </a:ext>
             </a:extLst>
           </p:cNvPr>
@@ -9284,7 +9314,7 @@
             <a:defPPr algn="l">
               <a:defRPr sz="1725" b="1">
                 <a:solidFill>
-                  <a:srgbClr val="152C3A"/>
+                  <a:srgbClr val="00355F"/>
                 </a:solidFill>
                 <a:latin typeface="Arial"/>
                 <a:ea typeface="Arial"/>
@@ -9300,7 +9330,7 @@
               <a:buNone/>
               <a:defRPr sz="1725" b="1">
                 <a:solidFill>
-                  <a:srgbClr val="152C3A"/>
+                  <a:srgbClr val="00355F"/>
                 </a:solidFill>
                 <a:latin typeface="Arial"/>
                 <a:ea typeface="Arial"/>
@@ -9310,7 +9340,7 @@
             <a:r>
               <a:rPr sz="1725" b="1">
                 <a:solidFill>
-                  <a:srgbClr val="152C3A"/>
+                  <a:srgbClr val="00355F"/>
                 </a:solidFill>
                 <a:latin typeface="Arial"/>
                 <a:ea typeface="Arial"/>
@@ -9326,7 +9356,7 @@
           <p:cNvPr id="12" name="">
             <a:extLst xmlns:a="http://schemas.openxmlformats.org/drawingml/2006/main">
               <a:ext uri="{FF2B5EF4-FFF2-40B4-BE49-F238E27FC236}">
-                <a16:creationId xmlns:a16="http://schemas.microsoft.com/office/drawing/2014/main" id="{77A2F902-CAD7-4264-9BFC-67203699996C}"/>
+                <a16:creationId xmlns:a16="http://schemas.microsoft.com/office/drawing/2014/main" id="{C6AD0970-C38E-43DE-BB7B-16EC10EC0CF6}"/>
               </a:ext>
             </a:extLst>
           </p:cNvPr>
@@ -9346,7 +9376,7 @@
             </a:avLst>
           </a:prstGeom>
           <a:solidFill xmlns:a="http://schemas.openxmlformats.org/drawingml/2006/main">
-            <a:srgbClr val="EAF6F4"/>
+            <a:srgbClr val="EEF6FC"/>
           </a:solidFill>
           <a:ln xmlns:a="http://schemas.openxmlformats.org/drawingml/2006/main" w="9525">
             <a:noFill/>
@@ -9358,7 +9388,7 @@
           <p:cNvPr id="13" name="Expression &amp; physicochemical properties">
             <a:extLst xmlns:a="http://schemas.openxmlformats.org/drawingml/2006/main">
               <a:ext uri="{FF2B5EF4-FFF2-40B4-BE49-F238E27FC236}">
-                <a16:creationId xmlns:a16="http://schemas.microsoft.com/office/drawing/2014/main" id="{99C18C97-7037-4692-9CC7-16CB2B29F128}"/>
+                <a16:creationId xmlns:a16="http://schemas.microsoft.com/office/drawing/2014/main" id="{D88B308F-B747-481E-997F-25B3180E4227}"/>
               </a:ext>
             </a:extLst>
           </p:cNvPr>
@@ -9386,7 +9416,7 @@
             <a:defPPr algn="l">
               <a:defRPr sz="1425" b="0">
                 <a:solidFill>
-                  <a:srgbClr val="647887"/>
+                  <a:srgbClr val="00355F"/>
                 </a:solidFill>
                 <a:latin typeface="Arial"/>
                 <a:ea typeface="Arial"/>
@@ -9402,7 +9432,7 @@
               <a:buNone/>
               <a:defRPr sz="1425" b="0">
                 <a:solidFill>
-                  <a:srgbClr val="647887"/>
+                  <a:srgbClr val="00355F"/>
                 </a:solidFill>
                 <a:latin typeface="Arial"/>
                 <a:ea typeface="Arial"/>
@@ -9412,7 +9442,7 @@
             <a:r>
               <a:rPr sz="1425" b="0">
                 <a:solidFill>
-                  <a:srgbClr val="647887"/>
+                  <a:srgbClr val="00355F"/>
                 </a:solidFill>
                 <a:latin typeface="Arial"/>
                 <a:ea typeface="Arial"/>
@@ -9428,7 +9458,7 @@
           <p:cNvPr id="14" name="expression / Tm / aggregation">
             <a:extLst xmlns:a="http://schemas.openxmlformats.org/drawingml/2006/main">
               <a:ext uri="{FF2B5EF4-FFF2-40B4-BE49-F238E27FC236}">
-                <a16:creationId xmlns:a16="http://schemas.microsoft.com/office/drawing/2014/main" id="{90E0DD34-1646-4F13-87E6-086081ED16D5}"/>
+                <a16:creationId xmlns:a16="http://schemas.microsoft.com/office/drawing/2014/main" id="{73C57E56-1625-4B07-9F0A-25C69B2BA0F9}"/>
               </a:ext>
             </a:extLst>
           </p:cNvPr>
@@ -9456,7 +9486,7 @@
             <a:defPPr algn="l">
               <a:defRPr sz="1725" b="1">
                 <a:solidFill>
-                  <a:srgbClr val="152C3A"/>
+                  <a:srgbClr val="00355F"/>
                 </a:solidFill>
                 <a:latin typeface="Arial"/>
                 <a:ea typeface="Arial"/>
@@ -9472,7 +9502,7 @@
               <a:buNone/>
               <a:defRPr sz="1725" b="1">
                 <a:solidFill>
-                  <a:srgbClr val="152C3A"/>
+                  <a:srgbClr val="00355F"/>
                 </a:solidFill>
                 <a:latin typeface="Arial"/>
                 <a:ea typeface="Arial"/>
@@ -9482,7 +9512,7 @@
             <a:r>
               <a:rPr sz="1725" b="1">
                 <a:solidFill>
-                  <a:srgbClr val="152C3A"/>
+                  <a:srgbClr val="00355F"/>
                 </a:solidFill>
                 <a:latin typeface="Arial"/>
                 <a:ea typeface="Arial"/>
@@ -9498,7 +9528,7 @@
           <p:cNvPr id="15" name="">
             <a:extLst xmlns:a="http://schemas.openxmlformats.org/drawingml/2006/main">
               <a:ext uri="{FF2B5EF4-FFF2-40B4-BE49-F238E27FC236}">
-                <a16:creationId xmlns:a16="http://schemas.microsoft.com/office/drawing/2014/main" id="{9BE98D0B-D369-48B5-AB3F-04DA2DF3EFE1}"/>
+                <a16:creationId xmlns:a16="http://schemas.microsoft.com/office/drawing/2014/main" id="{E81E970A-F77C-46AA-9C8F-25DB8B7841A6}"/>
               </a:ext>
             </a:extLst>
           </p:cNvPr>
@@ -9518,7 +9548,7 @@
             </a:avLst>
           </a:prstGeom>
           <a:solidFill xmlns:a="http://schemas.openxmlformats.org/drawingml/2006/main">
-            <a:srgbClr val="EAF6F4"/>
+            <a:srgbClr val="EEF6FC"/>
           </a:solidFill>
           <a:ln xmlns:a="http://schemas.openxmlformats.org/drawingml/2006/main" w="9525">
             <a:noFill/>
@@ -9530,7 +9560,7 @@
           <p:cNvPr id="16" name="Specificity &amp; cell function">
             <a:extLst xmlns:a="http://schemas.openxmlformats.org/drawingml/2006/main">
               <a:ext uri="{FF2B5EF4-FFF2-40B4-BE49-F238E27FC236}">
-                <a16:creationId xmlns:a16="http://schemas.microsoft.com/office/drawing/2014/main" id="{D3A5D865-4616-45B6-972B-4F71E90DA8E2}"/>
+                <a16:creationId xmlns:a16="http://schemas.microsoft.com/office/drawing/2014/main" id="{9C55FB2E-2837-4577-8C74-518CB8A1ACF5}"/>
               </a:ext>
             </a:extLst>
           </p:cNvPr>
@@ -9558,7 +9588,7 @@
             <a:defPPr algn="l">
               <a:defRPr sz="1425" b="0">
                 <a:solidFill>
-                  <a:srgbClr val="647887"/>
+                  <a:srgbClr val="00355F"/>
                 </a:solidFill>
                 <a:latin typeface="Arial"/>
                 <a:ea typeface="Arial"/>
@@ -9574,7 +9604,7 @@
               <a:buNone/>
               <a:defRPr sz="1425" b="0">
                 <a:solidFill>
-                  <a:srgbClr val="647887"/>
+                  <a:srgbClr val="00355F"/>
                 </a:solidFill>
                 <a:latin typeface="Arial"/>
                 <a:ea typeface="Arial"/>
@@ -9584,7 +9614,7 @@
             <a:r>
               <a:rPr sz="1425" b="0">
                 <a:solidFill>
-                  <a:srgbClr val="647887"/>
+                  <a:srgbClr val="00355F"/>
                 </a:solidFill>
                 <a:latin typeface="Arial"/>
                 <a:ea typeface="Arial"/>
@@ -9600,7 +9630,7 @@
           <p:cNvPr id="17" name="polyreactivity / epitope / cell potency">
             <a:extLst xmlns:a="http://schemas.openxmlformats.org/drawingml/2006/main">
               <a:ext uri="{FF2B5EF4-FFF2-40B4-BE49-F238E27FC236}">
-                <a16:creationId xmlns:a16="http://schemas.microsoft.com/office/drawing/2014/main" id="{69126347-73C3-4A3C-A4D8-27926757336B}"/>
+                <a16:creationId xmlns:a16="http://schemas.microsoft.com/office/drawing/2014/main" id="{A9388E49-DB74-4791-9E8B-1F448DEFD8AC}"/>
               </a:ext>
             </a:extLst>
           </p:cNvPr>
@@ -9628,7 +9658,7 @@
             <a:defPPr algn="l">
               <a:defRPr sz="1500" b="1">
                 <a:solidFill>
-                  <a:srgbClr val="152C3A"/>
+                  <a:srgbClr val="00355F"/>
                 </a:solidFill>
                 <a:latin typeface="Arial"/>
                 <a:ea typeface="Arial"/>
@@ -9644,7 +9674,7 @@
               <a:buNone/>
               <a:defRPr sz="1500" b="1">
                 <a:solidFill>
-                  <a:srgbClr val="152C3A"/>
+                  <a:srgbClr val="00355F"/>
                 </a:solidFill>
                 <a:latin typeface="Arial"/>
                 <a:ea typeface="Arial"/>
@@ -9654,7 +9684,7 @@
             <a:r>
               <a:rPr sz="1500" b="1">
                 <a:solidFill>
-                  <a:srgbClr val="152C3A"/>
+                  <a:srgbClr val="00355F"/>
                 </a:solidFill>
                 <a:latin typeface="Arial"/>
                 <a:ea typeface="Arial"/>
@@ -9670,7 +9700,7 @@
           <p:cNvPr id="18" name="Training records: sequence, target, conditions,">
             <a:extLst xmlns:a="http://schemas.openxmlformats.org/drawingml/2006/main">
               <a:ext uri="{FF2B5EF4-FFF2-40B4-BE49-F238E27FC236}">
-                <a16:creationId xmlns:a16="http://schemas.microsoft.com/office/drawing/2014/main" id="{3D319FB1-D010-497F-8CB0-69A9935D547E}"/>
+                <a16:creationId xmlns:a16="http://schemas.microsoft.com/office/drawing/2014/main" id="{8EDD4EC2-81F3-46BF-B417-CD1AFFF79A21}"/>
               </a:ext>
             </a:extLst>
           </p:cNvPr>
@@ -9698,7 +9728,7 @@
             <a:defPPr algn="l">
               <a:defRPr sz="1425" b="0">
                 <a:solidFill>
-                  <a:srgbClr val="647887"/>
+                  <a:srgbClr val="00355F"/>
                 </a:solidFill>
                 <a:latin typeface="Arial"/>
                 <a:ea typeface="Arial"/>
@@ -9714,7 +9744,7 @@
               <a:buNone/>
               <a:defRPr sz="1425" b="0">
                 <a:solidFill>
-                  <a:srgbClr val="647887"/>
+                  <a:srgbClr val="00355F"/>
                 </a:solidFill>
                 <a:latin typeface="Arial"/>
                 <a:ea typeface="Arial"/>
@@ -9724,7 +9754,7 @@
             <a:r>
               <a:rPr sz="1425" b="0">
                 <a:solidFill>
-                  <a:srgbClr val="647887"/>
+                  <a:srgbClr val="00355F"/>
                 </a:solidFill>
                 <a:latin typeface="Arial"/>
                 <a:ea typeface="Arial"/>
@@ -9741,7 +9771,7 @@
               <a:buNone/>
               <a:defRPr sz="1425" b="0">
                 <a:solidFill>
-                  <a:srgbClr val="647887"/>
+                  <a:srgbClr val="00355F"/>
                 </a:solidFill>
                 <a:latin typeface="Arial"/>
                 <a:ea typeface="Arial"/>
@@ -9751,7 +9781,7 @@
             <a:r>
               <a:rPr sz="1425" b="0">
                 <a:solidFill>
-                  <a:srgbClr val="647887"/>
+                  <a:srgbClr val="00355F"/>
                 </a:solidFill>
                 <a:latin typeface="Arial"/>
                 <a:ea typeface="Arial"/>
@@ -9767,7 +9797,7 @@
           <p:cNvPr id="19" name="">
             <a:extLst xmlns:a="http://schemas.openxmlformats.org/drawingml/2006/main">
               <a:ext uri="{FF2B5EF4-FFF2-40B4-BE49-F238E27FC236}">
-                <a16:creationId xmlns:a16="http://schemas.microsoft.com/office/drawing/2014/main" id="{DCE12F8D-EF81-4EE3-9C9E-086846313D15}"/>
+                <a16:creationId xmlns:a16="http://schemas.microsoft.com/office/drawing/2014/main" id="{97C0FDDA-4810-42D0-AE90-166668EEAD62}"/>
               </a:ext>
             </a:extLst>
           </p:cNvPr>
@@ -9791,7 +9821,7 @@
           </a:solidFill>
           <a:ln xmlns:a="http://schemas.openxmlformats.org/drawingml/2006/main" w="9525">
             <a:solidFill>
-              <a:srgbClr val="D7E3E8"/>
+              <a:srgbClr val="A5A5A5"/>
             </a:solidFill>
           </a:ln>
         </p:spPr>
@@ -9801,7 +9831,7 @@
           <p:cNvPr id="20" name="">
             <a:extLst xmlns:a="http://schemas.openxmlformats.org/drawingml/2006/main">
               <a:ext uri="{FF2B5EF4-FFF2-40B4-BE49-F238E27FC236}">
-                <a16:creationId xmlns:a16="http://schemas.microsoft.com/office/drawing/2014/main" id="{BCDDCB4A-E4D9-4201-B599-0FC960E64BAF}"/>
+                <a16:creationId xmlns:a16="http://schemas.microsoft.com/office/drawing/2014/main" id="{D63AFB2A-0785-495D-AC67-2ADBEB672D8A}"/>
               </a:ext>
             </a:extLst>
           </p:cNvPr>
@@ -9825,7 +9855,7 @@
           </a:solidFill>
           <a:ln xmlns:a="http://schemas.openxmlformats.org/drawingml/2006/main" w="9525">
             <a:solidFill>
-              <a:srgbClr val="D7E3E8"/>
+              <a:srgbClr val="A5A5A5"/>
             </a:solidFill>
           </a:ln>
         </p:spPr>
@@ -9835,7 +9865,7 @@
           <p:cNvPr id="21" name="Train / improve">
             <a:extLst xmlns:a="http://schemas.openxmlformats.org/drawingml/2006/main">
               <a:ext uri="{FF2B5EF4-FFF2-40B4-BE49-F238E27FC236}">
-                <a16:creationId xmlns:a16="http://schemas.microsoft.com/office/drawing/2014/main" id="{A5428438-7798-4109-A375-9B7FEC892134}"/>
+                <a16:creationId xmlns:a16="http://schemas.microsoft.com/office/drawing/2014/main" id="{7AD1A853-37EA-4CFF-AD3F-B0A5CB775028}"/>
               </a:ext>
             </a:extLst>
           </p:cNvPr>
@@ -9863,7 +9893,7 @@
             <a:defPPr algn="ctr">
               <a:defRPr sz="1650" b="1">
                 <a:solidFill>
-                  <a:srgbClr val="152C3A"/>
+                  <a:srgbClr val="00355F"/>
                 </a:solidFill>
                 <a:latin typeface="Arial"/>
                 <a:ea typeface="Arial"/>
@@ -9879,7 +9909,7 @@
               <a:buNone/>
               <a:defRPr sz="1650" b="1">
                 <a:solidFill>
-                  <a:srgbClr val="152C3A"/>
+                  <a:srgbClr val="00355F"/>
                 </a:solidFill>
                 <a:latin typeface="Arial"/>
                 <a:ea typeface="Arial"/>
@@ -9889,7 +9919,7 @@
             <a:r>
               <a:rPr sz="1650" b="1">
                 <a:solidFill>
-                  <a:srgbClr val="152C3A"/>
+                  <a:srgbClr val="00355F"/>
                 </a:solidFill>
                 <a:latin typeface="Arial"/>
                 <a:ea typeface="Arial"/>
@@ -9905,7 +9935,7 @@
           <p:cNvPr id="22" name="Design / validate">
             <a:extLst xmlns:a="http://schemas.openxmlformats.org/drawingml/2006/main">
               <a:ext uri="{FF2B5EF4-FFF2-40B4-BE49-F238E27FC236}">
-                <a16:creationId xmlns:a16="http://schemas.microsoft.com/office/drawing/2014/main" id="{DC85D5B1-A1B4-495D-9DC7-415C174E31D5}"/>
+                <a16:creationId xmlns:a16="http://schemas.microsoft.com/office/drawing/2014/main" id="{E9E12D42-4C81-4696-8B77-1BE3F41992D1}"/>
               </a:ext>
             </a:extLst>
           </p:cNvPr>
@@ -9933,7 +9963,7 @@
             <a:defPPr algn="ctr">
               <a:defRPr sz="1650" b="1">
                 <a:solidFill>
-                  <a:srgbClr val="152C3A"/>
+                  <a:srgbClr val="00355F"/>
                 </a:solidFill>
                 <a:latin typeface="Arial"/>
                 <a:ea typeface="Arial"/>
@@ -9949,7 +9979,7 @@
               <a:buNone/>
               <a:defRPr sz="1650" b="1">
                 <a:solidFill>
-                  <a:srgbClr val="152C3A"/>
+                  <a:srgbClr val="00355F"/>
                 </a:solidFill>
                 <a:latin typeface="Arial"/>
                 <a:ea typeface="Arial"/>
@@ -9959,7 +9989,7 @@
             <a:r>
               <a:rPr sz="1650" b="1">
                 <a:solidFill>
-                  <a:srgbClr val="152C3A"/>
+                  <a:srgbClr val="00355F"/>
                 </a:solidFill>
                 <a:latin typeface="Arial"/>
                 <a:ea typeface="Arial"/>
@@ -9975,7 +10005,7 @@
           <p:cNvPr id="23" name="">
             <a:extLst xmlns:a="http://schemas.openxmlformats.org/drawingml/2006/main">
               <a:ext uri="{FF2B5EF4-FFF2-40B4-BE49-F238E27FC236}">
-                <a16:creationId xmlns:a16="http://schemas.microsoft.com/office/drawing/2014/main" id="{8EFA9706-1474-4880-AF4B-444DD7B770F0}"/>
+                <a16:creationId xmlns:a16="http://schemas.microsoft.com/office/drawing/2014/main" id="{5B81C497-7425-4B04-AC41-E6D816D71C8E}"/>
               </a:ext>
             </a:extLst>
           </p:cNvPr>
@@ -10004,7 +10034,7 @@
           <a:noFill xmlns:a="http://schemas.openxmlformats.org/drawingml/2006/main"/>
           <a:ln xmlns:a="http://schemas.openxmlformats.org/drawingml/2006/main" w="19050">
             <a:solidFill>
-              <a:srgbClr val="007D80"/>
+              <a:srgbClr val="00355F"/>
             </a:solidFill>
           </a:ln>
         </p:spPr>
@@ -10014,7 +10044,7 @@
           <p:cNvPr id="24" name="">
             <a:extLst xmlns:a="http://schemas.openxmlformats.org/drawingml/2006/main">
               <a:ext uri="{FF2B5EF4-FFF2-40B4-BE49-F238E27FC236}">
-                <a16:creationId xmlns:a16="http://schemas.microsoft.com/office/drawing/2014/main" id="{316931B3-4315-46AC-9C33-29C4523BFB18}"/>
+                <a16:creationId xmlns:a16="http://schemas.microsoft.com/office/drawing/2014/main" id="{17FAE9EA-FAB9-4D4B-9BE0-D975B0545A42}"/>
               </a:ext>
             </a:extLst>
           </p:cNvPr>
@@ -10045,7 +10075,7 @@
             </a:pathLst>
           </a:custGeom>
           <a:solidFill xmlns:a="http://schemas.openxmlformats.org/drawingml/2006/main">
-            <a:srgbClr val="007D80"/>
+            <a:srgbClr val="00355F"/>
           </a:solidFill>
           <a:ln xmlns:a="http://schemas.openxmlformats.org/drawingml/2006/main" w="9525">
             <a:noFill/>
@@ -10057,7 +10087,7 @@
           <p:cNvPr id="25" name="">
             <a:extLst xmlns:a="http://schemas.openxmlformats.org/drawingml/2006/main">
               <a:ext uri="{FF2B5EF4-FFF2-40B4-BE49-F238E27FC236}">
-                <a16:creationId xmlns:a16="http://schemas.microsoft.com/office/drawing/2014/main" id="{2304E537-A76C-435A-87E8-8DB42EE6782F}"/>
+                <a16:creationId xmlns:a16="http://schemas.microsoft.com/office/drawing/2014/main" id="{61793ED1-AE04-4538-9FF4-56DBDF62464C}"/>
               </a:ext>
             </a:extLst>
           </p:cNvPr>
@@ -10086,7 +10116,7 @@
           <a:noFill xmlns:a="http://schemas.openxmlformats.org/drawingml/2006/main"/>
           <a:ln xmlns:a="http://schemas.openxmlformats.org/drawingml/2006/main" w="14288">
             <a:solidFill>
-              <a:srgbClr val="007D80"/>
+              <a:srgbClr val="00355F"/>
             </a:solidFill>
           </a:ln>
         </p:spPr>
@@ -10096,7 +10126,7 @@
           <p:cNvPr id="26" name="">
             <a:extLst xmlns:a="http://schemas.openxmlformats.org/drawingml/2006/main">
               <a:ext uri="{FF2B5EF4-FFF2-40B4-BE49-F238E27FC236}">
-                <a16:creationId xmlns:a16="http://schemas.microsoft.com/office/drawing/2014/main" id="{9DF921B6-546F-4A15-8D36-EF2004B4D01E}"/>
+                <a16:creationId xmlns:a16="http://schemas.microsoft.com/office/drawing/2014/main" id="{C5A4A880-E8F1-4CDE-9C39-E37FE68D7EE8}"/>
               </a:ext>
             </a:extLst>
           </p:cNvPr>
@@ -10125,7 +10155,7 @@
           <a:noFill xmlns:a="http://schemas.openxmlformats.org/drawingml/2006/main"/>
           <a:ln xmlns:a="http://schemas.openxmlformats.org/drawingml/2006/main" w="14288">
             <a:solidFill>
-              <a:srgbClr val="007D80"/>
+              <a:srgbClr val="00355F"/>
             </a:solidFill>
           </a:ln>
         </p:spPr>
@@ -10135,7 +10165,7 @@
           <p:cNvPr id="27" name="">
             <a:extLst xmlns:a="http://schemas.openxmlformats.org/drawingml/2006/main">
               <a:ext uri="{FF2B5EF4-FFF2-40B4-BE49-F238E27FC236}">
-                <a16:creationId xmlns:a16="http://schemas.microsoft.com/office/drawing/2014/main" id="{B9D08FFE-8D0F-4379-BC56-1FFA9FE92443}"/>
+                <a16:creationId xmlns:a16="http://schemas.microsoft.com/office/drawing/2014/main" id="{43453E81-B5E6-412A-8A16-A8673873B3E4}"/>
               </a:ext>
             </a:extLst>
           </p:cNvPr>
@@ -10164,7 +10194,7 @@
           <a:noFill xmlns:a="http://schemas.openxmlformats.org/drawingml/2006/main"/>
           <a:ln xmlns:a="http://schemas.openxmlformats.org/drawingml/2006/main" w="14288">
             <a:solidFill>
-              <a:srgbClr val="007D80"/>
+              <a:srgbClr val="00355F"/>
             </a:solidFill>
           </a:ln>
         </p:spPr>
@@ -10174,7 +10204,7 @@
           <p:cNvPr id="28" name="">
             <a:extLst xmlns:a="http://schemas.openxmlformats.org/drawingml/2006/main">
               <a:ext uri="{FF2B5EF4-FFF2-40B4-BE49-F238E27FC236}">
-                <a16:creationId xmlns:a16="http://schemas.microsoft.com/office/drawing/2014/main" id="{07B79A67-31B3-4050-BAD4-581AACBD3494}"/>
+                <a16:creationId xmlns:a16="http://schemas.microsoft.com/office/drawing/2014/main" id="{C820AACC-E3C2-47AC-9298-05E49A2465AC}"/>
               </a:ext>
             </a:extLst>
           </p:cNvPr>
@@ -10205,7 +10235,7 @@
             </a:pathLst>
           </a:custGeom>
           <a:solidFill xmlns:a="http://schemas.openxmlformats.org/drawingml/2006/main">
-            <a:srgbClr val="007D80"/>
+            <a:srgbClr val="00355F"/>
           </a:solidFill>
           <a:ln xmlns:a="http://schemas.openxmlformats.org/drawingml/2006/main" w="9525">
             <a:noFill/>
@@ -10217,7 +10247,7 @@
           <p:cNvPr id="29" name="">
             <a:extLst xmlns:a="http://schemas.openxmlformats.org/drawingml/2006/main">
               <a:ext uri="{FF2B5EF4-FFF2-40B4-BE49-F238E27FC236}">
-                <a16:creationId xmlns:a16="http://schemas.microsoft.com/office/drawing/2014/main" id="{F643CA1B-FE95-4069-992E-F1DDC8E87B80}"/>
+                <a16:creationId xmlns:a16="http://schemas.microsoft.com/office/drawing/2014/main" id="{B01A163D-D691-40AB-82B3-D8DCB63A0A8B}"/>
               </a:ext>
             </a:extLst>
           </p:cNvPr>
@@ -10235,7 +10265,7 @@
             <a:avLst/>
           </a:prstGeom>
           <a:solidFill xmlns:a="http://schemas.openxmlformats.org/drawingml/2006/main">
-            <a:srgbClr val="F5F8F9"/>
+            <a:srgbClr val="F4F9FD"/>
           </a:solidFill>
           <a:ln xmlns:a="http://schemas.openxmlformats.org/drawingml/2006/main" w="9525">
             <a:noFill/>
@@ -10247,7 +10277,7 @@
           <p:cNvPr id="30" name="Assays inform models">
             <a:extLst xmlns:a="http://schemas.openxmlformats.org/drawingml/2006/main">
               <a:ext uri="{FF2B5EF4-FFF2-40B4-BE49-F238E27FC236}">
-                <a16:creationId xmlns:a16="http://schemas.microsoft.com/office/drawing/2014/main" id="{6D28A19C-055C-4B13-AEF3-BA0994142333}"/>
+                <a16:creationId xmlns:a16="http://schemas.microsoft.com/office/drawing/2014/main" id="{1C924804-3673-4398-8AA5-6FE938B973D7}"/>
               </a:ext>
             </a:extLst>
           </p:cNvPr>
@@ -10275,7 +10305,7 @@
             <a:defPPr algn="ctr">
               <a:defRPr sz="1350" b="0">
                 <a:solidFill>
-                  <a:srgbClr val="007D80"/>
+                  <a:srgbClr val="00355F"/>
                 </a:solidFill>
                 <a:latin typeface="Arial"/>
                 <a:ea typeface="Arial"/>
@@ -10291,7 +10321,7 @@
               <a:buNone/>
               <a:defRPr sz="1350" b="0">
                 <a:solidFill>
-                  <a:srgbClr val="007D80"/>
+                  <a:srgbClr val="00355F"/>
                 </a:solidFill>
                 <a:latin typeface="Arial"/>
                 <a:ea typeface="Arial"/>
@@ -10301,7 +10331,7 @@
             <a:r>
               <a:rPr sz="1350" b="0">
                 <a:solidFill>
-                  <a:srgbClr val="007D80"/>
+                  <a:srgbClr val="00355F"/>
                 </a:solidFill>
                 <a:latin typeface="Arial"/>
                 <a:ea typeface="Arial"/>
@@ -10317,7 +10347,7 @@
           <p:cNvPr id="31" name="">
             <a:extLst xmlns:a="http://schemas.openxmlformats.org/drawingml/2006/main">
               <a:ext uri="{FF2B5EF4-FFF2-40B4-BE49-F238E27FC236}">
-                <a16:creationId xmlns:a16="http://schemas.microsoft.com/office/drawing/2014/main" id="{007ABB00-F085-46FB-85CB-181C6E4EAD96}"/>
+                <a16:creationId xmlns:a16="http://schemas.microsoft.com/office/drawing/2014/main" id="{7522FB1D-B88D-4BC5-92F4-B76CB6B0D830}"/>
               </a:ext>
             </a:extLst>
           </p:cNvPr>
@@ -10346,7 +10376,7 @@
           <a:noFill xmlns:a="http://schemas.openxmlformats.org/drawingml/2006/main"/>
           <a:ln xmlns:a="http://schemas.openxmlformats.org/drawingml/2006/main" w="21908">
             <a:solidFill>
-              <a:srgbClr val="007D80"/>
+              <a:srgbClr val="00355F"/>
             </a:solidFill>
           </a:ln>
         </p:spPr>
@@ -10356,7 +10386,7 @@
           <p:cNvPr id="32" name="">
             <a:extLst xmlns:a="http://schemas.openxmlformats.org/drawingml/2006/main">
               <a:ext uri="{FF2B5EF4-FFF2-40B4-BE49-F238E27FC236}">
-                <a16:creationId xmlns:a16="http://schemas.microsoft.com/office/drawing/2014/main" id="{B387C342-9DA8-459C-B55D-739B80FBE061}"/>
+                <a16:creationId xmlns:a16="http://schemas.microsoft.com/office/drawing/2014/main" id="{45A2FDD4-DD8B-4D65-ADCD-F2418427DC5B}"/>
               </a:ext>
             </a:extLst>
           </p:cNvPr>
@@ -10385,7 +10415,7 @@
           <a:noFill xmlns:a="http://schemas.openxmlformats.org/drawingml/2006/main"/>
           <a:ln xmlns:a="http://schemas.openxmlformats.org/drawingml/2006/main" w="21908">
             <a:solidFill>
-              <a:srgbClr val="007D80"/>
+              <a:srgbClr val="00355F"/>
             </a:solidFill>
           </a:ln>
         </p:spPr>
@@ -10395,7 +10425,7 @@
           <p:cNvPr id="33" name="">
             <a:extLst xmlns:a="http://schemas.openxmlformats.org/drawingml/2006/main">
               <a:ext uri="{FF2B5EF4-FFF2-40B4-BE49-F238E27FC236}">
-                <a16:creationId xmlns:a16="http://schemas.microsoft.com/office/drawing/2014/main" id="{6F2DF4A3-5DEE-42DF-9E5B-9CB4B4207CA8}"/>
+                <a16:creationId xmlns:a16="http://schemas.microsoft.com/office/drawing/2014/main" id="{022D896C-5F3B-4B7B-A768-8B4A80721EBE}"/>
               </a:ext>
             </a:extLst>
           </p:cNvPr>
@@ -10424,7 +10454,7 @@
           <a:noFill xmlns:a="http://schemas.openxmlformats.org/drawingml/2006/main"/>
           <a:ln xmlns:a="http://schemas.openxmlformats.org/drawingml/2006/main" w="21908">
             <a:solidFill>
-              <a:srgbClr val="007D80"/>
+              <a:srgbClr val="00355F"/>
             </a:solidFill>
           </a:ln>
         </p:spPr>
@@ -10434,7 +10464,7 @@
           <p:cNvPr id="34" name="">
             <a:extLst xmlns:a="http://schemas.openxmlformats.org/drawingml/2006/main">
               <a:ext uri="{FF2B5EF4-FFF2-40B4-BE49-F238E27FC236}">
-                <a16:creationId xmlns:a16="http://schemas.microsoft.com/office/drawing/2014/main" id="{A6DA14B6-93AF-49E0-98A7-4606E73E6179}"/>
+                <a16:creationId xmlns:a16="http://schemas.microsoft.com/office/drawing/2014/main" id="{0952CBCE-3A04-4051-89CF-6513E0A7775F}"/>
               </a:ext>
             </a:extLst>
           </p:cNvPr>
@@ -10468,7 +10498,7 @@
             </a:pathLst>
           </a:custGeom>
           <a:solidFill xmlns:a="http://schemas.openxmlformats.org/drawingml/2006/main">
-            <a:srgbClr val="F4FAF9"/>
+            <a:srgbClr val="F4F9FD"/>
           </a:solidFill>
           <a:ln xmlns:a="http://schemas.openxmlformats.org/drawingml/2006/main" w="9525">
             <a:noFill/>
@@ -10480,7 +10510,7 @@
           <p:cNvPr id="35" name="">
             <a:extLst xmlns:a="http://schemas.openxmlformats.org/drawingml/2006/main">
               <a:ext uri="{FF2B5EF4-FFF2-40B4-BE49-F238E27FC236}">
-                <a16:creationId xmlns:a16="http://schemas.microsoft.com/office/drawing/2014/main" id="{6967E7A7-D33E-4AD0-916C-F590851F3130}"/>
+                <a16:creationId xmlns:a16="http://schemas.microsoft.com/office/drawing/2014/main" id="{F36D0E8D-ED3B-48B9-8C1D-6AD4951E31BA}"/>
               </a:ext>
             </a:extLst>
           </p:cNvPr>
@@ -10509,7 +10539,7 @@
           <a:noFill xmlns:a="http://schemas.openxmlformats.org/drawingml/2006/main"/>
           <a:ln xmlns:a="http://schemas.openxmlformats.org/drawingml/2006/main" w="13335">
             <a:solidFill>
-              <a:srgbClr val="8EBDB7"/>
+              <a:srgbClr val="7399C6"/>
             </a:solidFill>
           </a:ln>
         </p:spPr>
@@ -10519,7 +10549,7 @@
           <p:cNvPr id="36" name="">
             <a:extLst xmlns:a="http://schemas.openxmlformats.org/drawingml/2006/main">
               <a:ext uri="{FF2B5EF4-FFF2-40B4-BE49-F238E27FC236}">
-                <a16:creationId xmlns:a16="http://schemas.microsoft.com/office/drawing/2014/main" id="{55A24E4D-5114-4D8D-9AB2-E377CEC57F4F}"/>
+                <a16:creationId xmlns:a16="http://schemas.microsoft.com/office/drawing/2014/main" id="{0F2EF029-6E6C-4844-91E4-E15E570783D8}"/>
               </a:ext>
             </a:extLst>
           </p:cNvPr>
@@ -10548,7 +10578,7 @@
           <a:noFill xmlns:a="http://schemas.openxmlformats.org/drawingml/2006/main"/>
           <a:ln xmlns:a="http://schemas.openxmlformats.org/drawingml/2006/main" w="13335">
             <a:solidFill>
-              <a:srgbClr val="8EBDB7"/>
+              <a:srgbClr val="7399C6"/>
             </a:solidFill>
           </a:ln>
         </p:spPr>
@@ -10558,7 +10588,7 @@
           <p:cNvPr id="37" name="">
             <a:extLst xmlns:a="http://schemas.openxmlformats.org/drawingml/2006/main">
               <a:ext uri="{FF2B5EF4-FFF2-40B4-BE49-F238E27FC236}">
-                <a16:creationId xmlns:a16="http://schemas.microsoft.com/office/drawing/2014/main" id="{3725CA94-EACD-4E38-ADE5-C637D7762BF3}"/>
+                <a16:creationId xmlns:a16="http://schemas.microsoft.com/office/drawing/2014/main" id="{53065982-7680-43E1-978D-909E31CE17F7}"/>
               </a:ext>
             </a:extLst>
           </p:cNvPr>
@@ -10578,11 +10608,11 @@
             </a:avLst>
           </a:prstGeom>
           <a:solidFill xmlns:a="http://schemas.openxmlformats.org/drawingml/2006/main">
-            <a:srgbClr val="F8FBFC"/>
+            <a:srgbClr val="F4F9FD"/>
           </a:solidFill>
           <a:ln xmlns:a="http://schemas.openxmlformats.org/drawingml/2006/main" w="9525">
             <a:solidFill>
-              <a:srgbClr val="D7E3E8"/>
+              <a:srgbClr val="A5A5A5"/>
             </a:solidFill>
           </a:ln>
         </p:spPr>
@@ -10592,7 +10622,7 @@
           <p:cNvPr id="38" name="Labels → assays → purchases">
             <a:extLst xmlns:a="http://schemas.openxmlformats.org/drawingml/2006/main">
               <a:ext uri="{FF2B5EF4-FFF2-40B4-BE49-F238E27FC236}">
-                <a16:creationId xmlns:a16="http://schemas.microsoft.com/office/drawing/2014/main" id="{9A7001DE-D74A-490D-9334-74DE659A98D7}"/>
+                <a16:creationId xmlns:a16="http://schemas.microsoft.com/office/drawing/2014/main" id="{91C4A504-0760-46C5-84B7-9073896CC036}"/>
               </a:ext>
             </a:extLst>
           </p:cNvPr>
@@ -10620,7 +10650,7 @@
             <a:defPPr algn="l">
               <a:defRPr sz="2100" b="1">
                 <a:solidFill>
-                  <a:srgbClr val="152C3A"/>
+                  <a:srgbClr val="00355F"/>
                 </a:solidFill>
                 <a:latin typeface="Arial"/>
                 <a:ea typeface="Arial"/>
@@ -10636,7 +10666,7 @@
               <a:buNone/>
               <a:defRPr sz="2100" b="1">
                 <a:solidFill>
-                  <a:srgbClr val="152C3A"/>
+                  <a:srgbClr val="00355F"/>
                 </a:solidFill>
                 <a:latin typeface="Arial"/>
                 <a:ea typeface="Arial"/>
@@ -10646,7 +10676,7 @@
             <a:r>
               <a:rPr sz="2100" b="1">
                 <a:solidFill>
-                  <a:srgbClr val="152C3A"/>
+                  <a:srgbClr val="00355F"/>
                 </a:solidFill>
                 <a:latin typeface="Arial"/>
                 <a:ea typeface="Arial"/>
@@ -10662,7 +10692,7 @@
           <p:cNvPr id="39" name="Tool revenue needs a bridge from label coverage to workflow volume and unit consumption">
             <a:extLst xmlns:a="http://schemas.openxmlformats.org/drawingml/2006/main">
               <a:ext uri="{FF2B5EF4-FFF2-40B4-BE49-F238E27FC236}">
-                <a16:creationId xmlns:a16="http://schemas.microsoft.com/office/drawing/2014/main" id="{1AD7AE2B-C59C-48C9-A1D0-9F4E8DB987D2}"/>
+                <a16:creationId xmlns:a16="http://schemas.microsoft.com/office/drawing/2014/main" id="{4AC87B5E-ADDE-4C9D-86A1-63698CCAC0CD}"/>
               </a:ext>
             </a:extLst>
           </p:cNvPr>
@@ -10690,7 +10720,7 @@
             <a:defPPr algn="l">
               <a:defRPr sz="1350" b="0">
                 <a:solidFill>
-                  <a:srgbClr val="647887"/>
+                  <a:srgbClr val="00355F"/>
                 </a:solidFill>
                 <a:latin typeface="Arial"/>
                 <a:ea typeface="Arial"/>
@@ -10706,7 +10736,7 @@
               <a:buNone/>
               <a:defRPr sz="1350" b="0">
                 <a:solidFill>
-                  <a:srgbClr val="647887"/>
+                  <a:srgbClr val="00355F"/>
                 </a:solidFill>
                 <a:latin typeface="Arial"/>
                 <a:ea typeface="Arial"/>
@@ -10716,7 +10746,7 @@
             <a:r>
               <a:rPr sz="1350" b="0">
                 <a:solidFill>
-                  <a:srgbClr val="647887"/>
+                  <a:srgbClr val="00355F"/>
                 </a:solidFill>
                 <a:latin typeface="Arial"/>
                 <a:ea typeface="Arial"/>
@@ -10732,7 +10762,7 @@
           <p:cNvPr id="40" name="">
             <a:extLst xmlns:a="http://schemas.openxmlformats.org/drawingml/2006/main">
               <a:ext uri="{FF2B5EF4-FFF2-40B4-BE49-F238E27FC236}">
-                <a16:creationId xmlns:a16="http://schemas.microsoft.com/office/drawing/2014/main" id="{1BE35979-C1A6-4B7F-9B9E-F41D4260121D}"/>
+                <a16:creationId xmlns:a16="http://schemas.microsoft.com/office/drawing/2014/main" id="{E4B72C0C-6A41-4E93-B762-B148EEB5DD20}"/>
               </a:ext>
             </a:extLst>
           </p:cNvPr>
@@ -10756,7 +10786,7 @@
           </a:solidFill>
           <a:ln xmlns:a="http://schemas.openxmlformats.org/drawingml/2006/main" w="9525">
             <a:solidFill>
-              <a:srgbClr val="D7E3E8"/>
+              <a:srgbClr val="A5A5A5"/>
             </a:solidFill>
           </a:ln>
         </p:spPr>
@@ -10766,7 +10796,7 @@
           <p:cNvPr id="41" name="">
             <a:extLst xmlns:a="http://schemas.openxmlformats.org/drawingml/2006/main">
               <a:ext uri="{FF2B5EF4-FFF2-40B4-BE49-F238E27FC236}">
-                <a16:creationId xmlns:a16="http://schemas.microsoft.com/office/drawing/2014/main" id="{DDC3BD2E-0834-48ED-8B8C-BB18527946A0}"/>
+                <a16:creationId xmlns:a16="http://schemas.microsoft.com/office/drawing/2014/main" id="{61BBBB50-3152-4BE4-A3CF-EFC4401F914A}"/>
               </a:ext>
             </a:extLst>
           </p:cNvPr>
@@ -10776,10 +10806,10 @@
           <p:nvPr/>
         </p:nvPicPr>
         <p:blipFill>
-          <a:blip xmlns:r="http://schemas.openxmlformats.org/officeDocument/2006/relationships" xmlns:a="http://schemas.openxmlformats.org/drawingml/2006/main" r:embed="Ra8cf4d3b1ad74357">
+          <a:blip xmlns:r="http://schemas.openxmlformats.org/officeDocument/2006/relationships" xmlns:a="http://schemas.openxmlformats.org/drawingml/2006/main" r:embed="R8519439bc0284a3d">
             <a:extLst>
               <a:ext uri="{96DAC541-7B7A-43D3-8B79-37D633B846F1}">
-                <asvg:svgBlip xmlns:asvg="http://schemas.microsoft.com/office/drawing/2016/SVG/main" r:embed="R4ee9c308fecb4613"/>
+                <asvg:svgBlip xmlns:asvg="http://schemas.microsoft.com/office/drawing/2016/SVG/main" r:embed="Rc8fc553e21b64e23"/>
               </a:ext>
             </a:extLst>
           </a:blip>
@@ -10800,7 +10830,7 @@
           <p:cNvPr id="42" name="Construction &amp; expression">
             <a:extLst xmlns:a="http://schemas.openxmlformats.org/drawingml/2006/main">
               <a:ext uri="{FF2B5EF4-FFF2-40B4-BE49-F238E27FC236}">
-                <a16:creationId xmlns:a16="http://schemas.microsoft.com/office/drawing/2014/main" id="{AD312504-5FE2-48F8-9109-393488F7FB6D}"/>
+                <a16:creationId xmlns:a16="http://schemas.microsoft.com/office/drawing/2014/main" id="{98B23CE8-96B2-499B-A4DD-2C4020214EAC}"/>
               </a:ext>
             </a:extLst>
           </p:cNvPr>
@@ -10828,7 +10858,7 @@
             <a:defPPr algn="l">
               <a:defRPr sz="1800" b="1">
                 <a:solidFill>
-                  <a:srgbClr val="152C3A"/>
+                  <a:srgbClr val="00355F"/>
                 </a:solidFill>
                 <a:latin typeface="Arial"/>
                 <a:ea typeface="Arial"/>
@@ -10844,7 +10874,7 @@
               <a:buNone/>
               <a:defRPr sz="1800" b="1">
                 <a:solidFill>
-                  <a:srgbClr val="152C3A"/>
+                  <a:srgbClr val="00355F"/>
                 </a:solidFill>
                 <a:latin typeface="Arial"/>
                 <a:ea typeface="Arial"/>
@@ -10854,7 +10884,7 @@
             <a:r>
               <a:rPr sz="1800" b="1">
                 <a:solidFill>
-                  <a:srgbClr val="152C3A"/>
+                  <a:srgbClr val="00355F"/>
                 </a:solidFill>
                 <a:latin typeface="Arial"/>
                 <a:ea typeface="Arial"/>
@@ -10870,7 +10900,7 @@
           <p:cNvPr id="43" name="DNA synthesis, vectors, expression, purification">
             <a:extLst xmlns:a="http://schemas.openxmlformats.org/drawingml/2006/main">
               <a:ext uri="{FF2B5EF4-FFF2-40B4-BE49-F238E27FC236}">
-                <a16:creationId xmlns:a16="http://schemas.microsoft.com/office/drawing/2014/main" id="{1BF920C8-4ADC-4D4B-BD00-B562CF2F5D35}"/>
+                <a16:creationId xmlns:a16="http://schemas.microsoft.com/office/drawing/2014/main" id="{C3CD6729-208D-46EE-9D29-FFCBA39D9478}"/>
               </a:ext>
             </a:extLst>
           </p:cNvPr>
@@ -10898,7 +10928,7 @@
             <a:defPPr algn="l">
               <a:defRPr sz="1500" b="0">
                 <a:solidFill>
-                  <a:srgbClr val="647887"/>
+                  <a:srgbClr val="00355F"/>
                 </a:solidFill>
                 <a:latin typeface="Arial"/>
                 <a:ea typeface="Arial"/>
@@ -10914,7 +10944,7 @@
               <a:buNone/>
               <a:defRPr sz="1500" b="0">
                 <a:solidFill>
-                  <a:srgbClr val="647887"/>
+                  <a:srgbClr val="00355F"/>
                 </a:solidFill>
                 <a:latin typeface="Arial"/>
                 <a:ea typeface="Arial"/>
@@ -10924,7 +10954,7 @@
             <a:r>
               <a:rPr sz="1500" b="0">
                 <a:solidFill>
-                  <a:srgbClr val="647887"/>
+                  <a:srgbClr val="00355F"/>
                 </a:solidFill>
                 <a:latin typeface="Arial"/>
                 <a:ea typeface="Arial"/>
@@ -10940,7 +10970,7 @@
           <p:cNvPr id="44" name="Expression labels + samples for other assays">
             <a:extLst xmlns:a="http://schemas.openxmlformats.org/drawingml/2006/main">
               <a:ext uri="{FF2B5EF4-FFF2-40B4-BE49-F238E27FC236}">
-                <a16:creationId xmlns:a16="http://schemas.microsoft.com/office/drawing/2014/main" id="{D6C4DEF3-AB37-45AB-B537-C0377009E34E}"/>
+                <a16:creationId xmlns:a16="http://schemas.microsoft.com/office/drawing/2014/main" id="{98705807-D9BB-42B5-99B9-BA3AD454023A}"/>
               </a:ext>
             </a:extLst>
           </p:cNvPr>
@@ -10968,7 +10998,7 @@
             <a:defPPr algn="l">
               <a:defRPr sz="1350" b="0">
                 <a:solidFill>
-                  <a:srgbClr val="007D80"/>
+                  <a:srgbClr val="00355F"/>
                 </a:solidFill>
                 <a:latin typeface="Arial"/>
                 <a:ea typeface="Arial"/>
@@ -10984,7 +11014,7 @@
               <a:buNone/>
               <a:defRPr sz="1350" b="0">
                 <a:solidFill>
-                  <a:srgbClr val="007D80"/>
+                  <a:srgbClr val="00355F"/>
                 </a:solidFill>
                 <a:latin typeface="Arial"/>
                 <a:ea typeface="Arial"/>
@@ -10994,7 +11024,7 @@
             <a:r>
               <a:rPr sz="1350" b="0">
                 <a:solidFill>
-                  <a:srgbClr val="007D80"/>
+                  <a:srgbClr val="00355F"/>
                 </a:solidFill>
                 <a:latin typeface="Arial"/>
                 <a:ea typeface="Arial"/>
@@ -11010,7 +11040,7 @@
           <p:cNvPr id="45" name="Count shared sample preparation once">
             <a:extLst xmlns:a="http://schemas.openxmlformats.org/drawingml/2006/main">
               <a:ext uri="{FF2B5EF4-FFF2-40B4-BE49-F238E27FC236}">
-                <a16:creationId xmlns:a16="http://schemas.microsoft.com/office/drawing/2014/main" id="{C920DAF2-F4B3-4FA1-A5D0-957BA99735D4}"/>
+                <a16:creationId xmlns:a16="http://schemas.microsoft.com/office/drawing/2014/main" id="{FD3E1D10-65F8-4613-972A-CD8008B524E9}"/>
               </a:ext>
             </a:extLst>
           </p:cNvPr>
@@ -11038,7 +11068,7 @@
             <a:defPPr algn="l">
               <a:defRPr sz="1275" b="0">
                 <a:solidFill>
-                  <a:srgbClr val="647887"/>
+                  <a:srgbClr val="00355F"/>
                 </a:solidFill>
                 <a:latin typeface="Arial"/>
                 <a:ea typeface="Arial"/>
@@ -11054,7 +11084,7 @@
               <a:buNone/>
               <a:defRPr sz="1275" b="0">
                 <a:solidFill>
-                  <a:srgbClr val="647887"/>
+                  <a:srgbClr val="00355F"/>
                 </a:solidFill>
                 <a:latin typeface="Arial"/>
                 <a:ea typeface="Arial"/>
@@ -11064,7 +11094,7 @@
             <a:r>
               <a:rPr sz="1275" b="0">
                 <a:solidFill>
-                  <a:srgbClr val="647887"/>
+                  <a:srgbClr val="00355F"/>
                 </a:solidFill>
                 <a:latin typeface="Arial"/>
                 <a:ea typeface="Arial"/>
@@ -11080,7 +11110,7 @@
           <p:cNvPr id="46" name="">
             <a:extLst xmlns:a="http://schemas.openxmlformats.org/drawingml/2006/main">
               <a:ext uri="{FF2B5EF4-FFF2-40B4-BE49-F238E27FC236}">
-                <a16:creationId xmlns:a16="http://schemas.microsoft.com/office/drawing/2014/main" id="{94CAE825-8203-420B-BE80-679DB561B838}"/>
+                <a16:creationId xmlns:a16="http://schemas.microsoft.com/office/drawing/2014/main" id="{BDEAE822-2058-4AD6-9BC9-C95E16D59B96}"/>
               </a:ext>
             </a:extLst>
           </p:cNvPr>
@@ -11104,7 +11134,7 @@
           </a:solidFill>
           <a:ln xmlns:a="http://schemas.openxmlformats.org/drawingml/2006/main" w="9525">
             <a:solidFill>
-              <a:srgbClr val="D7E3E8"/>
+              <a:srgbClr val="A5A5A5"/>
             </a:solidFill>
           </a:ln>
         </p:spPr>
@@ -11114,7 +11144,7 @@
           <p:cNvPr id="47" name="">
             <a:extLst xmlns:a="http://schemas.openxmlformats.org/drawingml/2006/main">
               <a:ext uri="{FF2B5EF4-FFF2-40B4-BE49-F238E27FC236}">
-                <a16:creationId xmlns:a16="http://schemas.microsoft.com/office/drawing/2014/main" id="{CEEBCEA4-EE41-46C5-A41F-B24B4F92B694}"/>
+                <a16:creationId xmlns:a16="http://schemas.microsoft.com/office/drawing/2014/main" id="{A2197F5F-8820-4B24-83AB-490417EBA650}"/>
               </a:ext>
             </a:extLst>
           </p:cNvPr>
@@ -11124,10 +11154,10 @@
           <p:nvPr/>
         </p:nvPicPr>
         <p:blipFill>
-          <a:blip xmlns:r="http://schemas.openxmlformats.org/officeDocument/2006/relationships" xmlns:a="http://schemas.openxmlformats.org/drawingml/2006/main" r:embed="R4c1a23fcd127477e">
+          <a:blip xmlns:r="http://schemas.openxmlformats.org/officeDocument/2006/relationships" xmlns:a="http://schemas.openxmlformats.org/drawingml/2006/main" r:embed="R1388b333704d44ef">
             <a:extLst>
               <a:ext uri="{96DAC541-7B7A-43D3-8B79-37D633B846F1}">
-                <asvg:svgBlip xmlns:asvg="http://schemas.microsoft.com/office/drawing/2016/SVG/main" r:embed="Rd34a9d68f6324afd"/>
+                <asvg:svgBlip xmlns:asvg="http://schemas.microsoft.com/office/drawing/2016/SVG/main" r:embed="Rd531e33713c04c26"/>
               </a:ext>
             </a:extLst>
           </a:blip>
@@ -11148,7 +11178,7 @@
           <p:cNvPr id="48" name="Protein &amp; functional testing">
             <a:extLst xmlns:a="http://schemas.openxmlformats.org/drawingml/2006/main">
               <a:ext uri="{FF2B5EF4-FFF2-40B4-BE49-F238E27FC236}">
-                <a16:creationId xmlns:a16="http://schemas.microsoft.com/office/drawing/2014/main" id="{9ED7C897-C15F-48F6-97B1-8CC156601898}"/>
+                <a16:creationId xmlns:a16="http://schemas.microsoft.com/office/drawing/2014/main" id="{D835B44D-F364-4BB0-8B9A-9650493C8054}"/>
               </a:ext>
             </a:extLst>
           </p:cNvPr>
@@ -11176,7 +11206,7 @@
             <a:defPPr algn="l">
               <a:defRPr sz="1800" b="1">
                 <a:solidFill>
-                  <a:srgbClr val="152C3A"/>
+                  <a:srgbClr val="00355F"/>
                 </a:solidFill>
                 <a:latin typeface="Arial"/>
                 <a:ea typeface="Arial"/>
@@ -11192,7 +11222,7 @@
               <a:buNone/>
               <a:defRPr sz="1800" b="1">
                 <a:solidFill>
-                  <a:srgbClr val="152C3A"/>
+                  <a:srgbClr val="00355F"/>
                 </a:solidFill>
                 <a:latin typeface="Arial"/>
                 <a:ea typeface="Arial"/>
@@ -11202,7 +11232,7 @@
             <a:r>
               <a:rPr sz="1800" b="1">
                 <a:solidFill>
-                  <a:srgbClr val="152C3A"/>
+                  <a:srgbClr val="00355F"/>
                 </a:solidFill>
                 <a:latin typeface="Arial"/>
                 <a:ea typeface="Arial"/>
@@ -11218,7 +11248,7 @@
           <p:cNvPr id="49" name="SPR / BLI, binding curves, epitope binning">
             <a:extLst xmlns:a="http://schemas.openxmlformats.org/drawingml/2006/main">
               <a:ext uri="{FF2B5EF4-FFF2-40B4-BE49-F238E27FC236}">
-                <a16:creationId xmlns:a16="http://schemas.microsoft.com/office/drawing/2014/main" id="{9AF5C311-5609-4761-9ACD-30F8C06D272A}"/>
+                <a16:creationId xmlns:a16="http://schemas.microsoft.com/office/drawing/2014/main" id="{B78DAE3F-3503-496B-BA15-6AC0D8AE2C7C}"/>
               </a:ext>
             </a:extLst>
           </p:cNvPr>
@@ -11246,7 +11276,7 @@
             <a:defPPr algn="l">
               <a:defRPr sz="1500" b="0">
                 <a:solidFill>
-                  <a:srgbClr val="647887"/>
+                  <a:srgbClr val="00355F"/>
                 </a:solidFill>
                 <a:latin typeface="Arial"/>
                 <a:ea typeface="Arial"/>
@@ -11262,7 +11292,7 @@
               <a:buNone/>
               <a:defRPr sz="1500" b="0">
                 <a:solidFill>
-                  <a:srgbClr val="647887"/>
+                  <a:srgbClr val="00355F"/>
                 </a:solidFill>
                 <a:latin typeface="Arial"/>
                 <a:ea typeface="Arial"/>
@@ -11272,7 +11302,7 @@
             <a:r>
               <a:rPr sz="1500" b="0">
                 <a:solidFill>
-                  <a:srgbClr val="647887"/>
+                  <a:srgbClr val="00355F"/>
                 </a:solidFill>
                 <a:latin typeface="Arial"/>
                 <a:ea typeface="Arial"/>
@@ -11288,7 +11318,7 @@
           <p:cNvPr id="50" name="Target proteins, sensors / chips, buffers">
             <a:extLst xmlns:a="http://schemas.openxmlformats.org/drawingml/2006/main">
               <a:ext uri="{FF2B5EF4-FFF2-40B4-BE49-F238E27FC236}">
-                <a16:creationId xmlns:a16="http://schemas.microsoft.com/office/drawing/2014/main" id="{5DC43932-D784-4442-B7FC-D5B0476B15A0}"/>
+                <a16:creationId xmlns:a16="http://schemas.microsoft.com/office/drawing/2014/main" id="{85C44D70-8F76-48FF-A777-26744DC01ED3}"/>
               </a:ext>
             </a:extLst>
           </p:cNvPr>
@@ -11316,7 +11346,7 @@
             <a:defPPr algn="l">
               <a:defRPr sz="1350" b="0">
                 <a:solidFill>
-                  <a:srgbClr val="007D80"/>
+                  <a:srgbClr val="00355F"/>
                 </a:solidFill>
                 <a:latin typeface="Arial"/>
                 <a:ea typeface="Arial"/>
@@ -11332,7 +11362,7 @@
               <a:buNone/>
               <a:defRPr sz="1350" b="0">
                 <a:solidFill>
-                  <a:srgbClr val="007D80"/>
+                  <a:srgbClr val="00355F"/>
                 </a:solidFill>
                 <a:latin typeface="Arial"/>
                 <a:ea typeface="Arial"/>
@@ -11342,7 +11372,7 @@
             <a:r>
               <a:rPr sz="1350" b="0">
                 <a:solidFill>
-                  <a:srgbClr val="007D80"/>
+                  <a:srgbClr val="00355F"/>
                 </a:solidFill>
                 <a:latin typeface="Arial"/>
                 <a:ea typeface="Arial"/>
@@ -11358,7 +11388,7 @@
           <p:cNvPr id="51" name="KD / kon / koff can share one kinetic run">
             <a:extLst xmlns:a="http://schemas.openxmlformats.org/drawingml/2006/main">
               <a:ext uri="{FF2B5EF4-FFF2-40B4-BE49-F238E27FC236}">
-                <a16:creationId xmlns:a16="http://schemas.microsoft.com/office/drawing/2014/main" id="{565BD07B-62DA-4770-A65F-A0A18A823B45}"/>
+                <a16:creationId xmlns:a16="http://schemas.microsoft.com/office/drawing/2014/main" id="{241183EF-4646-43A0-A828-ACBADE554B02}"/>
               </a:ext>
             </a:extLst>
           </p:cNvPr>
@@ -11386,7 +11416,7 @@
             <a:defPPr algn="l">
               <a:defRPr sz="1275" b="0">
                 <a:solidFill>
-                  <a:srgbClr val="647887"/>
+                  <a:srgbClr val="00355F"/>
                 </a:solidFill>
                 <a:latin typeface="Arial"/>
                 <a:ea typeface="Arial"/>
@@ -11402,7 +11432,7 @@
               <a:buNone/>
               <a:defRPr sz="1275" b="0">
                 <a:solidFill>
-                  <a:srgbClr val="647887"/>
+                  <a:srgbClr val="00355F"/>
                 </a:solidFill>
                 <a:latin typeface="Arial"/>
                 <a:ea typeface="Arial"/>
@@ -11412,7 +11442,7 @@
             <a:r>
               <a:rPr sz="1275" b="0">
                 <a:solidFill>
-                  <a:srgbClr val="647887"/>
+                  <a:srgbClr val="00355F"/>
                 </a:solidFill>
                 <a:latin typeface="Arial"/>
                 <a:ea typeface="Arial"/>
@@ -11428,7 +11458,7 @@
           <p:cNvPr id="52" name="">
             <a:extLst xmlns:a="http://schemas.openxmlformats.org/drawingml/2006/main">
               <a:ext uri="{FF2B5EF4-FFF2-40B4-BE49-F238E27FC236}">
-                <a16:creationId xmlns:a16="http://schemas.microsoft.com/office/drawing/2014/main" id="{CC898C04-AC17-40E8-B732-C3D1BF980C5A}"/>
+                <a16:creationId xmlns:a16="http://schemas.microsoft.com/office/drawing/2014/main" id="{996941DD-F3FE-4C1E-A078-A0B905C4554A}"/>
               </a:ext>
             </a:extLst>
           </p:cNvPr>
@@ -11452,7 +11482,7 @@
           </a:solidFill>
           <a:ln xmlns:a="http://schemas.openxmlformats.org/drawingml/2006/main" w="9525">
             <a:solidFill>
-              <a:srgbClr val="D7E3E8"/>
+              <a:srgbClr val="A5A5A5"/>
             </a:solidFill>
           </a:ln>
         </p:spPr>
@@ -11462,7 +11492,7 @@
           <p:cNvPr id="53" name="">
             <a:extLst xmlns:a="http://schemas.openxmlformats.org/drawingml/2006/main">
               <a:ext uri="{FF2B5EF4-FFF2-40B4-BE49-F238E27FC236}">
-                <a16:creationId xmlns:a16="http://schemas.microsoft.com/office/drawing/2014/main" id="{1A62510C-5A62-4F5C-BD49-DD9065C4073D}"/>
+                <a16:creationId xmlns:a16="http://schemas.microsoft.com/office/drawing/2014/main" id="{395E1E0D-3699-4BD0-8D20-C5FE05AA0C70}"/>
               </a:ext>
             </a:extLst>
           </p:cNvPr>
@@ -11472,10 +11502,10 @@
           <p:nvPr/>
         </p:nvPicPr>
         <p:blipFill>
-          <a:blip xmlns:r="http://schemas.openxmlformats.org/officeDocument/2006/relationships" xmlns:a="http://schemas.openxmlformats.org/drawingml/2006/main" r:embed="Ree6365ec6dcb4f4e">
+          <a:blip xmlns:r="http://schemas.openxmlformats.org/officeDocument/2006/relationships" xmlns:a="http://schemas.openxmlformats.org/drawingml/2006/main" r:embed="Re5e0d5de6cb64124">
             <a:extLst>
               <a:ext uri="{96DAC541-7B7A-43D3-8B79-37D633B846F1}">
-                <asvg:svgBlip xmlns:asvg="http://schemas.microsoft.com/office/drawing/2016/SVG/main" r:embed="Ra999c88cd9fb4450"/>
+                <asvg:svgBlip xmlns:asvg="http://schemas.microsoft.com/office/drawing/2016/SVG/main" r:embed="R47b4d9201ca347f2"/>
               </a:ext>
             </a:extLst>
           </a:blip>
@@ -11496,7 +11526,7 @@
           <p:cNvPr id="54" name="Cells &amp; culture systems">
             <a:extLst xmlns:a="http://schemas.openxmlformats.org/drawingml/2006/main">
               <a:ext uri="{FF2B5EF4-FFF2-40B4-BE49-F238E27FC236}">
-                <a16:creationId xmlns:a16="http://schemas.microsoft.com/office/drawing/2014/main" id="{2CD1BF4A-1E70-4E12-A717-B2C24BD94548}"/>
+                <a16:creationId xmlns:a16="http://schemas.microsoft.com/office/drawing/2014/main" id="{87A51E94-22F9-4CE2-89F2-30620BE1312B}"/>
               </a:ext>
             </a:extLst>
           </p:cNvPr>
@@ -11524,7 +11554,7 @@
             <a:defPPr algn="l">
               <a:defRPr sz="1800" b="1">
                 <a:solidFill>
-                  <a:srgbClr val="152C3A"/>
+                  <a:srgbClr val="00355F"/>
                 </a:solidFill>
                 <a:latin typeface="Arial"/>
                 <a:ea typeface="Arial"/>
@@ -11540,7 +11570,7 @@
               <a:buNone/>
               <a:defRPr sz="1800" b="1">
                 <a:solidFill>
-                  <a:srgbClr val="152C3A"/>
+                  <a:srgbClr val="00355F"/>
                 </a:solidFill>
                 <a:latin typeface="Arial"/>
                 <a:ea typeface="Arial"/>
@@ -11550,7 +11580,7 @@
             <a:r>
               <a:rPr sz="1800" b="1">
                 <a:solidFill>
-                  <a:srgbClr val="152C3A"/>
+                  <a:srgbClr val="00355F"/>
                 </a:solidFill>
                 <a:latin typeface="Arial"/>
                 <a:ea typeface="Arial"/>
@@ -11566,7 +11596,7 @@
           <p:cNvPr id="55" name="Functional cells, media, transfection, expansion">
             <a:extLst xmlns:a="http://schemas.openxmlformats.org/drawingml/2006/main">
               <a:ext uri="{FF2B5EF4-FFF2-40B4-BE49-F238E27FC236}">
-                <a16:creationId xmlns:a16="http://schemas.microsoft.com/office/drawing/2014/main" id="{20CF7F1E-BBE1-42F8-99AC-8B1C67185C07}"/>
+                <a16:creationId xmlns:a16="http://schemas.microsoft.com/office/drawing/2014/main" id="{E7D2A28F-ACDD-42E1-AAC4-BE234F3FC90A}"/>
               </a:ext>
             </a:extLst>
           </p:cNvPr>
@@ -11594,7 +11624,7 @@
             <a:defPPr algn="l">
               <a:defRPr sz="1500" b="0">
                 <a:solidFill>
-                  <a:srgbClr val="647887"/>
+                  <a:srgbClr val="00355F"/>
                 </a:solidFill>
                 <a:latin typeface="Arial"/>
                 <a:ea typeface="Arial"/>
@@ -11610,7 +11640,7 @@
               <a:buNone/>
               <a:defRPr sz="1500" b="0">
                 <a:solidFill>
-                  <a:srgbClr val="647887"/>
+                  <a:srgbClr val="00355F"/>
                 </a:solidFill>
                 <a:latin typeface="Arial"/>
                 <a:ea typeface="Arial"/>
@@ -11620,7 +11650,7 @@
             <a:r>
               <a:rPr sz="1500" b="0">
                 <a:solidFill>
-                  <a:srgbClr val="647887"/>
+                  <a:srgbClr val="00355F"/>
                 </a:solidFill>
                 <a:latin typeface="Arial"/>
                 <a:ea typeface="Arial"/>
@@ -11636,7 +11666,7 @@
           <p:cNvPr id="56" name="Cell potency; selected polyreactivity assays">
             <a:extLst xmlns:a="http://schemas.openxmlformats.org/drawingml/2006/main">
               <a:ext uri="{FF2B5EF4-FFF2-40B4-BE49-F238E27FC236}">
-                <a16:creationId xmlns:a16="http://schemas.microsoft.com/office/drawing/2014/main" id="{E0DCE027-29B7-47E3-82C4-92AFF28082B5}"/>
+                <a16:creationId xmlns:a16="http://schemas.microsoft.com/office/drawing/2014/main" id="{1FBD12A5-84C3-4CBA-A2B2-7360038B3F3D}"/>
               </a:ext>
             </a:extLst>
           </p:cNvPr>
@@ -11664,7 +11694,7 @@
             <a:defPPr algn="l">
               <a:defRPr sz="1350" b="0">
                 <a:solidFill>
-                  <a:srgbClr val="007D80"/>
+                  <a:srgbClr val="00355F"/>
                 </a:solidFill>
                 <a:latin typeface="Arial"/>
                 <a:ea typeface="Arial"/>
@@ -11680,7 +11710,7 @@
               <a:buNone/>
               <a:defRPr sz="1350" b="0">
                 <a:solidFill>
-                  <a:srgbClr val="007D80"/>
+                  <a:srgbClr val="00355F"/>
                 </a:solidFill>
                 <a:latin typeface="Arial"/>
                 <a:ea typeface="Arial"/>
@@ -11690,7 +11720,7 @@
             <a:r>
               <a:rPr sz="1350" b="0">
                 <a:solidFill>
-                  <a:srgbClr val="007D80"/>
+                  <a:srgbClr val="00355F"/>
                 </a:solidFill>
                 <a:latin typeface="Arial"/>
                 <a:ea typeface="Arial"/>
@@ -11706,7 +11736,7 @@
           <p:cNvPr id="57" name="Record cell model, target level and conditions">
             <a:extLst xmlns:a="http://schemas.openxmlformats.org/drawingml/2006/main">
               <a:ext uri="{FF2B5EF4-FFF2-40B4-BE49-F238E27FC236}">
-                <a16:creationId xmlns:a16="http://schemas.microsoft.com/office/drawing/2014/main" id="{B16272CB-4BE5-4EF1-8A35-9C1E2A237CEB}"/>
+                <a16:creationId xmlns:a16="http://schemas.microsoft.com/office/drawing/2014/main" id="{D03D16E2-7D02-427D-9FD1-2EE924351169}"/>
               </a:ext>
             </a:extLst>
           </p:cNvPr>
@@ -11734,7 +11764,7 @@
             <a:defPPr algn="l">
               <a:defRPr sz="1275" b="0">
                 <a:solidFill>
-                  <a:srgbClr val="647887"/>
+                  <a:srgbClr val="00355F"/>
                 </a:solidFill>
                 <a:latin typeface="Arial"/>
                 <a:ea typeface="Arial"/>
@@ -11750,7 +11780,7 @@
               <a:buNone/>
               <a:defRPr sz="1275" b="0">
                 <a:solidFill>
-                  <a:srgbClr val="647887"/>
+                  <a:srgbClr val="00355F"/>
                 </a:solidFill>
                 <a:latin typeface="Arial"/>
                 <a:ea typeface="Arial"/>
@@ -11760,7 +11790,7 @@
             <a:r>
               <a:rPr sz="1275" b="0">
                 <a:solidFill>
-                  <a:srgbClr val="647887"/>
+                  <a:srgbClr val="00355F"/>
                 </a:solidFill>
                 <a:latin typeface="Arial"/>
                 <a:ea typeface="Arial"/>
@@ -11776,7 +11806,7 @@
           <p:cNvPr id="58" name="">
             <a:extLst xmlns:a="http://schemas.openxmlformats.org/drawingml/2006/main">
               <a:ext uri="{FF2B5EF4-FFF2-40B4-BE49-F238E27FC236}">
-                <a16:creationId xmlns:a16="http://schemas.microsoft.com/office/drawing/2014/main" id="{FEB5FDB7-F639-4157-ACD0-EF63CBEF13FB}"/>
+                <a16:creationId xmlns:a16="http://schemas.microsoft.com/office/drawing/2014/main" id="{32658A50-C123-4432-A106-FCC6563F41CF}"/>
               </a:ext>
             </a:extLst>
           </p:cNvPr>
@@ -11800,7 +11830,7 @@
           </a:solidFill>
           <a:ln xmlns:a="http://schemas.openxmlformats.org/drawingml/2006/main" w="9525">
             <a:solidFill>
-              <a:srgbClr val="D7E3E8"/>
+              <a:srgbClr val="A5A5A5"/>
             </a:solidFill>
           </a:ln>
         </p:spPr>
@@ -11810,7 +11840,7 @@
           <p:cNvPr id="59" name="">
             <a:extLst xmlns:a="http://schemas.openxmlformats.org/drawingml/2006/main">
               <a:ext uri="{FF2B5EF4-FFF2-40B4-BE49-F238E27FC236}">
-                <a16:creationId xmlns:a16="http://schemas.microsoft.com/office/drawing/2014/main" id="{91BA3F1B-D406-4C66-95F4-889A8132C5E2}"/>
+                <a16:creationId xmlns:a16="http://schemas.microsoft.com/office/drawing/2014/main" id="{31181ECE-BD7C-4222-8A1B-536FF22D3721}"/>
               </a:ext>
             </a:extLst>
           </p:cNvPr>
@@ -11820,10 +11850,10 @@
           <p:nvPr/>
         </p:nvPicPr>
         <p:blipFill>
-          <a:blip xmlns:r="http://schemas.openxmlformats.org/officeDocument/2006/relationships" xmlns:a="http://schemas.openxmlformats.org/drawingml/2006/main" r:embed="R80c752b8b9ad4db6">
+          <a:blip xmlns:r="http://schemas.openxmlformats.org/officeDocument/2006/relationships" xmlns:a="http://schemas.openxmlformats.org/drawingml/2006/main" r:embed="R399f8324945348be">
             <a:extLst>
               <a:ext uri="{96DAC541-7B7A-43D3-8B79-37D633B846F1}">
-                <asvg:svgBlip xmlns:asvg="http://schemas.microsoft.com/office/drawing/2016/SVG/main" r:embed="R433fc35eface4970"/>
+                <asvg:svgBlip xmlns:asvg="http://schemas.microsoft.com/office/drawing/2016/SVG/main" r:embed="Rca9d07e535c443e5"/>
               </a:ext>
             </a:extLst>
           </a:blip>
@@ -11844,7 +11874,7 @@
           <p:cNvPr id="60" name="Measurement &amp; analysis">
             <a:extLst xmlns:a="http://schemas.openxmlformats.org/drawingml/2006/main">
               <a:ext uri="{FF2B5EF4-FFF2-40B4-BE49-F238E27FC236}">
-                <a16:creationId xmlns:a16="http://schemas.microsoft.com/office/drawing/2014/main" id="{30950CB6-14E9-4FBE-9A92-D5FBCA8769F0}"/>
+                <a16:creationId xmlns:a16="http://schemas.microsoft.com/office/drawing/2014/main" id="{F77CE9EB-72D0-40CF-8724-08ECB9D8BEA2}"/>
               </a:ext>
             </a:extLst>
           </p:cNvPr>
@@ -11872,7 +11902,7 @@
             <a:defPPr algn="l">
               <a:defRPr sz="1800" b="1">
                 <a:solidFill>
-                  <a:srgbClr val="152C3A"/>
+                  <a:srgbClr val="00355F"/>
                 </a:solidFill>
                 <a:latin typeface="Arial"/>
                 <a:ea typeface="Arial"/>
@@ -11888,7 +11918,7 @@
               <a:buNone/>
               <a:defRPr sz="1800" b="1">
                 <a:solidFill>
-                  <a:srgbClr val="152C3A"/>
+                  <a:srgbClr val="00355F"/>
                 </a:solidFill>
                 <a:latin typeface="Arial"/>
                 <a:ea typeface="Arial"/>
@@ -11898,7 +11928,7 @@
             <a:r>
               <a:rPr sz="1800" b="1">
                 <a:solidFill>
-                  <a:srgbClr val="152C3A"/>
+                  <a:srgbClr val="00355F"/>
                 </a:solidFill>
                 <a:latin typeface="Arial"/>
                 <a:ea typeface="Arial"/>
@@ -11914,7 +11944,7 @@
           <p:cNvPr id="61" name="SEC / HIC, nanoDSF, LC-MS, flow cytometry">
             <a:extLst xmlns:a="http://schemas.openxmlformats.org/drawingml/2006/main">
               <a:ext uri="{FF2B5EF4-FFF2-40B4-BE49-F238E27FC236}">
-                <a16:creationId xmlns:a16="http://schemas.microsoft.com/office/drawing/2014/main" id="{9DC48796-B864-42A3-9C40-D45AE89803D2}"/>
+                <a16:creationId xmlns:a16="http://schemas.microsoft.com/office/drawing/2014/main" id="{371D8279-90D4-4DE6-B6DA-868F1A3B87E8}"/>
               </a:ext>
             </a:extLst>
           </p:cNvPr>
@@ -11942,7 +11972,7 @@
             <a:defPPr algn="l">
               <a:defRPr sz="1500" b="0">
                 <a:solidFill>
-                  <a:srgbClr val="647887"/>
+                  <a:srgbClr val="00355F"/>
                 </a:solidFill>
                 <a:latin typeface="Arial"/>
                 <a:ea typeface="Arial"/>
@@ -11958,7 +11988,7 @@
               <a:buNone/>
               <a:defRPr sz="1500" b="0">
                 <a:solidFill>
-                  <a:srgbClr val="647887"/>
+                  <a:srgbClr val="00355F"/>
                 </a:solidFill>
                 <a:latin typeface="Arial"/>
                 <a:ea typeface="Arial"/>
@@ -11968,7 +11998,7 @@
             <a:r>
               <a:rPr sz="1500" b="0">
                 <a:solidFill>
-                  <a:srgbClr val="647887"/>
+                  <a:srgbClr val="00355F"/>
                 </a:solidFill>
                 <a:latin typeface="Arial"/>
                 <a:ea typeface="Arial"/>
@@ -11984,7 +12014,7 @@
           <p:cNvPr id="62" name="Stability, aggregation, characterization / QC">
             <a:extLst xmlns:a="http://schemas.openxmlformats.org/drawingml/2006/main">
               <a:ext uri="{FF2B5EF4-FFF2-40B4-BE49-F238E27FC236}">
-                <a16:creationId xmlns:a16="http://schemas.microsoft.com/office/drawing/2014/main" id="{848D6B6E-FAA9-4214-9903-96C1A1C5EA9D}"/>
+                <a16:creationId xmlns:a16="http://schemas.microsoft.com/office/drawing/2014/main" id="{943C81BE-E7D4-4D61-82DF-EB010B78336C}"/>
               </a:ext>
             </a:extLst>
           </p:cNvPr>
@@ -12012,7 +12042,7 @@
             <a:defPPr algn="l">
               <a:defRPr sz="1350" b="0">
                 <a:solidFill>
-                  <a:srgbClr val="007D80"/>
+                  <a:srgbClr val="00355F"/>
                 </a:solidFill>
                 <a:latin typeface="Arial"/>
                 <a:ea typeface="Arial"/>
@@ -12028,7 +12058,7 @@
               <a:buNone/>
               <a:defRPr sz="1350" b="0">
                 <a:solidFill>
-                  <a:srgbClr val="007D80"/>
+                  <a:srgbClr val="00355F"/>
                 </a:solidFill>
                 <a:latin typeface="Arial"/>
                 <a:ea typeface="Arial"/>
@@ -12038,7 +12068,7 @@
             <a:r>
               <a:rPr sz="1350" b="0">
                 <a:solidFill>
-                  <a:srgbClr val="007D80"/>
+                  <a:srgbClr val="00355F"/>
                 </a:solidFill>
                 <a:latin typeface="Arial"/>
                 <a:ea typeface="Arial"/>
@@ -12054,7 +12084,7 @@
           <p:cNvPr id="63" name="Columns are reused; model instrument CAPEX separately">
             <a:extLst xmlns:a="http://schemas.openxmlformats.org/drawingml/2006/main">
               <a:ext uri="{FF2B5EF4-FFF2-40B4-BE49-F238E27FC236}">
-                <a16:creationId xmlns:a16="http://schemas.microsoft.com/office/drawing/2014/main" id="{03230279-B72D-411B-81AD-66BC59E73354}"/>
+                <a16:creationId xmlns:a16="http://schemas.microsoft.com/office/drawing/2014/main" id="{3615B612-8F3B-43C8-9C46-D6C74B46AC6F}"/>
               </a:ext>
             </a:extLst>
           </p:cNvPr>
@@ -12082,7 +12112,7 @@
             <a:defPPr algn="l">
               <a:defRPr sz="1275" b="0">
                 <a:solidFill>
-                  <a:srgbClr val="647887"/>
+                  <a:srgbClr val="00355F"/>
                 </a:solidFill>
                 <a:latin typeface="Arial"/>
                 <a:ea typeface="Arial"/>
@@ -12098,7 +12128,7 @@
               <a:buNone/>
               <a:defRPr sz="1275" b="0">
                 <a:solidFill>
-                  <a:srgbClr val="647887"/>
+                  <a:srgbClr val="00355F"/>
                 </a:solidFill>
                 <a:latin typeface="Arial"/>
                 <a:ea typeface="Arial"/>
@@ -12108,7 +12138,7 @@
             <a:r>
               <a:rPr sz="1275" b="0">
                 <a:solidFill>
-                  <a:srgbClr val="647887"/>
+                  <a:srgbClr val="00355F"/>
                 </a:solidFill>
                 <a:latin typeface="Arial"/>
                 <a:ea typeface="Arial"/>
@@ -12124,7 +12154,7 @@
           <p:cNvPr id="64" name="">
             <a:extLst xmlns:a="http://schemas.openxmlformats.org/drawingml/2006/main">
               <a:ext uri="{FF2B5EF4-FFF2-40B4-BE49-F238E27FC236}">
-                <a16:creationId xmlns:a16="http://schemas.microsoft.com/office/drawing/2014/main" id="{68C70CF1-5821-4820-915C-F482C7F2EF7B}"/>
+                <a16:creationId xmlns:a16="http://schemas.microsoft.com/office/drawing/2014/main" id="{D98E8F5C-DCFC-40BC-82BA-128F3FB9BED9}"/>
               </a:ext>
             </a:extLst>
           </p:cNvPr>
@@ -12148,7 +12178,7 @@
           </a:solidFill>
           <a:ln xmlns:a="http://schemas.openxmlformats.org/drawingml/2006/main" w="9525">
             <a:solidFill>
-              <a:srgbClr val="D7E3E8"/>
+              <a:srgbClr val="A5A5A5"/>
             </a:solidFill>
           </a:ln>
         </p:spPr>
@@ -12158,7 +12188,7 @@
           <p:cNvPr id="65" name="">
             <a:extLst xmlns:a="http://schemas.openxmlformats.org/drawingml/2006/main">
               <a:ext uri="{FF2B5EF4-FFF2-40B4-BE49-F238E27FC236}">
-                <a16:creationId xmlns:a16="http://schemas.microsoft.com/office/drawing/2014/main" id="{26146A21-CAC5-43CB-A10D-B8E119344415}"/>
+                <a16:creationId xmlns:a16="http://schemas.microsoft.com/office/drawing/2014/main" id="{598A3F72-E526-4430-BF76-EF1E09FE604B}"/>
               </a:ext>
             </a:extLst>
           </p:cNvPr>
@@ -12168,10 +12198,10 @@
           <p:nvPr/>
         </p:nvPicPr>
         <p:blipFill>
-          <a:blip xmlns:r="http://schemas.openxmlformats.org/officeDocument/2006/relationships" xmlns:a="http://schemas.openxmlformats.org/drawingml/2006/main" r:embed="R6c2f49f1b40b45b0">
+          <a:blip xmlns:r="http://schemas.openxmlformats.org/officeDocument/2006/relationships" xmlns:a="http://schemas.openxmlformats.org/drawingml/2006/main" r:embed="R22ab9e1f25f94615">
             <a:extLst>
               <a:ext uri="{96DAC541-7B7A-43D3-8B79-37D633B846F1}">
-                <asvg:svgBlip xmlns:asvg="http://schemas.microsoft.com/office/drawing/2016/SVG/main" r:embed="Rc3bd1091a03541f3"/>
+                <asvg:svgBlip xmlns:asvg="http://schemas.microsoft.com/office/drawing/2016/SVG/main" r:embed="R32d9c06296634da4"/>
               </a:ext>
             </a:extLst>
           </a:blip>
@@ -12192,7 +12222,7 @@
           <p:cNvPr id="66" name="Sample handling, labware &amp; automation">
             <a:extLst xmlns:a="http://schemas.openxmlformats.org/drawingml/2006/main">
               <a:ext uri="{FF2B5EF4-FFF2-40B4-BE49-F238E27FC236}">
-                <a16:creationId xmlns:a16="http://schemas.microsoft.com/office/drawing/2014/main" id="{A8ECF13A-41D4-41F4-A717-BA47FDCCEC78}"/>
+                <a16:creationId xmlns:a16="http://schemas.microsoft.com/office/drawing/2014/main" id="{37E1DFE9-2501-43C6-BB41-BC37F8093F9D}"/>
               </a:ext>
             </a:extLst>
           </p:cNvPr>
@@ -12220,7 +12250,7 @@
             <a:defPPr algn="l">
               <a:defRPr sz="1800" b="1">
                 <a:solidFill>
-                  <a:srgbClr val="152C3A"/>
+                  <a:srgbClr val="00355F"/>
                 </a:solidFill>
                 <a:latin typeface="Arial"/>
                 <a:ea typeface="Arial"/>
@@ -12236,7 +12266,7 @@
               <a:buNone/>
               <a:defRPr sz="1800" b="1">
                 <a:solidFill>
-                  <a:srgbClr val="152C3A"/>
+                  <a:srgbClr val="00355F"/>
                 </a:solidFill>
                 <a:latin typeface="Arial"/>
                 <a:ea typeface="Arial"/>
@@ -12246,7 +12276,7 @@
             <a:r>
               <a:rPr sz="1800" b="1">
                 <a:solidFill>
-                  <a:srgbClr val="152C3A"/>
+                  <a:srgbClr val="00355F"/>
                 </a:solidFill>
                 <a:latin typeface="Arial"/>
                 <a:ea typeface="Arial"/>
@@ -12262,7 +12292,7 @@
           <p:cNvPr id="67" name="Plates, tips, tubes, filtration / beads, liquid handling">
             <a:extLst xmlns:a="http://schemas.openxmlformats.org/drawingml/2006/main">
               <a:ext uri="{FF2B5EF4-FFF2-40B4-BE49-F238E27FC236}">
-                <a16:creationId xmlns:a16="http://schemas.microsoft.com/office/drawing/2014/main" id="{5635D1CD-D8D0-4156-ABD6-27DEF1F4E14F}"/>
+                <a16:creationId xmlns:a16="http://schemas.microsoft.com/office/drawing/2014/main" id="{B6C3B861-5C35-4B49-8C2F-2E36BCD85F3F}"/>
               </a:ext>
             </a:extLst>
           </p:cNvPr>
@@ -12290,7 +12320,7 @@
             <a:defPPr algn="l">
               <a:defRPr sz="1500" b="0">
                 <a:solidFill>
-                  <a:srgbClr val="647887"/>
+                  <a:srgbClr val="00355F"/>
                 </a:solidFill>
                 <a:latin typeface="Arial"/>
                 <a:ea typeface="Arial"/>
@@ -12306,7 +12336,7 @@
               <a:buNone/>
               <a:defRPr sz="1500" b="0">
                 <a:solidFill>
-                  <a:srgbClr val="647887"/>
+                  <a:srgbClr val="00355F"/>
                 </a:solidFill>
                 <a:latin typeface="Arial"/>
                 <a:ea typeface="Arial"/>
@@ -12316,7 +12346,7 @@
             <a:r>
               <a:rPr sz="1500" b="0">
                 <a:solidFill>
-                  <a:srgbClr val="647887"/>
+                  <a:srgbClr val="00355F"/>
                 </a:solidFill>
                 <a:latin typeface="Arial"/>
                 <a:ea typeface="Arial"/>
@@ -12332,7 +12362,7 @@
           <p:cNvPr id="68" name="Across all workflows; miniaturization, reuse and scheduling alter net consumption">
             <a:extLst xmlns:a="http://schemas.openxmlformats.org/drawingml/2006/main">
               <a:ext uri="{FF2B5EF4-FFF2-40B4-BE49-F238E27FC236}">
-                <a16:creationId xmlns:a16="http://schemas.microsoft.com/office/drawing/2014/main" id="{16112721-F709-487C-B47D-8713C1E6AB2D}"/>
+                <a16:creationId xmlns:a16="http://schemas.microsoft.com/office/drawing/2014/main" id="{B301483B-5DDD-4C60-811B-2A339851C31C}"/>
               </a:ext>
             </a:extLst>
           </p:cNvPr>
@@ -12360,7 +12390,7 @@
             <a:defPPr algn="l">
               <a:defRPr sz="1350" b="0">
                 <a:solidFill>
-                  <a:srgbClr val="007D80"/>
+                  <a:srgbClr val="00355F"/>
                 </a:solidFill>
                 <a:latin typeface="Arial"/>
                 <a:ea typeface="Arial"/>
@@ -12376,7 +12406,7 @@
               <a:buNone/>
               <a:defRPr sz="1350" b="0">
                 <a:solidFill>
-                  <a:srgbClr val="007D80"/>
+                  <a:srgbClr val="00355F"/>
                 </a:solidFill>
                 <a:latin typeface="Arial"/>
                 <a:ea typeface="Arial"/>
@@ -12386,7 +12416,7 @@
             <a:r>
               <a:rPr sz="1350" b="0">
                 <a:solidFill>
-                  <a:srgbClr val="007D80"/>
+                  <a:srgbClr val="00355F"/>
                 </a:solidFill>
                 <a:latin typeface="Arial"/>
                 <a:ea typeface="Arial"/>
@@ -12402,7 +12432,7 @@
           <p:cNvPr id="69" name="">
             <a:extLst xmlns:a="http://schemas.openxmlformats.org/drawingml/2006/main">
               <a:ext uri="{FF2B5EF4-FFF2-40B4-BE49-F238E27FC236}">
-                <a16:creationId xmlns:a16="http://schemas.microsoft.com/office/drawing/2014/main" id="{EFAABBB7-9DAA-41F8-A7DF-106416F2F53B}"/>
+                <a16:creationId xmlns:a16="http://schemas.microsoft.com/office/drawing/2014/main" id="{B81C799F-B99A-42CF-A1CA-E9E6CE04F3D4}"/>
               </a:ext>
             </a:extLst>
           </p:cNvPr>
@@ -12422,11 +12452,11 @@
             </a:avLst>
           </a:prstGeom>
           <a:solidFill xmlns:a="http://schemas.openxmlformats.org/drawingml/2006/main">
-            <a:srgbClr val="EAF6F4"/>
+            <a:srgbClr val="EEF6FC"/>
           </a:solidFill>
           <a:ln xmlns:a="http://schemas.openxmlformats.org/drawingml/2006/main" w="9525">
             <a:solidFill>
-              <a:srgbClr val="D7E3E8"/>
+              <a:srgbClr val="A5A5A5"/>
             </a:solidFill>
           </a:ln>
         </p:spPr>
@@ -12436,7 +12466,7 @@
           <p:cNvPr id="70" name="">
             <a:extLst xmlns:a="http://schemas.openxmlformats.org/drawingml/2006/main">
               <a:ext uri="{FF2B5EF4-FFF2-40B4-BE49-F238E27FC236}">
-                <a16:creationId xmlns:a16="http://schemas.microsoft.com/office/drawing/2014/main" id="{1E23B6E8-5DF9-4C5D-864A-7DD93DFDBC06}"/>
+                <a16:creationId xmlns:a16="http://schemas.microsoft.com/office/drawing/2014/main" id="{269552AD-F0E4-4245-94FE-22E5333B4B6A}"/>
               </a:ext>
             </a:extLst>
           </p:cNvPr>
@@ -12456,11 +12486,11 @@
             </a:avLst>
           </a:prstGeom>
           <a:solidFill xmlns:a="http://schemas.openxmlformats.org/drawingml/2006/main">
-            <a:srgbClr val="FAF5EB"/>
+            <a:srgbClr val="FFFFFF"/>
           </a:solidFill>
           <a:ln xmlns:a="http://schemas.openxmlformats.org/drawingml/2006/main" w="9525">
             <a:solidFill>
-              <a:srgbClr val="D7E3E8"/>
+              <a:srgbClr val="A5A5A5"/>
             </a:solidFill>
           </a:ln>
         </p:spPr>
@@ -12470,7 +12500,7 @@
           <p:cNvPr id="71" name="ACROBiosystems: target proteins, functional cells &amp; characterization">
             <a:extLst xmlns:a="http://schemas.openxmlformats.org/drawingml/2006/main">
               <a:ext uri="{FF2B5EF4-FFF2-40B4-BE49-F238E27FC236}">
-                <a16:creationId xmlns:a16="http://schemas.microsoft.com/office/drawing/2014/main" id="{A3B9D121-4B9E-4807-BE2E-2B18222B630D}"/>
+                <a16:creationId xmlns:a16="http://schemas.microsoft.com/office/drawing/2014/main" id="{FF78356D-A199-4C58-883C-F7F15181B8D4}"/>
               </a:ext>
             </a:extLst>
           </p:cNvPr>
@@ -12498,7 +12528,7 @@
             <a:defPPr algn="l">
               <a:defRPr sz="1725" b="1">
                 <a:solidFill>
-                  <a:srgbClr val="152C3A"/>
+                  <a:srgbClr val="00355F"/>
                 </a:solidFill>
                 <a:latin typeface="Arial"/>
                 <a:ea typeface="Arial"/>
@@ -12514,7 +12544,7 @@
               <a:buNone/>
               <a:defRPr sz="1725" b="1">
                 <a:solidFill>
-                  <a:srgbClr val="152C3A"/>
+                  <a:srgbClr val="00355F"/>
                 </a:solidFill>
                 <a:latin typeface="Arial"/>
                 <a:ea typeface="Arial"/>
@@ -12524,7 +12554,7 @@
             <a:r>
               <a:rPr sz="1725" b="1">
                 <a:solidFill>
-                  <a:srgbClr val="152C3A"/>
+                  <a:srgbClr val="00355F"/>
                 </a:solidFill>
                 <a:latin typeface="Arial"/>
                 <a:ea typeface="Arial"/>
@@ -12540,7 +12570,7 @@
           <p:cNvPr id="72" name="AIDD-Ready offering exists; paid orders and repeat purchases still need verification">
             <a:extLst xmlns:a="http://schemas.openxmlformats.org/drawingml/2006/main">
               <a:ext uri="{FF2B5EF4-FFF2-40B4-BE49-F238E27FC236}">
-                <a16:creationId xmlns:a16="http://schemas.microsoft.com/office/drawing/2014/main" id="{68C87819-F2EA-4461-8295-5171190265E6}"/>
+                <a16:creationId xmlns:a16="http://schemas.microsoft.com/office/drawing/2014/main" id="{6D8078CF-DF5C-49F2-BB9F-8C0282D339D1}"/>
               </a:ext>
             </a:extLst>
           </p:cNvPr>
@@ -12568,7 +12598,7 @@
             <a:defPPr algn="l">
               <a:defRPr sz="1275" b="0">
                 <a:solidFill>
-                  <a:srgbClr val="647887"/>
+                  <a:srgbClr val="00355F"/>
                 </a:solidFill>
                 <a:latin typeface="Arial"/>
                 <a:ea typeface="Arial"/>
@@ -12584,7 +12614,7 @@
               <a:buNone/>
               <a:defRPr sz="1275" b="0">
                 <a:solidFill>
-                  <a:srgbClr val="647887"/>
+                  <a:srgbClr val="00355F"/>
                 </a:solidFill>
                 <a:latin typeface="Arial"/>
                 <a:ea typeface="Arial"/>
@@ -12594,7 +12624,7 @@
             <a:r>
               <a:rPr sz="1275" b="0">
                 <a:solidFill>
-                  <a:srgbClr val="647887"/>
+                  <a:srgbClr val="00355F"/>
                 </a:solidFill>
                 <a:latin typeface="Arial"/>
                 <a:ea typeface="Arial"/>
@@ -12610,7 +12640,7 @@
           <p:cNvPr id="73" name="NanoMicro: analytical separation &amp; lab purification materials">
             <a:extLst xmlns:a="http://schemas.openxmlformats.org/drawingml/2006/main">
               <a:ext uri="{FF2B5EF4-FFF2-40B4-BE49-F238E27FC236}">
-                <a16:creationId xmlns:a16="http://schemas.microsoft.com/office/drawing/2014/main" id="{60E4DFD0-E630-4823-974A-1DC09D4E49CF}"/>
+                <a16:creationId xmlns:a16="http://schemas.microsoft.com/office/drawing/2014/main" id="{D5F801AC-26B6-4284-A182-EA45B2C1C422}"/>
               </a:ext>
             </a:extLst>
           </p:cNvPr>
@@ -12638,7 +12668,7 @@
             <a:defPPr algn="l">
               <a:defRPr sz="1725" b="1">
                 <a:solidFill>
-                  <a:srgbClr val="152C3A"/>
+                  <a:srgbClr val="00355F"/>
                 </a:solidFill>
                 <a:latin typeface="Arial"/>
                 <a:ea typeface="Arial"/>
@@ -12654,7 +12684,7 @@
               <a:buNone/>
               <a:defRPr sz="1725" b="1">
                 <a:solidFill>
-                  <a:srgbClr val="152C3A"/>
+                  <a:srgbClr val="00355F"/>
                 </a:solidFill>
                 <a:latin typeface="Arial"/>
                 <a:ea typeface="Arial"/>
@@ -12664,7 +12694,7 @@
             <a:r>
               <a:rPr sz="1725" b="1">
                 <a:solidFill>
-                  <a:srgbClr val="152C3A"/>
+                  <a:srgbClr val="00355F"/>
                 </a:solidFill>
                 <a:latin typeface="Arial"/>
                 <a:ea typeface="Arial"/>
@@ -12680,7 +12710,7 @@
           <p:cNvPr id="74" name="Track sample runs, column life and ASP; manufacturing resin demand has a longer lag">
             <a:extLst xmlns:a="http://schemas.openxmlformats.org/drawingml/2006/main">
               <a:ext uri="{FF2B5EF4-FFF2-40B4-BE49-F238E27FC236}">
-                <a16:creationId xmlns:a16="http://schemas.microsoft.com/office/drawing/2014/main" id="{202BF98F-3899-4E1D-9CC3-8865C00FB64F}"/>
+                <a16:creationId xmlns:a16="http://schemas.microsoft.com/office/drawing/2014/main" id="{C257EFC7-E9E7-49F5-8ED0-B533A03E3C2E}"/>
               </a:ext>
             </a:extLst>
           </p:cNvPr>
@@ -12708,7 +12738,7 @@
             <a:defPPr algn="l">
               <a:defRPr sz="1275" b="0">
                 <a:solidFill>
-                  <a:srgbClr val="647887"/>
+                  <a:srgbClr val="00355F"/>
                 </a:solidFill>
                 <a:latin typeface="Arial"/>
                 <a:ea typeface="Arial"/>
@@ -12724,7 +12754,7 @@
               <a:buNone/>
               <a:defRPr sz="1275" b="0">
                 <a:solidFill>
-                  <a:srgbClr val="647887"/>
+                  <a:srgbClr val="00355F"/>
                 </a:solidFill>
                 <a:latin typeface="Arial"/>
                 <a:ea typeface="Arial"/>
@@ -12734,7 +12764,7 @@
             <a:r>
               <a:rPr sz="1275" b="0">
                 <a:solidFill>
-                  <a:srgbClr val="647887"/>
+                  <a:srgbClr val="00355F"/>
                 </a:solidFill>
                 <a:latin typeface="Arial"/>
                 <a:ea typeface="Arial"/>
@@ -12750,7 +12780,7 @@
           <p:cNvPr id="75" name="">
             <a:extLst xmlns:a="http://schemas.openxmlformats.org/drawingml/2006/main">
               <a:ext uri="{FF2B5EF4-FFF2-40B4-BE49-F238E27FC236}">
-                <a16:creationId xmlns:a16="http://schemas.microsoft.com/office/drawing/2014/main" id="{40F6AE21-30B4-424E-8F87-C9AB28277D65}"/>
+                <a16:creationId xmlns:a16="http://schemas.microsoft.com/office/drawing/2014/main" id="{C34EF463-3C49-460D-9396-03C5F46183F6}"/>
               </a:ext>
             </a:extLst>
           </p:cNvPr>
@@ -12770,7 +12800,7 @@
             </a:avLst>
           </a:prstGeom>
           <a:solidFill xmlns:a="http://schemas.openxmlformats.org/drawingml/2006/main">
-            <a:srgbClr val="152C3A"/>
+            <a:srgbClr val="00355F"/>
           </a:solidFill>
           <a:ln xmlns:a="http://schemas.openxmlformats.org/drawingml/2006/main" w="9525">
             <a:noFill/>
@@ -12782,7 +12812,7 @@
           <p:cNvPr id="76" name="LST purchases ≈ Σ [workflow executions × net purchased inputs per run × ASP]">
             <a:extLst xmlns:a="http://schemas.openxmlformats.org/drawingml/2006/main">
               <a:ext uri="{FF2B5EF4-FFF2-40B4-BE49-F238E27FC236}">
-                <a16:creationId xmlns:a16="http://schemas.microsoft.com/office/drawing/2014/main" id="{B1D173F1-BEB8-4F21-8C1E-0E4412F70BD4}"/>
+                <a16:creationId xmlns:a16="http://schemas.microsoft.com/office/drawing/2014/main" id="{063E87F5-F266-4C9B-9CCE-D8BF3D7D77FA}"/>
               </a:ext>
             </a:extLst>
           </p:cNvPr>
@@ -12852,7 +12882,7 @@
           <p:cNvPr id="77" name="Instrument CAPEX is separate. Product alignment does not establish AI orders or revenue. Sources: Ginkgo, Sartorius and company websites.">
             <a:extLst xmlns:a="http://schemas.openxmlformats.org/drawingml/2006/main">
               <a:ext uri="{FF2B5EF4-FFF2-40B4-BE49-F238E27FC236}">
-                <a16:creationId xmlns:a16="http://schemas.microsoft.com/office/drawing/2014/main" id="{80367922-DBD8-4449-8F0E-AE3055B9ABDF}"/>
+                <a16:creationId xmlns:a16="http://schemas.microsoft.com/office/drawing/2014/main" id="{C101B481-95AA-4122-BD35-066B06502648}"/>
               </a:ext>
             </a:extLst>
           </p:cNvPr>
@@ -12880,7 +12910,7 @@
             <a:defPPr algn="l">
               <a:defRPr sz="1238" b="0">
                 <a:solidFill>
-                  <a:srgbClr val="647887"/>
+                  <a:srgbClr val="00355F"/>
                 </a:solidFill>
                 <a:latin typeface="Arial"/>
                 <a:ea typeface="Arial"/>
@@ -12896,7 +12926,7 @@
               <a:buNone/>
               <a:defRPr sz="1238" b="0">
                 <a:solidFill>
-                  <a:srgbClr val="647887"/>
+                  <a:srgbClr val="00355F"/>
                 </a:solidFill>
                 <a:latin typeface="Arial"/>
                 <a:ea typeface="Arial"/>
@@ -12906,7 +12936,7 @@
             <a:r>
               <a:rPr sz="1238" b="0">
                 <a:solidFill>
-                  <a:srgbClr val="647887"/>
+                  <a:srgbClr val="00355F"/>
                 </a:solidFill>
                 <a:latin typeface="Arial"/>
                 <a:ea typeface="Arial"/>
@@ -12920,7 +12950,7 @@
     </p:spTree>
     <p:extLst>
       <p:ext uri="{BB962C8B-B14F-4D97-AF65-F5344CB8AC3E}">
-        <p14:creationId xmlns:p14="http://schemas.microsoft.com/office/powerpoint/2010/main" val="1270070976"/>
+        <p14:creationId xmlns:p14="http://schemas.microsoft.com/office/powerpoint/2010/main" val="1114599055"/>
       </p:ext>
     </p:extLst>
   </p:cSld>

</xml_diff>